<commit_message>
Update review deck with the new games and results; paper draft with figures, search-method section and Word version
Co-Authored-By: Claude Sonnet 5.5 <noreply@anthropic.com>
</commit_message>
<xml_diff>
--- a/docs/CP_Project_Review.pptx
+++ b/docs/CP_Project_Review.pptx
@@ -19,6 +19,9 @@
     <p:sldId id="267" r:id="rId18"/>
     <p:sldId id="268" r:id="rId19"/>
     <p:sldId id="269" r:id="rId20"/>
+    <p:sldId id="270" r:id="rId21"/>
+    <p:sldId id="271" r:id="rId22"/>
+    <p:sldId id="272" r:id="rId23"/>
   </p:sldIdLst>
   <p:sldSz cx="12191695" cy="6858000" type="screen4x3"/>
   <p:notesSz cx="6858000" cy="9144000"/>
@@ -3444,6 +3447,494 @@
                 </a:solidFill>
                 <a:latin typeface="Calibri"/>
               </a:rPr>
+              <a:t>Coding: Key Components</a:t>
+            </a:r>
+          </a:p>
+        </p:txBody>
+      </p:sp>
+      <p:cxnSp>
+        <p:nvCxnSpPr>
+          <p:cNvPr id="3" name="Connector 2"/>
+          <p:cNvCxnSpPr/>
+          <p:nvPr/>
+        </p:nvCxnSpPr>
+        <p:spPr>
+          <a:xfrm>
+            <a:off x="548640" y="1051560"/>
+            <a:ext cx="11064240" cy="0"/>
+          </a:xfrm>
+          <a:prstGeom prst="line">
+            <a:avLst/>
+          </a:prstGeom>
+          <a:ln w="25400">
+            <a:solidFill>
+              <a:srgbClr val="1F4FC8"/>
+            </a:solidFill>
+          </a:ln>
+        </p:spPr>
+        <p:style>
+          <a:lnRef idx="2">
+            <a:schemeClr val="accent1"/>
+          </a:lnRef>
+          <a:fillRef idx="0">
+            <a:schemeClr val="accent1"/>
+          </a:fillRef>
+          <a:effectRef idx="1">
+            <a:schemeClr val="accent1"/>
+          </a:effectRef>
+          <a:fontRef idx="minor">
+            <a:schemeClr val="tx1"/>
+          </a:fontRef>
+        </p:style>
+      </p:cxnSp>
+      <p:sp>
+        <p:nvSpPr>
+          <p:cNvPr id="4" name="TextBox 3"/>
+          <p:cNvSpPr txBox="1"/>
+          <p:nvPr/>
+        </p:nvSpPr>
+        <p:spPr>
+          <a:xfrm>
+            <a:off x="548640" y="1325880"/>
+            <a:ext cx="5486400" cy="457200"/>
+          </a:xfrm>
+          <a:prstGeom prst="rect">
+            <a:avLst/>
+          </a:prstGeom>
+          <a:noFill/>
+        </p:spPr>
+        <p:txBody>
+          <a:bodyPr wrap="square">
+            <a:spAutoFit/>
+          </a:bodyPr>
+          <a:lstStyle/>
+          <a:p>
+            <a:pPr>
+              <a:spcAft>
+                <a:spcPts val="600"/>
+              </a:spcAft>
+            </a:pPr>
+            <a:r>
+              <a:rPr sz="1800" b="1">
+                <a:solidFill>
+                  <a:srgbClr val="1F4FC8"/>
+                </a:solidFill>
+                <a:latin typeface="Calibri"/>
+              </a:rPr>
+              <a:t>Validator, Sokoban (simplified)</a:t>
+            </a:r>
+          </a:p>
+        </p:txBody>
+      </p:sp>
+      <p:sp>
+        <p:nvSpPr>
+          <p:cNvPr id="5" name="TextBox 4"/>
+          <p:cNvSpPr txBox="1"/>
+          <p:nvPr/>
+        </p:nvSpPr>
+        <p:spPr>
+          <a:xfrm>
+            <a:off x="548640" y="1783080"/>
+            <a:ext cx="5486400" cy="4206240"/>
+          </a:xfrm>
+          <a:prstGeom prst="rect">
+            <a:avLst/>
+          </a:prstGeom>
+          <a:noFill/>
+        </p:spPr>
+        <p:txBody>
+          <a:bodyPr wrap="square">
+            <a:spAutoFit/>
+          </a:bodyPr>
+          <a:lstStyle/>
+          <a:p>
+            <a:pPr>
+              <a:spcAft>
+                <a:spcPts val="600"/>
+              </a:spcAft>
+            </a:pPr>
+            <a:r>
+              <a:rPr sz="1400" b="0">
+                <a:solidFill>
+                  <a:srgbClr val="1A1A1A"/>
+                </a:solidFill>
+                <a:latin typeface="Consolas"/>
+              </a:rPr>
+              <a:t>for box in moved_boxes:</a:t>
+            </a:r>
+          </a:p>
+          <a:p>
+            <a:pPr>
+              <a:spcAft>
+                <a:spcPts val="600"/>
+              </a:spcAft>
+            </a:pPr>
+            <a:r>
+              <a:rPr sz="1400" b="0">
+                <a:solidFill>
+                  <a:srgbClr val="1A1A1A"/>
+                </a:solidFill>
+                <a:latin typeface="Consolas"/>
+              </a:rPr>
+              <a:t>    if box in goals: continue</a:t>
+            </a:r>
+          </a:p>
+          <a:p>
+            <a:pPr>
+              <a:spcAft>
+                <a:spcPts val="600"/>
+              </a:spcAft>
+            </a:pPr>
+            <a:r>
+              <a:rPr sz="1400" b="0">
+                <a:solidFill>
+                  <a:srgbClr val="1A1A1A"/>
+                </a:solidFill>
+                <a:latin typeface="Consolas"/>
+              </a:rPr>
+              <a:t>    if is_corner(box):</a:t>
+            </a:r>
+          </a:p>
+          <a:p>
+            <a:pPr>
+              <a:spcAft>
+                <a:spcPts val="600"/>
+              </a:spcAft>
+            </a:pPr>
+            <a:r>
+              <a:rPr sz="1400" b="0">
+                <a:solidFill>
+                  <a:srgbClr val="1A1A1A"/>
+                </a:solidFill>
+                <a:latin typeface="Consolas"/>
+              </a:rPr>
+              <a:t>        return reject("corner deadlock")</a:t>
+            </a:r>
+          </a:p>
+          <a:p>
+            <a:pPr>
+              <a:spcAft>
+                <a:spcPts val="600"/>
+              </a:spcAft>
+            </a:pPr>
+            <a:r>
+              <a:rPr sz="1400" b="0">
+                <a:solidFill>
+                  <a:srgbClr val="1A1A1A"/>
+                </a:solidFill>
+                <a:latin typeface="Consolas"/>
+              </a:rPr>
+              <a:t>    if against_wall(box):</a:t>
+            </a:r>
+          </a:p>
+          <a:p>
+            <a:pPr>
+              <a:spcAft>
+                <a:spcPts val="600"/>
+              </a:spcAft>
+            </a:pPr>
+            <a:r>
+              <a:rPr sz="1400" b="0">
+                <a:solidFill>
+                  <a:srgbClr val="1A1A1A"/>
+                </a:solidFill>
+                <a:latin typeface="Consolas"/>
+              </a:rPr>
+              <a:t>        return accept(conf=0.5)</a:t>
+            </a:r>
+          </a:p>
+          <a:p>
+            <a:pPr>
+              <a:spcAft>
+                <a:spcPts val="600"/>
+              </a:spcAft>
+            </a:pPr>
+            <a:r>
+              <a:rPr sz="1400" b="0">
+                <a:solidFill>
+                  <a:srgbClr val="1A1A1A"/>
+                </a:solidFill>
+                <a:latin typeface="Consolas"/>
+              </a:rPr>
+              <a:t>return accept(conf=1.0)</a:t>
+            </a:r>
+          </a:p>
+          <a:p>
+            <a:pPr>
+              <a:spcAft>
+                <a:spcPts val="600"/>
+              </a:spcAft>
+            </a:pPr>
+            <a:r>
+              <a:rPr sz="800" b="0">
+                <a:solidFill>
+                  <a:srgbClr val="1A1A1A"/>
+                </a:solidFill>
+                <a:latin typeface="Calibri"/>
+              </a:rPr>
+              <a:t/>
+            </a:r>
+          </a:p>
+          <a:p>
+            <a:pPr>
+              <a:spcAft>
+                <a:spcPts val="600"/>
+              </a:spcAft>
+            </a:pPr>
+            <a:r>
+              <a:rPr sz="1600" b="0">
+                <a:solidFill>
+                  <a:srgbClr val="5A5A5A"/>
+                </a:solidFill>
+                <a:latin typeface="Calibri"/>
+              </a:rPr>
+              <a:t>Rejected moves never enter the plan graph. Doubtful moves stay in, but cost more.</a:t>
+            </a:r>
+          </a:p>
+        </p:txBody>
+      </p:sp>
+      <p:sp>
+        <p:nvSpPr>
+          <p:cNvPr id="6" name="TextBox 5"/>
+          <p:cNvSpPr txBox="1"/>
+          <p:nvPr/>
+        </p:nvSpPr>
+        <p:spPr>
+          <a:xfrm>
+            <a:off x="6309360" y="1325880"/>
+            <a:ext cx="5303520" cy="457200"/>
+          </a:xfrm>
+          <a:prstGeom prst="rect">
+            <a:avLst/>
+          </a:prstGeom>
+          <a:noFill/>
+        </p:spPr>
+        <p:txBody>
+          <a:bodyPr wrap="square">
+            <a:spAutoFit/>
+          </a:bodyPr>
+          <a:lstStyle/>
+          <a:p>
+            <a:pPr>
+              <a:spcAft>
+                <a:spcPts val="600"/>
+              </a:spcAft>
+            </a:pPr>
+            <a:r>
+              <a:rPr sz="1800" b="1">
+                <a:solidFill>
+                  <a:srgbClr val="1F4FC8"/>
+                </a:solidFill>
+                <a:latin typeface="Calibri"/>
+              </a:rPr>
+              <a:t>Adaptive solver choice (simplified)</a:t>
+            </a:r>
+          </a:p>
+        </p:txBody>
+      </p:sp>
+      <p:sp>
+        <p:nvSpPr>
+          <p:cNvPr id="7" name="TextBox 6"/>
+          <p:cNvSpPr txBox="1"/>
+          <p:nvPr/>
+        </p:nvSpPr>
+        <p:spPr>
+          <a:xfrm>
+            <a:off x="6309360" y="1783080"/>
+            <a:ext cx="5303520" cy="4206240"/>
+          </a:xfrm>
+          <a:prstGeom prst="rect">
+            <a:avLst/>
+          </a:prstGeom>
+          <a:noFill/>
+        </p:spPr>
+        <p:txBody>
+          <a:bodyPr wrap="square">
+            <a:spAutoFit/>
+          </a:bodyPr>
+          <a:lstStyle/>
+          <a:p>
+            <a:pPr>
+              <a:spcAft>
+                <a:spcPts val="600"/>
+              </a:spcAft>
+            </a:pPr>
+            <a:r>
+              <a:rPr sz="1400" b="0">
+                <a:solidFill>
+                  <a:srgbClr val="1A1A1A"/>
+                </a:solidFill>
+                <a:latin typeface="Consolas"/>
+              </a:rPr>
+              <a:t>def decide_method(level, graph):</a:t>
+            </a:r>
+          </a:p>
+          <a:p>
+            <a:pPr>
+              <a:spcAft>
+                <a:spcPts val="600"/>
+              </a:spcAft>
+            </a:pPr>
+            <a:r>
+              <a:rPr sz="1400" b="0">
+                <a:solidFill>
+                  <a:srgbClr val="1A1A1A"/>
+                </a:solidFill>
+                <a:latin typeface="Consolas"/>
+              </a:rPr>
+              <a:t>    if level.complexity(graph.start) &gt; 1:</a:t>
+            </a:r>
+          </a:p>
+          <a:p>
+            <a:pPr>
+              <a:spcAft>
+                <a:spcPts val="600"/>
+              </a:spcAft>
+            </a:pPr>
+            <a:r>
+              <a:rPr sz="1400" b="0">
+                <a:solidFill>
+                  <a:srgbClr val="1A1A1A"/>
+                </a:solidFill>
+                <a:latin typeface="Consolas"/>
+              </a:rPr>
+              <a:t>        return CP_SAT</a:t>
+            </a:r>
+          </a:p>
+          <a:p>
+            <a:pPr>
+              <a:spcAft>
+                <a:spcPts val="600"/>
+              </a:spcAft>
+            </a:pPr>
+            <a:r>
+              <a:rPr sz="1400" b="0">
+                <a:solidFill>
+                  <a:srgbClr val="1A1A1A"/>
+                </a:solidFill>
+                <a:latin typeface="Consolas"/>
+              </a:rPr>
+              <a:t>    return ASTAR</a:t>
+            </a:r>
+          </a:p>
+          <a:p>
+            <a:pPr>
+              <a:spcAft>
+                <a:spcPts val="600"/>
+              </a:spcAft>
+            </a:pPr>
+            <a:r>
+              <a:rPr sz="800" b="0">
+                <a:solidFill>
+                  <a:srgbClr val="1A1A1A"/>
+                </a:solidFill>
+                <a:latin typeface="Calibri"/>
+              </a:rPr>
+              <a:t/>
+            </a:r>
+          </a:p>
+          <a:p>
+            <a:pPr>
+              <a:spcAft>
+                <a:spcPts val="600"/>
+              </a:spcAft>
+            </a:pPr>
+            <a:r>
+              <a:rPr sz="1600" b="0">
+                <a:solidFill>
+                  <a:srgbClr val="5A5A5A"/>
+                </a:solidFill>
+                <a:latin typeface="Calibri"/>
+              </a:rPr>
+              <a:t>Every game implements one interface: ACTIONS, step, is_goal, heuristic, complexity, render. A new game plugs in without touching the pipeline.</a:t>
+            </a:r>
+          </a:p>
+          <a:p>
+            <a:pPr>
+              <a:spcAft>
+                <a:spcPts val="600"/>
+              </a:spcAft>
+            </a:pPr>
+            <a:r>
+              <a:rPr sz="800" b="0">
+                <a:solidFill>
+                  <a:srgbClr val="1A1A1A"/>
+                </a:solidFill>
+                <a:latin typeface="Calibri"/>
+              </a:rPr>
+              <a:t/>
+            </a:r>
+          </a:p>
+          <a:p>
+            <a:pPr>
+              <a:spcAft>
+                <a:spcPts val="600"/>
+              </a:spcAft>
+            </a:pPr>
+            <a:r>
+              <a:rPr sz="1600" b="0">
+                <a:solidFill>
+                  <a:srgbClr val="5A5A5A"/>
+                </a:solidFill>
+                <a:latin typeface="Calibri"/>
+              </a:rPr>
+              <a:t>Seven games: Sokoban, River Crossing, Rush Hour, Peg Solitaire, 24-puzzle, Rubik's cube, and 3,000 Boxoban levels.</a:t>
+            </a:r>
+          </a:p>
+        </p:txBody>
+      </p:sp>
+    </p:spTree>
+  </p:cSld>
+  <p:clrMapOvr>
+    <a:masterClrMapping/>
+  </p:clrMapOvr>
+</p:sld>
+</file>
+
+<file path=ppt/slides/slide11.xml><?xml version="1.0" encoding="utf-8"?>
+<p:sld xmlns:a="http://schemas.openxmlformats.org/drawingml/2006/main" xmlns:p="http://schemas.openxmlformats.org/presentationml/2006/main" xmlns:r="http://schemas.openxmlformats.org/officeDocument/2006/relationships">
+  <p:cSld>
+    <p:spTree>
+      <p:nvGrpSpPr>
+        <p:cNvPr id="1" name=""/>
+        <p:cNvGrpSpPr/>
+        <p:nvPr/>
+      </p:nvGrpSpPr>
+      <p:grpSpPr/>
+      <p:sp>
+        <p:nvSpPr>
+          <p:cNvPr id="2" name="TextBox 1"/>
+          <p:cNvSpPr txBox="1"/>
+          <p:nvPr/>
+        </p:nvSpPr>
+        <p:spPr>
+          <a:xfrm>
+            <a:off x="548640" y="320040"/>
+            <a:ext cx="10972800" cy="731520"/>
+          </a:xfrm>
+          <a:prstGeom prst="rect">
+            <a:avLst/>
+          </a:prstGeom>
+          <a:noFill/>
+        </p:spPr>
+        <p:txBody>
+          <a:bodyPr wrap="square">
+            <a:spAutoFit/>
+          </a:bodyPr>
+          <a:lstStyle/>
+          <a:p>
+            <a:pPr>
+              <a:spcAft>
+                <a:spcPts val="600"/>
+              </a:spcAft>
+            </a:pPr>
+            <a:r>
+              <a:rPr sz="3400" b="1">
+                <a:solidFill>
+                  <a:srgbClr val="1A1A1A"/>
+                </a:solidFill>
+                <a:latin typeface="Calibri"/>
+              </a:rPr>
               <a:t>Results and Discussion: Safety and Speed</a:t>
             </a:r>
           </a:p>
@@ -4179,7 +4670,7 @@
 </p:sld>
 </file>
 
-<file path=ppt/slides/slide11.xml><?xml version="1.0" encoding="utf-8"?>
+<file path=ppt/slides/slide12.xml><?xml version="1.0" encoding="utf-8"?>
 <p:sld xmlns:a="http://schemas.openxmlformats.org/drawingml/2006/main" xmlns:p="http://schemas.openxmlformats.org/presentationml/2006/main" xmlns:r="http://schemas.openxmlformats.org/officeDocument/2006/relationships">
   <p:cSld>
     <p:spTree>
@@ -4933,7 +5424,1686 @@
 </p:sld>
 </file>
 
-<file path=ppt/slides/slide12.xml><?xml version="1.0" encoding="utf-8"?>
+<file path=ppt/slides/slide13.xml><?xml version="1.0" encoding="utf-8"?>
+<p:sld xmlns:a="http://schemas.openxmlformats.org/drawingml/2006/main" xmlns:p="http://schemas.openxmlformats.org/presentationml/2006/main" xmlns:r="http://schemas.openxmlformats.org/officeDocument/2006/relationships">
+  <p:cSld>
+    <p:spTree>
+      <p:nvGrpSpPr>
+        <p:cNvPr id="1" name=""/>
+        <p:cNvGrpSpPr/>
+        <p:nvPr/>
+      </p:nvGrpSpPr>
+      <p:grpSpPr/>
+      <p:sp>
+        <p:nvSpPr>
+          <p:cNvPr id="2" name="TextBox 1"/>
+          <p:cNvSpPr txBox="1"/>
+          <p:nvPr/>
+        </p:nvSpPr>
+        <p:spPr>
+          <a:xfrm>
+            <a:off x="548640" y="320040"/>
+            <a:ext cx="10972800" cy="731520"/>
+          </a:xfrm>
+          <a:prstGeom prst="rect">
+            <a:avLst/>
+          </a:prstGeom>
+          <a:noFill/>
+        </p:spPr>
+        <p:txBody>
+          <a:bodyPr wrap="square">
+            <a:spAutoFit/>
+          </a:bodyPr>
+          <a:lstStyle/>
+          <a:p>
+            <a:pPr>
+              <a:spcAft>
+                <a:spcPts val="600"/>
+              </a:spcAft>
+            </a:pPr>
+            <a:r>
+              <a:rPr sz="3400" b="1">
+                <a:solidFill>
+                  <a:srgbClr val="1A1A1A"/>
+                </a:solidFill>
+                <a:latin typeface="Calibri"/>
+              </a:rPr>
+              <a:t>Results and Discussion: Harder Games</a:t>
+            </a:r>
+          </a:p>
+        </p:txBody>
+      </p:sp>
+      <p:cxnSp>
+        <p:nvCxnSpPr>
+          <p:cNvPr id="3" name="Connector 2"/>
+          <p:cNvCxnSpPr/>
+          <p:nvPr/>
+        </p:nvCxnSpPr>
+        <p:spPr>
+          <a:xfrm>
+            <a:off x="548640" y="1051560"/>
+            <a:ext cx="11064240" cy="0"/>
+          </a:xfrm>
+          <a:prstGeom prst="line">
+            <a:avLst/>
+          </a:prstGeom>
+          <a:ln w="25400">
+            <a:solidFill>
+              <a:srgbClr val="1F4FC8"/>
+            </a:solidFill>
+          </a:ln>
+        </p:spPr>
+        <p:style>
+          <a:lnRef idx="2">
+            <a:schemeClr val="accent1"/>
+          </a:lnRef>
+          <a:fillRef idx="0">
+            <a:schemeClr val="accent1"/>
+          </a:fillRef>
+          <a:effectRef idx="1">
+            <a:schemeClr val="accent1"/>
+          </a:effectRef>
+          <a:fontRef idx="minor">
+            <a:schemeClr val="tx1"/>
+          </a:fontRef>
+        </p:style>
+      </p:cxnSp>
+      <p:sp>
+        <p:nvSpPr>
+          <p:cNvPr id="4" name="TextBox 3"/>
+          <p:cNvSpPr txBox="1"/>
+          <p:nvPr/>
+        </p:nvSpPr>
+        <p:spPr>
+          <a:xfrm>
+            <a:off x="548640" y="1115568"/>
+            <a:ext cx="10972800" cy="457200"/>
+          </a:xfrm>
+          <a:prstGeom prst="rect">
+            <a:avLst/>
+          </a:prstGeom>
+          <a:noFill/>
+        </p:spPr>
+        <p:txBody>
+          <a:bodyPr wrap="square">
+            <a:spAutoFit/>
+          </a:bodyPr>
+          <a:lstStyle/>
+          <a:p>
+            <a:pPr>
+              <a:spcAft>
+                <a:spcPts val="600"/>
+              </a:spcAft>
+            </a:pPr>
+            <a:r>
+              <a:rPr sz="1600" b="0">
+                <a:solidFill>
+                  <a:srgbClr val="5A5A5A"/>
+                </a:solidFill>
+                <a:latin typeface="Calibri"/>
+              </a:rPr>
+              <a:t>Peg Solitaire, 24-puzzle and Rubik's cube. 60 instances per row, 30 for the cube.</a:t>
+            </a:r>
+          </a:p>
+        </p:txBody>
+      </p:sp>
+      <p:graphicFrame>
+        <p:nvGraphicFramePr>
+          <p:cNvPr id="5" name="Table 4"/>
+          <p:cNvGraphicFramePr>
+            <a:graphicFrameLocks noGrp="1"/>
+          </p:cNvGraphicFramePr>
+          <p:nvPr/>
+        </p:nvGraphicFramePr>
+        <p:xfrm>
+          <a:off x="548640" y="1737360"/>
+          <a:ext cx="11064240" cy="2103120"/>
+        </p:xfrm>
+        <a:graphic>
+          <a:graphicData uri="http://schemas.openxmlformats.org/drawingml/2006/table">
+            <a:tbl>
+              <a:tblPr firstRow="1" bandRow="1">
+                <a:tableStyleId>{5C22544A-7EE6-4342-B048-85BDC9FD1C3A}</a:tableStyleId>
+              </a:tblPr>
+              <a:tblGrid>
+                <a:gridCol w="2651760"/>
+                <a:gridCol w="2651760"/>
+                <a:gridCol w="2743200"/>
+                <a:gridCol w="3017520"/>
+              </a:tblGrid>
+              <a:tr h="420624">
+                <a:tc>
+                  <a:txBody>
+                    <a:bodyPr/>
+                    <a:lstStyle/>
+                    <a:p>
+                      <a:r>
+                        <a:rPr sz="1500" b="1">
+                          <a:solidFill>
+                            <a:srgbClr val="FFFFFF"/>
+                          </a:solidFill>
+                          <a:latin typeface="Calibri"/>
+                        </a:rPr>
+                        <a:t>Jumps from the goal</a:t>
+                      </a:r>
+                    </a:p>
+                  </a:txBody>
+                  <a:tcPr>
+                    <a:solidFill>
+                      <a:srgbClr val="1F4FC8"/>
+                    </a:solidFill>
+                  </a:tcPr>
+                </a:tc>
+                <a:tc>
+                  <a:txBody>
+                    <a:bodyPr/>
+                    <a:lstStyle/>
+                    <a:p>
+                      <a:r>
+                        <a:rPr sz="1500" b="1">
+                          <a:solidFill>
+                            <a:srgbClr val="FFFFFF"/>
+                          </a:solidFill>
+                          <a:latin typeface="Calibri"/>
+                        </a:rPr>
+                        <a:t>Solved, no checker</a:t>
+                      </a:r>
+                    </a:p>
+                  </a:txBody>
+                  <a:tcPr>
+                    <a:solidFill>
+                      <a:srgbClr val="1F4FC8"/>
+                    </a:solidFill>
+                  </a:tcPr>
+                </a:tc>
+                <a:tc>
+                  <a:txBody>
+                    <a:bodyPr/>
+                    <a:lstStyle/>
+                    <a:p>
+                      <a:r>
+                        <a:rPr sz="1500" b="1">
+                          <a:solidFill>
+                            <a:srgbClr val="FFFFFF"/>
+                          </a:solidFill>
+                          <a:latin typeface="Calibri"/>
+                        </a:rPr>
+                        <a:t>Solved, pagoda checker</a:t>
+                      </a:r>
+                    </a:p>
+                  </a:txBody>
+                  <a:tcPr>
+                    <a:solidFill>
+                      <a:srgbClr val="1F4FC8"/>
+                    </a:solidFill>
+                  </a:tcPr>
+                </a:tc>
+                <a:tc>
+                  <a:txBody>
+                    <a:bodyPr/>
+                    <a:lstStyle/>
+                    <a:p>
+                      <a:r>
+                        <a:rPr sz="1500" b="1">
+                          <a:solidFill>
+                            <a:srgbClr val="FFFFFF"/>
+                          </a:solidFill>
+                          <a:latin typeface="Calibri"/>
+                        </a:rPr>
+                        <a:t>Mean nodes, no checker / checker</a:t>
+                      </a:r>
+                    </a:p>
+                  </a:txBody>
+                  <a:tcPr>
+                    <a:solidFill>
+                      <a:srgbClr val="1F4FC8"/>
+                    </a:solidFill>
+                  </a:tcPr>
+                </a:tc>
+              </a:tr>
+              <a:tr h="420624">
+                <a:tc>
+                  <a:txBody>
+                    <a:bodyPr/>
+                    <a:lstStyle/>
+                    <a:p>
+                      <a:r>
+                        <a:rPr sz="1500" b="0">
+                          <a:solidFill>
+                            <a:srgbClr val="1A1A1A"/>
+                          </a:solidFill>
+                          <a:latin typeface="Calibri"/>
+                        </a:rPr>
+                        <a:t>12</a:t>
+                      </a:r>
+                    </a:p>
+                  </a:txBody>
+                  <a:tcPr>
+                    <a:solidFill>
+                      <a:srgbClr val="FFFFFF"/>
+                    </a:solidFill>
+                  </a:tcPr>
+                </a:tc>
+                <a:tc>
+                  <a:txBody>
+                    <a:bodyPr/>
+                    <a:lstStyle/>
+                    <a:p>
+                      <a:r>
+                        <a:rPr sz="1500" b="0">
+                          <a:solidFill>
+                            <a:srgbClr val="1A1A1A"/>
+                          </a:solidFill>
+                          <a:latin typeface="Calibri"/>
+                        </a:rPr>
+                        <a:t>100%</a:t>
+                      </a:r>
+                    </a:p>
+                  </a:txBody>
+                  <a:tcPr>
+                    <a:solidFill>
+                      <a:srgbClr val="FFFFFF"/>
+                    </a:solidFill>
+                  </a:tcPr>
+                </a:tc>
+                <a:tc>
+                  <a:txBody>
+                    <a:bodyPr/>
+                    <a:lstStyle/>
+                    <a:p>
+                      <a:r>
+                        <a:rPr sz="1500" b="0">
+                          <a:solidFill>
+                            <a:srgbClr val="1A1A1A"/>
+                          </a:solidFill>
+                          <a:latin typeface="Calibri"/>
+                        </a:rPr>
+                        <a:t>100%</a:t>
+                      </a:r>
+                    </a:p>
+                  </a:txBody>
+                  <a:tcPr>
+                    <a:solidFill>
+                      <a:srgbClr val="FFFFFF"/>
+                    </a:solidFill>
+                  </a:tcPr>
+                </a:tc>
+                <a:tc>
+                  <a:txBody>
+                    <a:bodyPr/>
+                    <a:lstStyle/>
+                    <a:p>
+                      <a:r>
+                        <a:rPr sz="1500" b="0">
+                          <a:solidFill>
+                            <a:srgbClr val="1A1A1A"/>
+                          </a:solidFill>
+                          <a:latin typeface="Calibri"/>
+                        </a:rPr>
+                        <a:t>296 / 237</a:t>
+                      </a:r>
+                    </a:p>
+                  </a:txBody>
+                  <a:tcPr>
+                    <a:solidFill>
+                      <a:srgbClr val="FFFFFF"/>
+                    </a:solidFill>
+                  </a:tcPr>
+                </a:tc>
+              </a:tr>
+              <a:tr h="420624">
+                <a:tc>
+                  <a:txBody>
+                    <a:bodyPr/>
+                    <a:lstStyle/>
+                    <a:p>
+                      <a:r>
+                        <a:rPr sz="1500" b="0">
+                          <a:solidFill>
+                            <a:srgbClr val="1A1A1A"/>
+                          </a:solidFill>
+                          <a:latin typeface="Calibri"/>
+                        </a:rPr>
+                        <a:t>18</a:t>
+                      </a:r>
+                    </a:p>
+                  </a:txBody>
+                  <a:tcPr>
+                    <a:solidFill>
+                      <a:srgbClr val="F6F6F6"/>
+                    </a:solidFill>
+                  </a:tcPr>
+                </a:tc>
+                <a:tc>
+                  <a:txBody>
+                    <a:bodyPr/>
+                    <a:lstStyle/>
+                    <a:p>
+                      <a:r>
+                        <a:rPr sz="1500" b="0">
+                          <a:solidFill>
+                            <a:srgbClr val="1A1A1A"/>
+                          </a:solidFill>
+                          <a:latin typeface="Calibri"/>
+                        </a:rPr>
+                        <a:t>100%</a:t>
+                      </a:r>
+                    </a:p>
+                  </a:txBody>
+                  <a:tcPr>
+                    <a:solidFill>
+                      <a:srgbClr val="F6F6F6"/>
+                    </a:solidFill>
+                  </a:tcPr>
+                </a:tc>
+                <a:tc>
+                  <a:txBody>
+                    <a:bodyPr/>
+                    <a:lstStyle/>
+                    <a:p>
+                      <a:r>
+                        <a:rPr sz="1500" b="0">
+                          <a:solidFill>
+                            <a:srgbClr val="1A1A1A"/>
+                          </a:solidFill>
+                          <a:latin typeface="Calibri"/>
+                        </a:rPr>
+                        <a:t>100%</a:t>
+                      </a:r>
+                    </a:p>
+                  </a:txBody>
+                  <a:tcPr>
+                    <a:solidFill>
+                      <a:srgbClr val="F6F6F6"/>
+                    </a:solidFill>
+                  </a:tcPr>
+                </a:tc>
+                <a:tc>
+                  <a:txBody>
+                    <a:bodyPr/>
+                    <a:lstStyle/>
+                    <a:p>
+                      <a:r>
+                        <a:rPr sz="1500" b="0">
+                          <a:solidFill>
+                            <a:srgbClr val="1A1A1A"/>
+                          </a:solidFill>
+                          <a:latin typeface="Calibri"/>
+                        </a:rPr>
+                        <a:t>2,776 / 1,914</a:t>
+                      </a:r>
+                    </a:p>
+                  </a:txBody>
+                  <a:tcPr>
+                    <a:solidFill>
+                      <a:srgbClr val="F6F6F6"/>
+                    </a:solidFill>
+                  </a:tcPr>
+                </a:tc>
+              </a:tr>
+              <a:tr h="420624">
+                <a:tc>
+                  <a:txBody>
+                    <a:bodyPr/>
+                    <a:lstStyle/>
+                    <a:p>
+                      <a:r>
+                        <a:rPr sz="1500" b="0">
+                          <a:solidFill>
+                            <a:srgbClr val="1A1A1A"/>
+                          </a:solidFill>
+                          <a:latin typeface="Calibri"/>
+                        </a:rPr>
+                        <a:t>22</a:t>
+                      </a:r>
+                    </a:p>
+                  </a:txBody>
+                  <a:tcPr>
+                    <a:solidFill>
+                      <a:srgbClr val="FFFFFF"/>
+                    </a:solidFill>
+                  </a:tcPr>
+                </a:tc>
+                <a:tc>
+                  <a:txBody>
+                    <a:bodyPr/>
+                    <a:lstStyle/>
+                    <a:p>
+                      <a:r>
+                        <a:rPr sz="1500" b="0">
+                          <a:solidFill>
+                            <a:srgbClr val="1A1A1A"/>
+                          </a:solidFill>
+                          <a:latin typeface="Calibri"/>
+                        </a:rPr>
+                        <a:t>93%</a:t>
+                      </a:r>
+                    </a:p>
+                  </a:txBody>
+                  <a:tcPr>
+                    <a:solidFill>
+                      <a:srgbClr val="FFFFFF"/>
+                    </a:solidFill>
+                  </a:tcPr>
+                </a:tc>
+                <a:tc>
+                  <a:txBody>
+                    <a:bodyPr/>
+                    <a:lstStyle/>
+                    <a:p>
+                      <a:r>
+                        <a:rPr sz="1500" b="0">
+                          <a:solidFill>
+                            <a:srgbClr val="1A1A1A"/>
+                          </a:solidFill>
+                          <a:latin typeface="Calibri"/>
+                        </a:rPr>
+                        <a:t>98%</a:t>
+                      </a:r>
+                    </a:p>
+                  </a:txBody>
+                  <a:tcPr>
+                    <a:solidFill>
+                      <a:srgbClr val="FFFFFF"/>
+                    </a:solidFill>
+                  </a:tcPr>
+                </a:tc>
+                <a:tc>
+                  <a:txBody>
+                    <a:bodyPr/>
+                    <a:lstStyle/>
+                    <a:p>
+                      <a:r>
+                        <a:rPr sz="1500" b="0">
+                          <a:solidFill>
+                            <a:srgbClr val="1A1A1A"/>
+                          </a:solidFill>
+                          <a:latin typeface="Calibri"/>
+                        </a:rPr>
+                        <a:t>13,780 / 9,663</a:t>
+                      </a:r>
+                    </a:p>
+                  </a:txBody>
+                  <a:tcPr>
+                    <a:solidFill>
+                      <a:srgbClr val="FFFFFF"/>
+                    </a:solidFill>
+                  </a:tcPr>
+                </a:tc>
+              </a:tr>
+              <a:tr h="420624">
+                <a:tc>
+                  <a:txBody>
+                    <a:bodyPr/>
+                    <a:lstStyle/>
+                    <a:p>
+                      <a:r>
+                        <a:rPr sz="1500" b="0">
+                          <a:solidFill>
+                            <a:srgbClr val="1A1A1A"/>
+                          </a:solidFill>
+                          <a:latin typeface="Calibri"/>
+                        </a:rPr>
+                        <a:t>26</a:t>
+                      </a:r>
+                    </a:p>
+                  </a:txBody>
+                  <a:tcPr>
+                    <a:solidFill>
+                      <a:srgbClr val="F6F6F6"/>
+                    </a:solidFill>
+                  </a:tcPr>
+                </a:tc>
+                <a:tc>
+                  <a:txBody>
+                    <a:bodyPr/>
+                    <a:lstStyle/>
+                    <a:p>
+                      <a:r>
+                        <a:rPr sz="1500" b="0">
+                          <a:solidFill>
+                            <a:srgbClr val="1A1A1A"/>
+                          </a:solidFill>
+                          <a:latin typeface="Calibri"/>
+                        </a:rPr>
+                        <a:t>58%</a:t>
+                      </a:r>
+                    </a:p>
+                  </a:txBody>
+                  <a:tcPr>
+                    <a:solidFill>
+                      <a:srgbClr val="F6F6F6"/>
+                    </a:solidFill>
+                  </a:tcPr>
+                </a:tc>
+                <a:tc>
+                  <a:txBody>
+                    <a:bodyPr/>
+                    <a:lstStyle/>
+                    <a:p>
+                      <a:r>
+                        <a:rPr sz="1500" b="0">
+                          <a:solidFill>
+                            <a:srgbClr val="1A1A1A"/>
+                          </a:solidFill>
+                          <a:latin typeface="Calibri"/>
+                        </a:rPr>
+                        <a:t>75%</a:t>
+                      </a:r>
+                    </a:p>
+                  </a:txBody>
+                  <a:tcPr>
+                    <a:solidFill>
+                      <a:srgbClr val="F6F6F6"/>
+                    </a:solidFill>
+                  </a:tcPr>
+                </a:tc>
+                <a:tc>
+                  <a:txBody>
+                    <a:bodyPr/>
+                    <a:lstStyle/>
+                    <a:p>
+                      <a:r>
+                        <a:rPr sz="1500" b="0">
+                          <a:solidFill>
+                            <a:srgbClr val="1A1A1A"/>
+                          </a:solidFill>
+                          <a:latin typeface="Calibri"/>
+                        </a:rPr>
+                        <a:t>39,170 / 31,817</a:t>
+                      </a:r>
+                    </a:p>
+                  </a:txBody>
+                  <a:tcPr>
+                    <a:solidFill>
+                      <a:srgbClr val="F6F6F6"/>
+                    </a:solidFill>
+                  </a:tcPr>
+                </a:tc>
+              </a:tr>
+            </a:tbl>
+          </a:graphicData>
+        </a:graphic>
+      </p:graphicFrame>
+      <p:sp>
+        <p:nvSpPr>
+          <p:cNvPr id="6" name="TextBox 5"/>
+          <p:cNvSpPr txBox="1"/>
+          <p:nvPr/>
+        </p:nvSpPr>
+        <p:spPr>
+          <a:xfrm>
+            <a:off x="548640" y="4023360"/>
+            <a:ext cx="11064240" cy="2651760"/>
+          </a:xfrm>
+          <a:prstGeom prst="rect">
+            <a:avLst/>
+          </a:prstGeom>
+          <a:noFill/>
+        </p:spPr>
+        <p:txBody>
+          <a:bodyPr wrap="square">
+            <a:spAutoFit/>
+          </a:bodyPr>
+          <a:lstStyle/>
+          <a:p>
+            <a:pPr>
+              <a:spcAft>
+                <a:spcPts val="600"/>
+              </a:spcAft>
+            </a:pPr>
+            <a:r>
+              <a:rPr sz="1600" b="0">
+                <a:solidFill>
+                  <a:srgbClr val="1A1A1A"/>
+                </a:solidFill>
+                <a:latin typeface="Calibri"/>
+              </a:rPr>
+              <a:t>•  Peg Solitaire: the pagoda bound proves positions lost. From the real start it cuts the search from 139,048 to 82,009 nodes.</a:t>
+            </a:r>
+          </a:p>
+          <a:p>
+            <a:pPr>
+              <a:spcAft>
+                <a:spcPts val="600"/>
+              </a:spcAft>
+            </a:pPr>
+            <a:r>
+              <a:rPr sz="1600" b="0">
+                <a:solidFill>
+                  <a:srgbClr val="1A1A1A"/>
+                </a:solidFill>
+                <a:latin typeface="Calibri"/>
+              </a:rPr>
+              <a:t>•  24-puzzle and cube: the checker only guards the start. On an unsolvable start the plain search spends its whole budget (60,000 and 400,000 nodes), the check uses at most 1.</a:t>
+            </a:r>
+          </a:p>
+          <a:p>
+            <a:pPr>
+              <a:spcAft>
+                <a:spcPts val="600"/>
+              </a:spcAft>
+            </a:pPr>
+            <a:r>
+              <a:rPr sz="1600" b="0">
+                <a:solidFill>
+                  <a:srgbClr val="1A1A1A"/>
+                </a:solidFill>
+                <a:latin typeface="Calibri"/>
+              </a:rPr>
+              <a:t>•  Weighted A* solves 100%, 95%, 73% and 57% of 24-puzzle scrambles of 20, 40, 60 and 80 moves. Meet in the middle solves every cube scramble of 4 to 8 moves.</a:t>
+            </a:r>
+          </a:p>
+        </p:txBody>
+      </p:sp>
+    </p:spTree>
+  </p:cSld>
+  <p:clrMapOvr>
+    <a:masterClrMapping/>
+  </p:clrMapOvr>
+</p:sld>
+</file>
+
+<file path=ppt/slides/slide14.xml><?xml version="1.0" encoding="utf-8"?>
+<p:sld xmlns:a="http://schemas.openxmlformats.org/drawingml/2006/main" xmlns:p="http://schemas.openxmlformats.org/presentationml/2006/main" xmlns:r="http://schemas.openxmlformats.org/officeDocument/2006/relationships">
+  <p:cSld>
+    <p:spTree>
+      <p:nvGrpSpPr>
+        <p:cNvPr id="1" name=""/>
+        <p:cNvGrpSpPr/>
+        <p:nvPr/>
+      </p:nvGrpSpPr>
+      <p:grpSpPr/>
+      <p:sp>
+        <p:nvSpPr>
+          <p:cNvPr id="2" name="TextBox 1"/>
+          <p:cNvSpPr txBox="1"/>
+          <p:nvPr/>
+        </p:nvSpPr>
+        <p:spPr>
+          <a:xfrm>
+            <a:off x="548640" y="320040"/>
+            <a:ext cx="10972800" cy="731520"/>
+          </a:xfrm>
+          <a:prstGeom prst="rect">
+            <a:avLst/>
+          </a:prstGeom>
+          <a:noFill/>
+        </p:spPr>
+        <p:txBody>
+          <a:bodyPr wrap="square">
+            <a:spAutoFit/>
+          </a:bodyPr>
+          <a:lstStyle/>
+          <a:p>
+            <a:pPr>
+              <a:spcAft>
+                <a:spcPts val="600"/>
+              </a:spcAft>
+            </a:pPr>
+            <a:r>
+              <a:rPr sz="3400" b="1">
+                <a:solidFill>
+                  <a:srgbClr val="1A1A1A"/>
+                </a:solidFill>
+                <a:latin typeface="Calibri"/>
+              </a:rPr>
+              <a:t>Results and Discussion: Other Search Methods</a:t>
+            </a:r>
+          </a:p>
+        </p:txBody>
+      </p:sp>
+      <p:cxnSp>
+        <p:nvCxnSpPr>
+          <p:cNvPr id="3" name="Connector 2"/>
+          <p:cNvCxnSpPr/>
+          <p:nvPr/>
+        </p:nvCxnSpPr>
+        <p:spPr>
+          <a:xfrm>
+            <a:off x="548640" y="1051560"/>
+            <a:ext cx="11064240" cy="0"/>
+          </a:xfrm>
+          <a:prstGeom prst="line">
+            <a:avLst/>
+          </a:prstGeom>
+          <a:ln w="25400">
+            <a:solidFill>
+              <a:srgbClr val="1F4FC8"/>
+            </a:solidFill>
+          </a:ln>
+        </p:spPr>
+        <p:style>
+          <a:lnRef idx="2">
+            <a:schemeClr val="accent1"/>
+          </a:lnRef>
+          <a:fillRef idx="0">
+            <a:schemeClr val="accent1"/>
+          </a:fillRef>
+          <a:effectRef idx="1">
+            <a:schemeClr val="accent1"/>
+          </a:effectRef>
+          <a:fontRef idx="minor">
+            <a:schemeClr val="tx1"/>
+          </a:fontRef>
+        </p:style>
+      </p:cxnSp>
+      <p:sp>
+        <p:nvSpPr>
+          <p:cNvPr id="4" name="TextBox 3"/>
+          <p:cNvSpPr txBox="1"/>
+          <p:nvPr/>
+        </p:nvSpPr>
+        <p:spPr>
+          <a:xfrm>
+            <a:off x="548640" y="1115568"/>
+            <a:ext cx="10972800" cy="457200"/>
+          </a:xfrm>
+          <a:prstGeom prst="rect">
+            <a:avLst/>
+          </a:prstGeom>
+          <a:noFill/>
+        </p:spPr>
+        <p:txBody>
+          <a:bodyPr wrap="square">
+            <a:spAutoFit/>
+          </a:bodyPr>
+          <a:lstStyle/>
+          <a:p>
+            <a:pPr>
+              <a:spcAft>
+                <a:spcPts val="600"/>
+              </a:spcAft>
+            </a:pPr>
+            <a:r>
+              <a:rPr sz="1600" b="0">
+                <a:solidFill>
+                  <a:srgbClr val="5A5A5A"/>
+                </a:solidFill>
+                <a:latin typeface="Calibri"/>
+              </a:rPr>
+              <a:t>Do BFS, DFS and A* variants help? Share solved within 100,000 nodes, with mean nodes in brackets.</a:t>
+            </a:r>
+          </a:p>
+        </p:txBody>
+      </p:sp>
+      <p:graphicFrame>
+        <p:nvGraphicFramePr>
+          <p:cNvPr id="5" name="Table 4"/>
+          <p:cNvGraphicFramePr>
+            <a:graphicFrameLocks noGrp="1"/>
+          </p:cNvGraphicFramePr>
+          <p:nvPr/>
+        </p:nvGraphicFramePr>
+        <p:xfrm>
+          <a:off x="548640" y="1737360"/>
+          <a:ext cx="11064240" cy="2880360"/>
+        </p:xfrm>
+        <a:graphic>
+          <a:graphicData uri="http://schemas.openxmlformats.org/drawingml/2006/table">
+            <a:tbl>
+              <a:tblPr firstRow="1" bandRow="1">
+                <a:tableStyleId>{5C22544A-7EE6-4342-B048-85BDC9FD1C3A}</a:tableStyleId>
+              </a:tblPr>
+              <a:tblGrid>
+                <a:gridCol w="3017520"/>
+                <a:gridCol w="1920240"/>
+                <a:gridCol w="2103120"/>
+                <a:gridCol w="2011680"/>
+                <a:gridCol w="2011680"/>
+              </a:tblGrid>
+              <a:tr h="411480">
+                <a:tc>
+                  <a:txBody>
+                    <a:bodyPr/>
+                    <a:lstStyle/>
+                    <a:p>
+                      <a:r>
+                        <a:rPr sz="1400" b="1">
+                          <a:solidFill>
+                            <a:srgbClr val="FFFFFF"/>
+                          </a:solidFill>
+                          <a:latin typeface="Calibri"/>
+                        </a:rPr>
+                        <a:t>Game</a:t>
+                      </a:r>
+                    </a:p>
+                  </a:txBody>
+                  <a:tcPr>
+                    <a:solidFill>
+                      <a:srgbClr val="1F4FC8"/>
+                    </a:solidFill>
+                  </a:tcPr>
+                </a:tc>
+                <a:tc>
+                  <a:txBody>
+                    <a:bodyPr/>
+                    <a:lstStyle/>
+                    <a:p>
+                      <a:r>
+                        <a:rPr sz="1400" b="1">
+                          <a:solidFill>
+                            <a:srgbClr val="FFFFFF"/>
+                          </a:solidFill>
+                          <a:latin typeface="Calibri"/>
+                        </a:rPr>
+                        <a:t>BFS</a:t>
+                      </a:r>
+                    </a:p>
+                  </a:txBody>
+                  <a:tcPr>
+                    <a:solidFill>
+                      <a:srgbClr val="1F4FC8"/>
+                    </a:solidFill>
+                  </a:tcPr>
+                </a:tc>
+                <a:tc>
+                  <a:txBody>
+                    <a:bodyPr/>
+                    <a:lstStyle/>
+                    <a:p>
+                      <a:r>
+                        <a:rPr sz="1400" b="1">
+                          <a:solidFill>
+                            <a:srgbClr val="FFFFFF"/>
+                          </a:solidFill>
+                          <a:latin typeface="Calibri"/>
+                        </a:rPr>
+                        <a:t>DFS</a:t>
+                      </a:r>
+                    </a:p>
+                  </a:txBody>
+                  <a:tcPr>
+                    <a:solidFill>
+                      <a:srgbClr val="1F4FC8"/>
+                    </a:solidFill>
+                  </a:tcPr>
+                </a:tc>
+                <a:tc>
+                  <a:txBody>
+                    <a:bodyPr/>
+                    <a:lstStyle/>
+                    <a:p>
+                      <a:r>
+                        <a:rPr sz="1400" b="1">
+                          <a:solidFill>
+                            <a:srgbClr val="FFFFFF"/>
+                          </a:solidFill>
+                          <a:latin typeface="Calibri"/>
+                        </a:rPr>
+                        <a:t>Weighted A*</a:t>
+                      </a:r>
+                    </a:p>
+                  </a:txBody>
+                  <a:tcPr>
+                    <a:solidFill>
+                      <a:srgbClr val="1F4FC8"/>
+                    </a:solidFill>
+                  </a:tcPr>
+                </a:tc>
+                <a:tc>
+                  <a:txBody>
+                    <a:bodyPr/>
+                    <a:lstStyle/>
+                    <a:p>
+                      <a:r>
+                        <a:rPr sz="1400" b="1">
+                          <a:solidFill>
+                            <a:srgbClr val="FFFFFF"/>
+                          </a:solidFill>
+                          <a:latin typeface="Calibri"/>
+                        </a:rPr>
+                        <a:t>Meet in the middle</a:t>
+                      </a:r>
+                    </a:p>
+                  </a:txBody>
+                  <a:tcPr>
+                    <a:solidFill>
+                      <a:srgbClr val="1F4FC8"/>
+                    </a:solidFill>
+                  </a:tcPr>
+                </a:tc>
+              </a:tr>
+              <a:tr h="411480">
+                <a:tc>
+                  <a:txBody>
+                    <a:bodyPr/>
+                    <a:lstStyle/>
+                    <a:p>
+                      <a:r>
+                        <a:rPr sz="1400" b="0">
+                          <a:solidFill>
+                            <a:srgbClr val="1A1A1A"/>
+                          </a:solidFill>
+                          <a:latin typeface="Calibri"/>
+                        </a:rPr>
+                        <a:t>River Crossing</a:t>
+                      </a:r>
+                    </a:p>
+                  </a:txBody>
+                  <a:tcPr>
+                    <a:solidFill>
+                      <a:srgbClr val="FFFFFF"/>
+                    </a:solidFill>
+                  </a:tcPr>
+                </a:tc>
+                <a:tc>
+                  <a:txBody>
+                    <a:bodyPr/>
+                    <a:lstStyle/>
+                    <a:p>
+                      <a:r>
+                        <a:rPr sz="1400" b="0">
+                          <a:solidFill>
+                            <a:srgbClr val="1A1A1A"/>
+                          </a:solidFill>
+                          <a:latin typeface="Calibri"/>
+                        </a:rPr>
+                        <a:t>100% (28)</a:t>
+                      </a:r>
+                    </a:p>
+                  </a:txBody>
+                  <a:tcPr>
+                    <a:solidFill>
+                      <a:srgbClr val="FFFFFF"/>
+                    </a:solidFill>
+                  </a:tcPr>
+                </a:tc>
+                <a:tc>
+                  <a:txBody>
+                    <a:bodyPr/>
+                    <a:lstStyle/>
+                    <a:p>
+                      <a:r>
+                        <a:rPr sz="1400" b="0">
+                          <a:solidFill>
+                            <a:srgbClr val="1A1A1A"/>
+                          </a:solidFill>
+                          <a:latin typeface="Calibri"/>
+                        </a:rPr>
+                        <a:t>100% (19)</a:t>
+                      </a:r>
+                    </a:p>
+                  </a:txBody>
+                  <a:tcPr>
+                    <a:solidFill>
+                      <a:srgbClr val="FFFFFF"/>
+                    </a:solidFill>
+                  </a:tcPr>
+                </a:tc>
+                <a:tc>
+                  <a:txBody>
+                    <a:bodyPr/>
+                    <a:lstStyle/>
+                    <a:p>
+                      <a:r>
+                        <a:rPr sz="1400" b="0">
+                          <a:solidFill>
+                            <a:srgbClr val="1A1A1A"/>
+                          </a:solidFill>
+                          <a:latin typeface="Calibri"/>
+                        </a:rPr>
+                        <a:t>100% (26)</a:t>
+                      </a:r>
+                    </a:p>
+                  </a:txBody>
+                  <a:tcPr>
+                    <a:solidFill>
+                      <a:srgbClr val="FFFFFF"/>
+                    </a:solidFill>
+                  </a:tcPr>
+                </a:tc>
+                <a:tc>
+                  <a:txBody>
+                    <a:bodyPr/>
+                    <a:lstStyle/>
+                    <a:p>
+                      <a:r>
+                        <a:rPr sz="1400" b="0">
+                          <a:solidFill>
+                            <a:srgbClr val="1A1A1A"/>
+                          </a:solidFill>
+                          <a:latin typeface="Calibri"/>
+                        </a:rPr>
+                        <a:t>n/a</a:t>
+                      </a:r>
+                    </a:p>
+                  </a:txBody>
+                  <a:tcPr>
+                    <a:solidFill>
+                      <a:srgbClr val="FFFFFF"/>
+                    </a:solidFill>
+                  </a:tcPr>
+                </a:tc>
+              </a:tr>
+              <a:tr h="411480">
+                <a:tc>
+                  <a:txBody>
+                    <a:bodyPr/>
+                    <a:lstStyle/>
+                    <a:p>
+                      <a:r>
+                        <a:rPr sz="1400" b="0">
+                          <a:solidFill>
+                            <a:srgbClr val="1A1A1A"/>
+                          </a:solidFill>
+                          <a:latin typeface="Calibri"/>
+                        </a:rPr>
+                        <a:t>Rush Hour</a:t>
+                      </a:r>
+                    </a:p>
+                  </a:txBody>
+                  <a:tcPr>
+                    <a:solidFill>
+                      <a:srgbClr val="F6F6F6"/>
+                    </a:solidFill>
+                  </a:tcPr>
+                </a:tc>
+                <a:tc>
+                  <a:txBody>
+                    <a:bodyPr/>
+                    <a:lstStyle/>
+                    <a:p>
+                      <a:r>
+                        <a:rPr sz="1400" b="0">
+                          <a:solidFill>
+                            <a:srgbClr val="1A1A1A"/>
+                          </a:solidFill>
+                          <a:latin typeface="Calibri"/>
+                        </a:rPr>
+                        <a:t>100% (20)</a:t>
+                      </a:r>
+                    </a:p>
+                  </a:txBody>
+                  <a:tcPr>
+                    <a:solidFill>
+                      <a:srgbClr val="F6F6F6"/>
+                    </a:solidFill>
+                  </a:tcPr>
+                </a:tc>
+                <a:tc>
+                  <a:txBody>
+                    <a:bodyPr/>
+                    <a:lstStyle/>
+                    <a:p>
+                      <a:r>
+                        <a:rPr sz="1400" b="0">
+                          <a:solidFill>
+                            <a:srgbClr val="1A1A1A"/>
+                          </a:solidFill>
+                          <a:latin typeface="Calibri"/>
+                        </a:rPr>
+                        <a:t>100% (18)</a:t>
+                      </a:r>
+                    </a:p>
+                  </a:txBody>
+                  <a:tcPr>
+                    <a:solidFill>
+                      <a:srgbClr val="F6F6F6"/>
+                    </a:solidFill>
+                  </a:tcPr>
+                </a:tc>
+                <a:tc>
+                  <a:txBody>
+                    <a:bodyPr/>
+                    <a:lstStyle/>
+                    <a:p>
+                      <a:r>
+                        <a:rPr sz="1400" b="0">
+                          <a:solidFill>
+                            <a:srgbClr val="1A1A1A"/>
+                          </a:solidFill>
+                          <a:latin typeface="Calibri"/>
+                        </a:rPr>
+                        <a:t>100% (12)</a:t>
+                      </a:r>
+                    </a:p>
+                  </a:txBody>
+                  <a:tcPr>
+                    <a:solidFill>
+                      <a:srgbClr val="F6F6F6"/>
+                    </a:solidFill>
+                  </a:tcPr>
+                </a:tc>
+                <a:tc>
+                  <a:txBody>
+                    <a:bodyPr/>
+                    <a:lstStyle/>
+                    <a:p>
+                      <a:r>
+                        <a:rPr sz="1400" b="0">
+                          <a:solidFill>
+                            <a:srgbClr val="1A1A1A"/>
+                          </a:solidFill>
+                          <a:latin typeface="Calibri"/>
+                        </a:rPr>
+                        <a:t>n/a</a:t>
+                      </a:r>
+                    </a:p>
+                  </a:txBody>
+                  <a:tcPr>
+                    <a:solidFill>
+                      <a:srgbClr val="F6F6F6"/>
+                    </a:solidFill>
+                  </a:tcPr>
+                </a:tc>
+              </a:tr>
+              <a:tr h="411480">
+                <a:tc>
+                  <a:txBody>
+                    <a:bodyPr/>
+                    <a:lstStyle/>
+                    <a:p>
+                      <a:r>
+                        <a:rPr sz="1400" b="0">
+                          <a:solidFill>
+                            <a:srgbClr val="1A1A1A"/>
+                          </a:solidFill>
+                          <a:latin typeface="Calibri"/>
+                        </a:rPr>
+                        <a:t>Peg Solitaire, real start</a:t>
+                      </a:r>
+                    </a:p>
+                  </a:txBody>
+                  <a:tcPr>
+                    <a:solidFill>
+                      <a:srgbClr val="FFFFFF"/>
+                    </a:solidFill>
+                  </a:tcPr>
+                </a:tc>
+                <a:tc>
+                  <a:txBody>
+                    <a:bodyPr/>
+                    <a:lstStyle/>
+                    <a:p>
+                      <a:r>
+                        <a:rPr sz="1400" b="0">
+                          <a:solidFill>
+                            <a:srgbClr val="1A1A1A"/>
+                          </a:solidFill>
+                          <a:latin typeface="Calibri"/>
+                        </a:rPr>
+                        <a:t>0%</a:t>
+                      </a:r>
+                    </a:p>
+                  </a:txBody>
+                  <a:tcPr>
+                    <a:solidFill>
+                      <a:srgbClr val="FFFFFF"/>
+                    </a:solidFill>
+                  </a:tcPr>
+                </a:tc>
+                <a:tc>
+                  <a:txBody>
+                    <a:bodyPr/>
+                    <a:lstStyle/>
+                    <a:p>
+                      <a:r>
+                        <a:rPr sz="1400" b="0">
+                          <a:solidFill>
+                            <a:srgbClr val="1A1A1A"/>
+                          </a:solidFill>
+                          <a:latin typeface="Calibri"/>
+                        </a:rPr>
+                        <a:t>100% (10,845)</a:t>
+                      </a:r>
+                    </a:p>
+                  </a:txBody>
+                  <a:tcPr>
+                    <a:solidFill>
+                      <a:srgbClr val="FFFFFF"/>
+                    </a:solidFill>
+                  </a:tcPr>
+                </a:tc>
+                <a:tc>
+                  <a:txBody>
+                    <a:bodyPr/>
+                    <a:lstStyle/>
+                    <a:p>
+                      <a:r>
+                        <a:rPr sz="1400" b="0">
+                          <a:solidFill>
+                            <a:srgbClr val="1A1A1A"/>
+                          </a:solidFill>
+                          <a:latin typeface="Calibri"/>
+                        </a:rPr>
+                        <a:t>0%</a:t>
+                      </a:r>
+                    </a:p>
+                  </a:txBody>
+                  <a:tcPr>
+                    <a:solidFill>
+                      <a:srgbClr val="FFFFFF"/>
+                    </a:solidFill>
+                  </a:tcPr>
+                </a:tc>
+                <a:tc>
+                  <a:txBody>
+                    <a:bodyPr/>
+                    <a:lstStyle/>
+                    <a:p>
+                      <a:r>
+                        <a:rPr sz="1400" b="0">
+                          <a:solidFill>
+                            <a:srgbClr val="1A1A1A"/>
+                          </a:solidFill>
+                          <a:latin typeface="Calibri"/>
+                        </a:rPr>
+                        <a:t>n/a</a:t>
+                      </a:r>
+                    </a:p>
+                  </a:txBody>
+                  <a:tcPr>
+                    <a:solidFill>
+                      <a:srgbClr val="FFFFFF"/>
+                    </a:solidFill>
+                  </a:tcPr>
+                </a:tc>
+              </a:tr>
+              <a:tr h="411480">
+                <a:tc>
+                  <a:txBody>
+                    <a:bodyPr/>
+                    <a:lstStyle/>
+                    <a:p>
+                      <a:r>
+                        <a:rPr sz="1400" b="0">
+                          <a:solidFill>
+                            <a:srgbClr val="1A1A1A"/>
+                          </a:solidFill>
+                          <a:latin typeface="Calibri"/>
+                        </a:rPr>
+                        <a:t>Boxoban, 20 levels</a:t>
+                      </a:r>
+                    </a:p>
+                  </a:txBody>
+                  <a:tcPr>
+                    <a:solidFill>
+                      <a:srgbClr val="F6F6F6"/>
+                    </a:solidFill>
+                  </a:tcPr>
+                </a:tc>
+                <a:tc>
+                  <a:txBody>
+                    <a:bodyPr/>
+                    <a:lstStyle/>
+                    <a:p>
+                      <a:r>
+                        <a:rPr sz="1400" b="0">
+                          <a:solidFill>
+                            <a:srgbClr val="1A1A1A"/>
+                          </a:solidFill>
+                          <a:latin typeface="Calibri"/>
+                        </a:rPr>
+                        <a:t>45% (41,347)</a:t>
+                      </a:r>
+                    </a:p>
+                  </a:txBody>
+                  <a:tcPr>
+                    <a:solidFill>
+                      <a:srgbClr val="F6F6F6"/>
+                    </a:solidFill>
+                  </a:tcPr>
+                </a:tc>
+                <a:tc>
+                  <a:txBody>
+                    <a:bodyPr/>
+                    <a:lstStyle/>
+                    <a:p>
+                      <a:r>
+                        <a:rPr sz="1400" b="0">
+                          <a:solidFill>
+                            <a:srgbClr val="1A1A1A"/>
+                          </a:solidFill>
+                          <a:latin typeface="Calibri"/>
+                        </a:rPr>
+                        <a:t>55% (37,835)</a:t>
+                      </a:r>
+                    </a:p>
+                  </a:txBody>
+                  <a:tcPr>
+                    <a:solidFill>
+                      <a:srgbClr val="F6F6F6"/>
+                    </a:solidFill>
+                  </a:tcPr>
+                </a:tc>
+                <a:tc>
+                  <a:txBody>
+                    <a:bodyPr/>
+                    <a:lstStyle/>
+                    <a:p>
+                      <a:r>
+                        <a:rPr sz="1400" b="0">
+                          <a:solidFill>
+                            <a:srgbClr val="1A1A1A"/>
+                          </a:solidFill>
+                          <a:latin typeface="Calibri"/>
+                        </a:rPr>
+                        <a:t>55% (24,368)</a:t>
+                      </a:r>
+                    </a:p>
+                  </a:txBody>
+                  <a:tcPr>
+                    <a:solidFill>
+                      <a:srgbClr val="F6F6F6"/>
+                    </a:solidFill>
+                  </a:tcPr>
+                </a:tc>
+                <a:tc>
+                  <a:txBody>
+                    <a:bodyPr/>
+                    <a:lstStyle/>
+                    <a:p>
+                      <a:r>
+                        <a:rPr sz="1400" b="0">
+                          <a:solidFill>
+                            <a:srgbClr val="1A1A1A"/>
+                          </a:solidFill>
+                          <a:latin typeface="Calibri"/>
+                        </a:rPr>
+                        <a:t>n/a</a:t>
+                      </a:r>
+                    </a:p>
+                  </a:txBody>
+                  <a:tcPr>
+                    <a:solidFill>
+                      <a:srgbClr val="F6F6F6"/>
+                    </a:solidFill>
+                  </a:tcPr>
+                </a:tc>
+              </a:tr>
+              <a:tr h="411480">
+                <a:tc>
+                  <a:txBody>
+                    <a:bodyPr/>
+                    <a:lstStyle/>
+                    <a:p>
+                      <a:r>
+                        <a:rPr sz="1400" b="0">
+                          <a:solidFill>
+                            <a:srgbClr val="1A1A1A"/>
+                          </a:solidFill>
+                          <a:latin typeface="Calibri"/>
+                        </a:rPr>
+                        <a:t>24-puzzle, 20 moves</a:t>
+                      </a:r>
+                    </a:p>
+                  </a:txBody>
+                  <a:tcPr>
+                    <a:solidFill>
+                      <a:srgbClr val="FFFFFF"/>
+                    </a:solidFill>
+                  </a:tcPr>
+                </a:tc>
+                <a:tc>
+                  <a:txBody>
+                    <a:bodyPr/>
+                    <a:lstStyle/>
+                    <a:p>
+                      <a:r>
+                        <a:rPr sz="1400" b="0">
+                          <a:solidFill>
+                            <a:srgbClr val="1A1A1A"/>
+                          </a:solidFill>
+                          <a:latin typeface="Calibri"/>
+                        </a:rPr>
+                        <a:t>0%</a:t>
+                      </a:r>
+                    </a:p>
+                  </a:txBody>
+                  <a:tcPr>
+                    <a:solidFill>
+                      <a:srgbClr val="FFFFFF"/>
+                    </a:solidFill>
+                  </a:tcPr>
+                </a:tc>
+                <a:tc>
+                  <a:txBody>
+                    <a:bodyPr/>
+                    <a:lstStyle/>
+                    <a:p>
+                      <a:r>
+                        <a:rPr sz="1400" b="0">
+                          <a:solidFill>
+                            <a:srgbClr val="1A1A1A"/>
+                          </a:solidFill>
+                          <a:latin typeface="Calibri"/>
+                        </a:rPr>
+                        <a:t>0%</a:t>
+                      </a:r>
+                    </a:p>
+                  </a:txBody>
+                  <a:tcPr>
+                    <a:solidFill>
+                      <a:srgbClr val="FFFFFF"/>
+                    </a:solidFill>
+                  </a:tcPr>
+                </a:tc>
+                <a:tc>
+                  <a:txBody>
+                    <a:bodyPr/>
+                    <a:lstStyle/>
+                    <a:p>
+                      <a:r>
+                        <a:rPr sz="1400" b="0">
+                          <a:solidFill>
+                            <a:srgbClr val="1A1A1A"/>
+                          </a:solidFill>
+                          <a:latin typeface="Calibri"/>
+                        </a:rPr>
+                        <a:t>100% (413)</a:t>
+                      </a:r>
+                    </a:p>
+                  </a:txBody>
+                  <a:tcPr>
+                    <a:solidFill>
+                      <a:srgbClr val="FFFFFF"/>
+                    </a:solidFill>
+                  </a:tcPr>
+                </a:tc>
+                <a:tc>
+                  <a:txBody>
+                    <a:bodyPr/>
+                    <a:lstStyle/>
+                    <a:p>
+                      <a:r>
+                        <a:rPr sz="1400" b="0">
+                          <a:solidFill>
+                            <a:srgbClr val="1A1A1A"/>
+                          </a:solidFill>
+                          <a:latin typeface="Calibri"/>
+                        </a:rPr>
+                        <a:t>100% (18,453)</a:t>
+                      </a:r>
+                    </a:p>
+                  </a:txBody>
+                  <a:tcPr>
+                    <a:solidFill>
+                      <a:srgbClr val="FFFFFF"/>
+                    </a:solidFill>
+                  </a:tcPr>
+                </a:tc>
+              </a:tr>
+              <a:tr h="411480">
+                <a:tc>
+                  <a:txBody>
+                    <a:bodyPr/>
+                    <a:lstStyle/>
+                    <a:p>
+                      <a:r>
+                        <a:rPr sz="1400" b="0">
+                          <a:solidFill>
+                            <a:srgbClr val="1A1A1A"/>
+                          </a:solidFill>
+                          <a:latin typeface="Calibri"/>
+                        </a:rPr>
+                        <a:t>Rubik's cube, 6 moves</a:t>
+                      </a:r>
+                    </a:p>
+                  </a:txBody>
+                  <a:tcPr>
+                    <a:solidFill>
+                      <a:srgbClr val="F6F6F6"/>
+                    </a:solidFill>
+                  </a:tcPr>
+                </a:tc>
+                <a:tc>
+                  <a:txBody>
+                    <a:bodyPr/>
+                    <a:lstStyle/>
+                    <a:p>
+                      <a:r>
+                        <a:rPr sz="1400" b="0">
+                          <a:solidFill>
+                            <a:srgbClr val="1A1A1A"/>
+                          </a:solidFill>
+                          <a:latin typeface="Calibri"/>
+                        </a:rPr>
+                        <a:t>15% (11,676)</a:t>
+                      </a:r>
+                    </a:p>
+                  </a:txBody>
+                  <a:tcPr>
+                    <a:solidFill>
+                      <a:srgbClr val="F6F6F6"/>
+                    </a:solidFill>
+                  </a:tcPr>
+                </a:tc>
+                <a:tc>
+                  <a:txBody>
+                    <a:bodyPr/>
+                    <a:lstStyle/>
+                    <a:p>
+                      <a:r>
+                        <a:rPr sz="1400" b="0">
+                          <a:solidFill>
+                            <a:srgbClr val="1A1A1A"/>
+                          </a:solidFill>
+                          <a:latin typeface="Calibri"/>
+                        </a:rPr>
+                        <a:t>0%</a:t>
+                      </a:r>
+                    </a:p>
+                  </a:txBody>
+                  <a:tcPr>
+                    <a:solidFill>
+                      <a:srgbClr val="F6F6F6"/>
+                    </a:solidFill>
+                  </a:tcPr>
+                </a:tc>
+                <a:tc>
+                  <a:txBody>
+                    <a:bodyPr/>
+                    <a:lstStyle/>
+                    <a:p>
+                      <a:r>
+                        <a:rPr sz="1400" b="0">
+                          <a:solidFill>
+                            <a:srgbClr val="1A1A1A"/>
+                          </a:solidFill>
+                          <a:latin typeface="Calibri"/>
+                        </a:rPr>
+                        <a:t>100% (392)</a:t>
+                      </a:r>
+                    </a:p>
+                  </a:txBody>
+                  <a:tcPr>
+                    <a:solidFill>
+                      <a:srgbClr val="F6F6F6"/>
+                    </a:solidFill>
+                  </a:tcPr>
+                </a:tc>
+                <a:tc>
+                  <a:txBody>
+                    <a:bodyPr/>
+                    <a:lstStyle/>
+                    <a:p>
+                      <a:r>
+                        <a:rPr sz="1400" b="0">
+                          <a:solidFill>
+                            <a:srgbClr val="1A1A1A"/>
+                          </a:solidFill>
+                          <a:latin typeface="Calibri"/>
+                        </a:rPr>
+                        <a:t>100% (5,544)</a:t>
+                      </a:r>
+                    </a:p>
+                  </a:txBody>
+                  <a:tcPr>
+                    <a:solidFill>
+                      <a:srgbClr val="F6F6F6"/>
+                    </a:solidFill>
+                  </a:tcPr>
+                </a:tc>
+              </a:tr>
+            </a:tbl>
+          </a:graphicData>
+        </a:graphic>
+      </p:graphicFrame>
+      <p:sp>
+        <p:nvSpPr>
+          <p:cNvPr id="6" name="TextBox 5"/>
+          <p:cNvSpPr txBox="1"/>
+          <p:nvPr/>
+        </p:nvSpPr>
+        <p:spPr>
+          <a:xfrm>
+            <a:off x="548640" y="4754880"/>
+            <a:ext cx="11064240" cy="1920240"/>
+          </a:xfrm>
+          <a:prstGeom prst="rect">
+            <a:avLst/>
+          </a:prstGeom>
+          <a:noFill/>
+        </p:spPr>
+        <p:txBody>
+          <a:bodyPr wrap="square">
+            <a:spAutoFit/>
+          </a:bodyPr>
+          <a:lstStyle/>
+          <a:p>
+            <a:pPr>
+              <a:spcAft>
+                <a:spcPts val="600"/>
+              </a:spcAft>
+            </a:pPr>
+            <a:r>
+              <a:rPr sz="1600" b="0">
+                <a:solidFill>
+                  <a:srgbClr val="1A1A1A"/>
+                </a:solidFill>
+                <a:latin typeface="Calibri"/>
+              </a:rPr>
+              <a:t>•  DFS helps in one game: Peg Solitaire, where every solution is 31 jumps. BFS suffices only on the tiny games.</a:t>
+            </a:r>
+          </a:p>
+          <a:p>
+            <a:pPr>
+              <a:spcAft>
+                <a:spcPts val="600"/>
+              </a:spcAft>
+            </a:pPr>
+            <a:r>
+              <a:rPr sz="1600" b="0">
+                <a:solidFill>
+                  <a:srgbClr val="1A1A1A"/>
+                </a:solidFill>
+                <a:latin typeface="Calibri"/>
+              </a:rPr>
+              <a:t>•  Weighted A* is the best general choice. AO* does not apply: every game is deterministic, so it reduces to A*.</a:t>
+            </a:r>
+          </a:p>
+        </p:txBody>
+      </p:sp>
+    </p:spTree>
+  </p:cSld>
+  <p:clrMapOvr>
+    <a:masterClrMapping/>
+  </p:clrMapOvr>
+</p:sld>
+</file>
+
+<file path=ppt/slides/slide15.xml><?xml version="1.0" encoding="utf-8"?>
 <p:sld xmlns:a="http://schemas.openxmlformats.org/drawingml/2006/main" xmlns:p="http://schemas.openxmlformats.org/presentationml/2006/main" xmlns:r="http://schemas.openxmlformats.org/officeDocument/2006/relationships">
   <p:cSld>
     <p:spTree>
@@ -5379,7 +7549,7 @@
               </a:spcAft>
             </a:pPr>
             <a:r>
-              <a:rPr sz="1700" b="0">
+              <a:rPr sz="1600" b="0">
                 <a:solidFill>
                   <a:srgbClr val="1A1A1A"/>
                 </a:solidFill>
@@ -5395,7 +7565,7 @@
               </a:spcAft>
             </a:pPr>
             <a:r>
-              <a:rPr sz="1700" b="0">
+              <a:rPr sz="1600" b="0">
                 <a:solidFill>
                   <a:srgbClr val="1A1A1A"/>
                 </a:solidFill>
@@ -5411,7 +7581,7 @@
               </a:spcAft>
             </a:pPr>
             <a:r>
-              <a:rPr sz="1700" b="0">
+              <a:rPr sz="1600" b="0">
                 <a:solidFill>
                   <a:srgbClr val="1A1A1A"/>
                 </a:solidFill>
@@ -5427,7 +7597,7 @@
               </a:spcAft>
             </a:pPr>
             <a:r>
-              <a:rPr sz="1700" b="0">
+              <a:rPr sz="1600" b="0">
                 <a:solidFill>
                   <a:srgbClr val="1A1A1A"/>
                 </a:solidFill>
@@ -5443,13 +7613,29 @@
               </a:spcAft>
             </a:pPr>
             <a:r>
-              <a:rPr sz="1700" b="0">
+              <a:rPr sz="1600" b="0">
                 <a:solidFill>
                   <a:srgbClr val="1A1A1A"/>
                 </a:solidFill>
                 <a:latin typeface="Calibri"/>
               </a:rPr>
               <a:t>•  With a decent proposer, goal-reach rate barely changes; the value is safety and fewer wasted replans.</a:t>
+            </a:r>
+          </a:p>
+          <a:p>
+            <a:pPr>
+              <a:spcAft>
+                <a:spcPts val="600"/>
+              </a:spcAft>
+            </a:pPr>
+            <a:r>
+              <a:rPr sz="1600" b="0">
+                <a:solidFill>
+                  <a:srgbClr val="1A1A1A"/>
+                </a:solidFill>
+                <a:latin typeface="Calibri"/>
+              </a:rPr>
+              <a:t>•  Harder games: scrambles are random walks, and the cube is tested only to 8 moves.</a:t>
             </a:r>
           </a:p>
         </p:txBody>
@@ -5462,7 +7648,7 @@
 </p:sld>
 </file>
 
-<file path=ppt/slides/slide13.xml><?xml version="1.0" encoding="utf-8"?>
+<file path=ppt/slides/slide16.xml><?xml version="1.0" encoding="utf-8"?>
 <p:sld xmlns:a="http://schemas.openxmlformats.org/drawingml/2006/main" xmlns:p="http://schemas.openxmlformats.org/presentationml/2006/main" xmlns:r="http://schemas.openxmlformats.org/officeDocument/2006/relationships">
   <p:cSld>
     <p:spTree>
@@ -5574,13 +7760,13 @@
               </a:spcAft>
             </a:pPr>
             <a:r>
-              <a:rPr sz="2100" b="0">
+              <a:rPr sz="2000" b="0">
                 <a:solidFill>
                   <a:srgbClr val="1A1A1A"/>
                 </a:solidFill>
                 <a:latin typeface="Calibri"/>
               </a:rPr>
-              <a:t>•  We built a checking and selection layer on the TAPE pipeline and tested it on four benchmark families.</a:t>
+              <a:t>•  We built a checking and selection layer on the TAPE pipeline and tested it on seven games, with no language model.</a:t>
             </a:r>
           </a:p>
           <a:p>
@@ -5590,7 +7776,7 @@
               </a:spcAft>
             </a:pPr>
             <a:r>
-              <a:rPr sz="2100" b="0">
+              <a:rPr sz="2000" b="0">
                 <a:solidFill>
                   <a:srgbClr val="1A1A1A"/>
                 </a:solidFill>
@@ -5606,7 +7792,7 @@
               </a:spcAft>
             </a:pPr>
             <a:r>
-              <a:rPr sz="2100" b="0">
+              <a:rPr sz="2000" b="0">
                 <a:solidFill>
                   <a:srgbClr val="1A1A1A"/>
                 </a:solidFill>
@@ -5622,13 +7808,29 @@
               </a:spcAft>
             </a:pPr>
             <a:r>
-              <a:rPr sz="2100" b="0">
+              <a:rPr sz="2000" b="0">
                 <a:solidFill>
                   <a:srgbClr val="1A1A1A"/>
                 </a:solidFill>
                 <a:latin typeface="Calibri"/>
               </a:rPr>
               <a:t>•  Remembering failures reduces replans, but only when failures are state-dependent.</a:t>
+            </a:r>
+          </a:p>
+          <a:p>
+            <a:pPr>
+              <a:spcAft>
+                <a:spcPts val="600"/>
+              </a:spcAft>
+            </a:pPr>
+            <a:r>
+              <a:rPr sz="2000" b="0">
+                <a:solidFill>
+                  <a:srgbClr val="1A1A1A"/>
+                </a:solidFill>
+                <a:latin typeface="Calibri"/>
+              </a:rPr>
+              <a:t>•  On the harder games the checker prunes Peg Solitaire and guards unsolvable starts. DFS helps only Peg Solitaire; AO* does not apply.</a:t>
             </a:r>
           </a:p>
         </p:txBody>
@@ -5722,7 +7924,7 @@
                 </a:solidFill>
                 <a:latin typeface="Calibri"/>
               </a:rPr>
-              <a:t>•  Write up the results as a paper (draft in progress).</a:t>
+              <a:t>•  Finish the research paper (full draft written, with figures).</a:t>
             </a:r>
           </a:p>
         </p:txBody>
@@ -5735,7 +7937,7 @@
 </p:sld>
 </file>
 
-<file path=ppt/slides/slide14.xml><?xml version="1.0" encoding="utf-8"?>
+<file path=ppt/slides/slide17.xml><?xml version="1.0" encoding="utf-8"?>
 <p:sld xmlns:a="http://schemas.openxmlformats.org/drawingml/2006/main" xmlns:p="http://schemas.openxmlformats.org/presentationml/2006/main" xmlns:r="http://schemas.openxmlformats.org/officeDocument/2006/relationships">
   <p:cSld>
     <p:spTree>
@@ -5843,11 +8045,11 @@
           <a:p>
             <a:pPr>
               <a:spcAft>
-                <a:spcPts val="600"/>
-              </a:spcAft>
-            </a:pPr>
-            <a:r>
-              <a:rPr sz="1300" b="0">
+                <a:spcPts val="500"/>
+              </a:spcAft>
+            </a:pPr>
+            <a:r>
+              <a:rPr sz="1100" b="0">
                 <a:solidFill>
                   <a:srgbClr val="1A1A1A"/>
                 </a:solidFill>
@@ -5859,11 +8061,11 @@
           <a:p>
             <a:pPr>
               <a:spcAft>
-                <a:spcPts val="600"/>
-              </a:spcAft>
-            </a:pPr>
-            <a:r>
-              <a:rPr sz="1300" b="0">
+                <a:spcPts val="500"/>
+              </a:spcAft>
+            </a:pPr>
+            <a:r>
+              <a:rPr sz="1100" b="0">
                 <a:solidFill>
                   <a:srgbClr val="1A1A1A"/>
                 </a:solidFill>
@@ -5875,11 +8077,11 @@
           <a:p>
             <a:pPr>
               <a:spcAft>
-                <a:spcPts val="600"/>
-              </a:spcAft>
-            </a:pPr>
-            <a:r>
-              <a:rPr sz="1300" b="0">
+                <a:spcPts val="500"/>
+              </a:spcAft>
+            </a:pPr>
+            <a:r>
+              <a:rPr sz="1100" b="0">
                 <a:solidFill>
                   <a:srgbClr val="1A1A1A"/>
                 </a:solidFill>
@@ -5891,11 +8093,11 @@
           <a:p>
             <a:pPr>
               <a:spcAft>
-                <a:spcPts val="600"/>
-              </a:spcAft>
-            </a:pPr>
-            <a:r>
-              <a:rPr sz="1300" b="0">
+                <a:spcPts val="500"/>
+              </a:spcAft>
+            </a:pPr>
+            <a:r>
+              <a:rPr sz="1100" b="0">
                 <a:solidFill>
                   <a:srgbClr val="1A1A1A"/>
                 </a:solidFill>
@@ -5907,11 +8109,11 @@
           <a:p>
             <a:pPr>
               <a:spcAft>
-                <a:spcPts val="600"/>
-              </a:spcAft>
-            </a:pPr>
-            <a:r>
-              <a:rPr sz="1300" b="0">
+                <a:spcPts val="500"/>
+              </a:spcAft>
+            </a:pPr>
+            <a:r>
+              <a:rPr sz="1100" b="0">
                 <a:solidFill>
                   <a:srgbClr val="1A1A1A"/>
                 </a:solidFill>
@@ -5923,11 +8125,11 @@
           <a:p>
             <a:pPr>
               <a:spcAft>
-                <a:spcPts val="600"/>
-              </a:spcAft>
-            </a:pPr>
-            <a:r>
-              <a:rPr sz="1300" b="0">
+                <a:spcPts val="500"/>
+              </a:spcAft>
+            </a:pPr>
+            <a:r>
+              <a:rPr sz="1100" b="0">
                 <a:solidFill>
                   <a:srgbClr val="1A1A1A"/>
                 </a:solidFill>
@@ -5939,11 +8141,11 @@
           <a:p>
             <a:pPr>
               <a:spcAft>
-                <a:spcPts val="600"/>
-              </a:spcAft>
-            </a:pPr>
-            <a:r>
-              <a:rPr sz="1300" b="0">
+                <a:spcPts val="500"/>
+              </a:spcAft>
+            </a:pPr>
+            <a:r>
+              <a:rPr sz="1100" b="0">
                 <a:solidFill>
                   <a:srgbClr val="1A1A1A"/>
                 </a:solidFill>
@@ -5955,17 +8157,65 @@
           <a:p>
             <a:pPr>
               <a:spcAft>
-                <a:spcPts val="600"/>
-              </a:spcAft>
-            </a:pPr>
-            <a:r>
-              <a:rPr sz="1300" b="0">
+                <a:spcPts val="500"/>
+              </a:spcAft>
+            </a:pPr>
+            <a:r>
+              <a:rPr sz="1100" b="0">
                 <a:solidFill>
                   <a:srgbClr val="1A1A1A"/>
                 </a:solidFill>
                 <a:latin typeface="Calibri"/>
               </a:rPr>
               <a:t>[8] L. Wang et al., "Plan-and-Solve Prompting," arXiv:2305.04091, 2023.</a:t>
+            </a:r>
+          </a:p>
+          <a:p>
+            <a:pPr>
+              <a:spcAft>
+                <a:spcPts val="500"/>
+              </a:spcAft>
+            </a:pPr>
+            <a:r>
+              <a:rPr sz="1100" b="0">
+                <a:solidFill>
+                  <a:srgbClr val="1A1A1A"/>
+                </a:solidFill>
+                <a:latin typeface="Calibri"/>
+              </a:rPr>
+              <a:t>[9] B. Xu et al., "ReWOO: Decoupling Reasoning from Observations for Efficient Augmented Language Models," arXiv:2305.18323, 2023.</a:t>
+            </a:r>
+          </a:p>
+          <a:p>
+            <a:pPr>
+              <a:spcAft>
+                <a:spcPts val="500"/>
+              </a:spcAft>
+            </a:pPr>
+            <a:r>
+              <a:rPr sz="1100" b="0">
+                <a:solidFill>
+                  <a:srgbClr val="1A1A1A"/>
+                </a:solidFill>
+                <a:latin typeface="Calibri"/>
+              </a:rPr>
+              <a:t>[10] M. Shridhar et al., "ALFWorld: Aligning Text and Embodied Environments for Interactive Learning," arXiv:2010.03768, 2020.</a:t>
+            </a:r>
+          </a:p>
+          <a:p>
+            <a:pPr>
+              <a:spcAft>
+                <a:spcPts val="500"/>
+              </a:spcAft>
+            </a:pPr>
+            <a:r>
+              <a:rPr sz="1100" b="0">
+                <a:solidFill>
+                  <a:srgbClr val="1A1A1A"/>
+                </a:solidFill>
+                <a:latin typeface="Calibri"/>
+              </a:rPr>
+              <a:t>[11] H. Trivedi et al., "MuSiQue: Multihop Questions via Single-hop Question Composition," arXiv:2108.00573, 2021.</a:t>
             </a:r>
           </a:p>
         </p:txBody>
@@ -5994,145 +8244,161 @@
           <a:p>
             <a:pPr>
               <a:spcAft>
-                <a:spcPts val="600"/>
-              </a:spcAft>
-            </a:pPr>
-            <a:r>
-              <a:rPr sz="1300" b="0">
+                <a:spcPts val="500"/>
+              </a:spcAft>
+            </a:pPr>
+            <a:r>
+              <a:rPr sz="1100" b="0">
                 <a:solidFill>
                   <a:srgbClr val="1A1A1A"/>
                 </a:solidFill>
                 <a:latin typeface="Calibri"/>
               </a:rPr>
-              <a:t>[9] B. Xu et al., "ReWOO: Decoupling Reasoning from Observations for Efficient Augmented Language Models," arXiv:2305.18323, 2023.</a:t>
-            </a:r>
-          </a:p>
-          <a:p>
-            <a:pPr>
-              <a:spcAft>
-                <a:spcPts val="600"/>
-              </a:spcAft>
-            </a:pPr>
-            <a:r>
-              <a:rPr sz="1300" b="0">
+              <a:t>[12] K. Cobbe et al., "Training Verifiers to Solve Math Word Problems," arXiv:2110.14168, 2021.</a:t>
+            </a:r>
+          </a:p>
+          <a:p>
+            <a:pPr>
+              <a:spcAft>
+                <a:spcPts val="500"/>
+              </a:spcAft>
+            </a:pPr>
+            <a:r>
+              <a:rPr sz="1100" b="0">
                 <a:solidFill>
                   <a:srgbClr val="1A1A1A"/>
                 </a:solidFill>
                 <a:latin typeface="Calibri"/>
               </a:rPr>
-              <a:t>[10] M. Shridhar et al., "ALFWorld: Aligning Text and Embodied Environments for Interactive Learning," arXiv:2010.03768, 2020.</a:t>
-            </a:r>
-          </a:p>
-          <a:p>
-            <a:pPr>
-              <a:spcAft>
-                <a:spcPts val="600"/>
-              </a:spcAft>
-            </a:pPr>
-            <a:r>
-              <a:rPr sz="1300" b="0">
+              <a:t>[13] P. Hart, N. Nilsson, B. Raphael, "A Formal Basis for the Heuristic Determination of Minimum Cost Paths," IEEE Trans. Systems Science and Cybernetics, 1968.</a:t>
+            </a:r>
+          </a:p>
+          <a:p>
+            <a:pPr>
+              <a:spcAft>
+                <a:spcPts val="500"/>
+              </a:spcAft>
+            </a:pPr>
+            <a:r>
+              <a:rPr sz="1100" b="0">
                 <a:solidFill>
                   <a:srgbClr val="1A1A1A"/>
                 </a:solidFill>
                 <a:latin typeface="Calibri"/>
               </a:rPr>
-              <a:t>[11] H. Trivedi et al., "MuSiQue: Multihop Questions via Single-hop Question Composition," arXiv:2108.00573, 2021.</a:t>
-            </a:r>
-          </a:p>
-          <a:p>
-            <a:pPr>
-              <a:spcAft>
-                <a:spcPts val="600"/>
-              </a:spcAft>
-            </a:pPr>
-            <a:r>
-              <a:rPr sz="1300" b="0">
+              <a:t>[14] J. Culberson, "Sokoban is PSPACE-complete," Tech. Rep. TR97-02, Univ. of Alberta, 1997.</a:t>
+            </a:r>
+          </a:p>
+          <a:p>
+            <a:pPr>
+              <a:spcAft>
+                <a:spcPts val="500"/>
+              </a:spcAft>
+            </a:pPr>
+            <a:r>
+              <a:rPr sz="1100" b="0">
                 <a:solidFill>
                   <a:srgbClr val="1A1A1A"/>
                 </a:solidFill>
                 <a:latin typeface="Calibri"/>
               </a:rPr>
-              <a:t>[12] K. Cobbe et al., "Training Verifiers to Solve Math Word Problems," arXiv:2110.14168, 2021.</a:t>
-            </a:r>
-          </a:p>
-          <a:p>
-            <a:pPr>
-              <a:spcAft>
-                <a:spcPts val="600"/>
-              </a:spcAft>
-            </a:pPr>
-            <a:r>
-              <a:rPr sz="1300" b="0">
+              <a:t>[15] G. W. Flake, E. B. Baum, "Rush Hour is PSPACE-complete," Theoretical Computer Science 270(1-2):895-911, 2002.</a:t>
+            </a:r>
+          </a:p>
+          <a:p>
+            <a:pPr>
+              <a:spcAft>
+                <a:spcPts val="500"/>
+              </a:spcAft>
+            </a:pPr>
+            <a:r>
+              <a:rPr sz="1100" b="0">
                 <a:solidFill>
                   <a:srgbClr val="1A1A1A"/>
                 </a:solidFill>
                 <a:latin typeface="Calibri"/>
               </a:rPr>
-              <a:t>[13] P. Hart, N. Nilsson, B. Raphael, "A Formal Basis for the Heuristic Determination of Minimum Cost Paths," IEEE Trans. Systems Science and Cybernetics, 1968.</a:t>
-            </a:r>
-          </a:p>
-          <a:p>
-            <a:pPr>
-              <a:spcAft>
-                <a:spcPts val="600"/>
-              </a:spcAft>
-            </a:pPr>
-            <a:r>
-              <a:rPr sz="1300" b="0">
+              <a:t>[16] DeepMind, "Boxoban levels," github.com/google-deepmind/boxoban-levels.</a:t>
+            </a:r>
+          </a:p>
+          <a:p>
+            <a:pPr>
+              <a:spcAft>
+                <a:spcPts val="500"/>
+              </a:spcAft>
+            </a:pPr>
+            <a:r>
+              <a:rPr sz="1100" b="0">
                 <a:solidFill>
                   <a:srgbClr val="1A1A1A"/>
                 </a:solidFill>
                 <a:latin typeface="Calibri"/>
               </a:rPr>
-              <a:t>[14] J. Culberson, "Sokoban is PSPACE-complete," Tech. Rep. TR97-02, Univ. of Alberta, 1997.</a:t>
-            </a:r>
-          </a:p>
-          <a:p>
-            <a:pPr>
-              <a:spcAft>
-                <a:spcPts val="600"/>
-              </a:spcAft>
-            </a:pPr>
-            <a:r>
-              <a:rPr sz="1300" b="0">
+              <a:t>[17] L. Perron, V. Furnon, "OR-Tools," Google, developers.google.com/optimization.</a:t>
+            </a:r>
+          </a:p>
+          <a:p>
+            <a:pPr>
+              <a:spcAft>
+                <a:spcPts val="500"/>
+              </a:spcAft>
+            </a:pPr>
+            <a:r>
+              <a:rPr sz="1100" b="0">
                 <a:solidFill>
                   <a:srgbClr val="1A1A1A"/>
                 </a:solidFill>
                 <a:latin typeface="Calibri"/>
               </a:rPr>
-              <a:t>[15] G. W. Flake, E. B. Baum, "Rush Hour is PSPACE-complete," Theoretical Computer Science 270(1-2):895-911, 2002.</a:t>
-            </a:r>
-          </a:p>
-          <a:p>
-            <a:pPr>
-              <a:spcAft>
-                <a:spcPts val="600"/>
-              </a:spcAft>
-            </a:pPr>
-            <a:r>
-              <a:rPr sz="1300" b="0">
+              <a:t>[18] I. Pohl, "Heuristic search viewed as path finding in a graph," Artificial Intelligence 1(3-4):193-204, 1970.</a:t>
+            </a:r>
+          </a:p>
+          <a:p>
+            <a:pPr>
+              <a:spcAft>
+                <a:spcPts val="500"/>
+              </a:spcAft>
+            </a:pPr>
+            <a:r>
+              <a:rPr sz="1100" b="0">
                 <a:solidFill>
                   <a:srgbClr val="1A1A1A"/>
                 </a:solidFill>
                 <a:latin typeface="Calibri"/>
               </a:rPr>
-              <a:t>[16] DeepMind, "Boxoban levels," github.com/google-deepmind/boxoban-levels.</a:t>
-            </a:r>
-          </a:p>
-          <a:p>
-            <a:pPr>
-              <a:spcAft>
-                <a:spcPts val="600"/>
-              </a:spcAft>
-            </a:pPr>
-            <a:r>
-              <a:rPr sz="1300" b="0">
+              <a:t>[19] R. E. Korf, "Depth-first iterative-deepening," Artificial Intelligence 27(1):97-109, 1985.</a:t>
+            </a:r>
+          </a:p>
+          <a:p>
+            <a:pPr>
+              <a:spcAft>
+                <a:spcPts val="500"/>
+              </a:spcAft>
+            </a:pPr>
+            <a:r>
+              <a:rPr sz="1100" b="0">
                 <a:solidFill>
                   <a:srgbClr val="1A1A1A"/>
                 </a:solidFill>
                 <a:latin typeface="Calibri"/>
               </a:rPr>
-              <a:t>[17] L. Perron, V. Furnon, "OR-Tools," Google, developers.google.com/optimization.</a:t>
+              <a:t>[20] T. Rokicki et al., "The diameter of the Rubik's Cube group is twenty," SIAM J. Discrete Math. 27(2):1082-1105, 2013.</a:t>
+            </a:r>
+          </a:p>
+          <a:p>
+            <a:pPr>
+              <a:spcAft>
+                <a:spcPts val="500"/>
+              </a:spcAft>
+            </a:pPr>
+            <a:r>
+              <a:rPr sz="1100" b="0">
+                <a:solidFill>
+                  <a:srgbClr val="1A1A1A"/>
+                </a:solidFill>
+                <a:latin typeface="Calibri"/>
+              </a:rPr>
+              <a:t>[21] E. A. Hansen, S. Zilberstein, "LAO*: A heuristic search algorithm that finds solutions with loops," Artificial Intelligence 129(1-2):35-62, 2001.</a:t>
             </a:r>
           </a:p>
         </p:txBody>
@@ -6327,7 +8593,7 @@
                 </a:solidFill>
                 <a:latin typeface="Calibri"/>
               </a:rPr>
-              <a:t>•  Tested on four benchmark families: Sokoban, River Crossing, Rush Hour and Boxoban.</a:t>
+              <a:t>•  Tested on seven games: Sokoban, River Crossing, Rush Hour, Peg Solitaire, the 24-puzzle, the Rubik's cube and 3,000 Boxoban levels.</a:t>
             </a:r>
           </a:p>
         </p:txBody>
@@ -9022,7 +11288,7 @@
                 </a:solidFill>
                 <a:latin typeface="Calibri"/>
               </a:rPr>
-              <a:t>Coding Progress</a:t>
+              <a:t>Games and Benchmarks</a:t>
             </a:r>
           </a:p>
         </p:txBody>
@@ -9096,7 +11362,7 @@
                 </a:solidFill>
                 <a:latin typeface="Calibri"/>
               </a:rPr>
-              <a:t>Target for this review: 40%. Completed: all five pipeline phases and the evaluation experiments.</a:t>
+              <a:t>One interface, seven games, each with its own rule checker.</a:t>
             </a:r>
           </a:p>
         </p:txBody>
@@ -9111,7 +11377,7 @@
         </p:nvGraphicFramePr>
         <p:xfrm>
           <a:off x="548640" y="1737360"/>
-          <a:ext cx="11064240" cy="3520440"/>
+          <a:ext cx="11064240" cy="3803904"/>
         </p:xfrm>
         <a:graphic>
           <a:graphicData uri="http://schemas.openxmlformats.org/drawingml/2006/table">
@@ -9120,24 +11386,25 @@
                 <a:tableStyleId>{5C22544A-7EE6-4342-B048-85BDC9FD1C3A}</a:tableStyleId>
               </a:tblPr>
               <a:tblGrid>
-                <a:gridCol w="2743200"/>
-                <a:gridCol w="6675120"/>
-                <a:gridCol w="1645920"/>
+                <a:gridCol w="2468880"/>
+                <a:gridCol w="3383280"/>
+                <a:gridCol w="3108960"/>
+                <a:gridCol w="2103120"/>
               </a:tblGrid>
-              <a:tr h="502920">
-                <a:tc>
-                  <a:txBody>
-                    <a:bodyPr/>
-                    <a:lstStyle/>
-                    <a:p>
-                      <a:r>
-                        <a:rPr sz="1500" b="1">
+              <a:tr h="475488">
+                <a:tc>
+                  <a:txBody>
+                    <a:bodyPr/>
+                    <a:lstStyle/>
+                    <a:p>
+                      <a:r>
+                        <a:rPr sz="1300" b="1">
                           <a:solidFill>
                             <a:srgbClr val="FFFFFF"/>
                           </a:solidFill>
                           <a:latin typeface="Calibri"/>
                         </a:rPr>
-                        <a:t>Phase</a:t>
+                        <a:t>Game</a:t>
                       </a:r>
                     </a:p>
                   </a:txBody>
@@ -9153,13 +11420,13 @@
                     <a:lstStyle/>
                     <a:p>
                       <a:r>
-                        <a:rPr sz="1500" b="1">
+                        <a:rPr sz="1300" b="1">
                           <a:solidFill>
                             <a:srgbClr val="FFFFFF"/>
                           </a:solidFill>
                           <a:latin typeface="Calibri"/>
                         </a:rPr>
-                        <a:t>What was coded</a:t>
+                        <a:t>Size</a:t>
                       </a:r>
                     </a:p>
                   </a:txBody>
@@ -9175,13 +11442,13 @@
                     <a:lstStyle/>
                     <a:p>
                       <a:r>
-                        <a:rPr sz="1500" b="1">
+                        <a:rPr sz="1300" b="1">
                           <a:solidFill>
                             <a:srgbClr val="FFFFFF"/>
                           </a:solidFill>
                           <a:latin typeface="Calibri"/>
                         </a:rPr>
-                        <a:t>Status</a:t>
+                        <a:t>Checker</a:t>
                       </a:r>
                     </a:p>
                   </a:txBody>
@@ -9191,21 +11458,43 @@
                     </a:solidFill>
                   </a:tcPr>
                 </a:tc>
+                <a:tc>
+                  <a:txBody>
+                    <a:bodyPr/>
+                    <a:lstStyle/>
+                    <a:p>
+                      <a:r>
+                        <a:rPr sz="1300" b="1">
+                          <a:solidFill>
+                            <a:srgbClr val="FFFFFF"/>
+                          </a:solidFill>
+                          <a:latin typeface="Calibri"/>
+                        </a:rPr>
+                        <a:t>Proposer</a:t>
+                      </a:r>
+                    </a:p>
+                  </a:txBody>
+                  <a:tcPr>
+                    <a:solidFill>
+                      <a:srgbClr val="1F4FC8"/>
+                    </a:solidFill>
+                  </a:tcPr>
+                </a:tc>
               </a:tr>
-              <a:tr h="502920">
-                <a:tc>
-                  <a:txBody>
-                    <a:bodyPr/>
-                    <a:lstStyle/>
-                    <a:p>
-                      <a:r>
-                        <a:rPr sz="1500" b="0">
-                          <a:solidFill>
-                            <a:srgbClr val="1A1A1A"/>
-                          </a:solidFill>
-                          <a:latin typeface="Calibri"/>
-                        </a:rPr>
-                        <a:t>1  TAPE baseline</a:t>
+              <a:tr h="475488">
+                <a:tc>
+                  <a:txBody>
+                    <a:bodyPr/>
+                    <a:lstStyle/>
+                    <a:p>
+                      <a:r>
+                        <a:rPr sz="1300" b="0">
+                          <a:solidFill>
+                            <a:srgbClr val="1A1A1A"/>
+                          </a:solidFill>
+                          <a:latin typeface="Calibri"/>
+                        </a:rPr>
+                        <a:t>Sokoban (4 levels)</a:t>
                       </a:r>
                     </a:p>
                   </a:txBody>
@@ -9221,13 +11510,13 @@
                     <a:lstStyle/>
                     <a:p>
                       <a:r>
-                        <a:rPr sz="1500" b="0">
-                          <a:solidFill>
-                            <a:srgbClr val="1A1A1A"/>
-                          </a:solidFill>
-                          <a:latin typeface="Calibri"/>
-                        </a:rPr>
-                        <a:t>Environment interface, plan graph, CP-SAT solver, constrained execution, replanning</a:t>
+                        <a:rPr sz="1300" b="0">
+                          <a:solidFill>
+                            <a:srgbClr val="1A1A1A"/>
+                          </a:solidFill>
+                          <a:latin typeface="Calibri"/>
+                        </a:rPr>
+                        <a:t>Up to 3 boxes, PSPACE-complete</a:t>
                       </a:r>
                     </a:p>
                   </a:txBody>
@@ -9243,13 +11532,13 @@
                     <a:lstStyle/>
                     <a:p>
                       <a:r>
-                        <a:rPr sz="1500" b="0">
-                          <a:solidFill>
-                            <a:srgbClr val="1A1A1A"/>
-                          </a:solidFill>
-                          <a:latin typeface="Calibri"/>
-                        </a:rPr>
-                        <a:t>Done</a:t>
+                        <a:rPr sz="1300" b="0">
+                          <a:solidFill>
+                            <a:srgbClr val="1A1A1A"/>
+                          </a:solidFill>
+                          <a:latin typeface="Calibri"/>
+                        </a:rPr>
+                        <a:t>Dead corner rule</a:t>
                       </a:r>
                     </a:p>
                   </a:txBody>
@@ -9259,21 +11548,43 @@
                     </a:solidFill>
                   </a:tcPr>
                 </a:tc>
+                <a:tc>
+                  <a:txBody>
+                    <a:bodyPr/>
+                    <a:lstStyle/>
+                    <a:p>
+                      <a:r>
+                        <a:rPr sz="1300" b="0">
+                          <a:solidFill>
+                            <a:srgbClr val="1A1A1A"/>
+                          </a:solidFill>
+                          <a:latin typeface="Calibri"/>
+                        </a:rPr>
+                        <a:t>BFS plus noisy walks</a:t>
+                      </a:r>
+                    </a:p>
+                  </a:txBody>
+                  <a:tcPr>
+                    <a:solidFill>
+                      <a:srgbClr val="FFFFFF"/>
+                    </a:solidFill>
+                  </a:tcPr>
+                </a:tc>
               </a:tr>
-              <a:tr h="502920">
-                <a:tc>
-                  <a:txBody>
-                    <a:bodyPr/>
-                    <a:lstStyle/>
-                    <a:p>
-                      <a:r>
-                        <a:rPr sz="1500" b="0">
-                          <a:solidFill>
-                            <a:srgbClr val="1A1A1A"/>
-                          </a:solidFill>
-                          <a:latin typeface="Calibri"/>
-                        </a:rPr>
-                        <a:t>2  Graph validation</a:t>
+              <a:tr h="475488">
+                <a:tc>
+                  <a:txBody>
+                    <a:bodyPr/>
+                    <a:lstStyle/>
+                    <a:p>
+                      <a:r>
+                        <a:rPr sz="1300" b="0">
+                          <a:solidFill>
+                            <a:srgbClr val="1A1A1A"/>
+                          </a:solidFill>
+                          <a:latin typeface="Calibri"/>
+                        </a:rPr>
+                        <a:t>River Crossing</a:t>
                       </a:r>
                     </a:p>
                   </a:txBody>
@@ -9289,13 +11600,13 @@
                     <a:lstStyle/>
                     <a:p>
                       <a:r>
-                        <a:rPr sz="1500" b="0">
-                          <a:solidFill>
-                            <a:srgbClr val="1A1A1A"/>
-                          </a:solidFill>
-                          <a:latin typeface="Calibri"/>
-                        </a:rPr>
-                        <a:t>Rule checkers: Sokoban corners, River Crossing safety, Rush Hour gridlock</a:t>
+                        <a:rPr sz="1300" b="0">
+                          <a:solidFill>
+                            <a:srgbClr val="1A1A1A"/>
+                          </a:solidFill>
+                          <a:latin typeface="Calibri"/>
+                        </a:rPr>
+                        <a:t>3 pairs, 11-move optimum</a:t>
                       </a:r>
                     </a:p>
                   </a:txBody>
@@ -9311,13 +11622,13 @@
                     <a:lstStyle/>
                     <a:p>
                       <a:r>
-                        <a:rPr sz="1500" b="0">
-                          <a:solidFill>
-                            <a:srgbClr val="1A1A1A"/>
-                          </a:solidFill>
-                          <a:latin typeface="Calibri"/>
-                        </a:rPr>
-                        <a:t>Done</a:t>
+                        <a:rPr sz="1300" b="0">
+                          <a:solidFill>
+                            <a:srgbClr val="1A1A1A"/>
+                          </a:solidFill>
+                          <a:latin typeface="Calibri"/>
+                        </a:rPr>
+                        <a:t>Outnumbered rule</a:t>
                       </a:r>
                     </a:p>
                   </a:txBody>
@@ -9327,21 +11638,43 @@
                     </a:solidFill>
                   </a:tcPr>
                 </a:tc>
+                <a:tc>
+                  <a:txBody>
+                    <a:bodyPr/>
+                    <a:lstStyle/>
+                    <a:p>
+                      <a:r>
+                        <a:rPr sz="1300" b="0">
+                          <a:solidFill>
+                            <a:srgbClr val="1A1A1A"/>
+                          </a:solidFill>
+                          <a:latin typeface="Calibri"/>
+                        </a:rPr>
+                        <a:t>BFS plus noisy walks</a:t>
+                      </a:r>
+                    </a:p>
+                  </a:txBody>
+                  <a:tcPr>
+                    <a:solidFill>
+                      <a:srgbClr val="F6F6F6"/>
+                    </a:solidFill>
+                  </a:tcPr>
+                </a:tc>
               </a:tr>
-              <a:tr h="502920">
-                <a:tc>
-                  <a:txBody>
-                    <a:bodyPr/>
-                    <a:lstStyle/>
-                    <a:p>
-                      <a:r>
-                        <a:rPr sz="1500" b="0">
-                          <a:solidFill>
-                            <a:srgbClr val="1A1A1A"/>
-                          </a:solidFill>
-                          <a:latin typeface="Calibri"/>
-                        </a:rPr>
-                        <a:t>3  Self-improving graph</a:t>
+              <a:tr h="475488">
+                <a:tc>
+                  <a:txBody>
+                    <a:bodyPr/>
+                    <a:lstStyle/>
+                    <a:p>
+                      <a:r>
+                        <a:rPr sz="1300" b="0">
+                          <a:solidFill>
+                            <a:srgbClr val="1A1A1A"/>
+                          </a:solidFill>
+                          <a:latin typeface="Calibri"/>
+                        </a:rPr>
+                        <a:t>Rush Hour</a:t>
                       </a:r>
                     </a:p>
                   </a:txBody>
@@ -9357,13 +11690,13 @@
                     <a:lstStyle/>
                     <a:p>
                       <a:r>
-                        <a:rPr sz="1500" b="0">
-                          <a:solidFill>
-                            <a:srgbClr val="1A1A1A"/>
-                          </a:solidFill>
-                          <a:latin typeface="Calibri"/>
-                        </a:rPr>
-                        <a:t>SQLite experience store with smoothed confidence</a:t>
+                        <a:rPr sz="1300" b="0">
+                          <a:solidFill>
+                            <a:srgbClr val="1A1A1A"/>
+                          </a:solidFill>
+                          <a:latin typeface="Calibri"/>
+                        </a:rPr>
+                        <a:t>6 by 6 board, PSPACE-complete</a:t>
                       </a:r>
                     </a:p>
                   </a:txBody>
@@ -9379,13 +11712,13 @@
                     <a:lstStyle/>
                     <a:p>
                       <a:r>
-                        <a:rPr sz="1500" b="0">
-                          <a:solidFill>
-                            <a:srgbClr val="1A1A1A"/>
-                          </a:solidFill>
-                          <a:latin typeface="Calibri"/>
-                        </a:rPr>
-                        <a:t>Done</a:t>
+                        <a:rPr sz="1300" b="0">
+                          <a:solidFill>
+                            <a:srgbClr val="1A1A1A"/>
+                          </a:solidFill>
+                          <a:latin typeface="Calibri"/>
+                        </a:rPr>
+                        <a:t>Row gridlock rule</a:t>
                       </a:r>
                     </a:p>
                   </a:txBody>
@@ -9395,21 +11728,43 @@
                     </a:solidFill>
                   </a:tcPr>
                 </a:tc>
+                <a:tc>
+                  <a:txBody>
+                    <a:bodyPr/>
+                    <a:lstStyle/>
+                    <a:p>
+                      <a:r>
+                        <a:rPr sz="1300" b="0">
+                          <a:solidFill>
+                            <a:srgbClr val="1A1A1A"/>
+                          </a:solidFill>
+                          <a:latin typeface="Calibri"/>
+                        </a:rPr>
+                        <a:t>BFS plus noisy walks</a:t>
+                      </a:r>
+                    </a:p>
+                  </a:txBody>
+                  <a:tcPr>
+                    <a:solidFill>
+                      <a:srgbClr val="FFFFFF"/>
+                    </a:solidFill>
+                  </a:tcPr>
+                </a:tc>
               </a:tr>
-              <a:tr h="502920">
-                <a:tc>
-                  <a:txBody>
-                    <a:bodyPr/>
-                    <a:lstStyle/>
-                    <a:p>
-                      <a:r>
-                        <a:rPr sz="1500" b="0">
-                          <a:solidFill>
-                            <a:srgbClr val="1A1A1A"/>
-                          </a:solidFill>
-                          <a:latin typeface="Calibri"/>
-                        </a:rPr>
-                        <a:t>4  Dynamic score</a:t>
+              <a:tr h="475488">
+                <a:tc>
+                  <a:txBody>
+                    <a:bodyPr/>
+                    <a:lstStyle/>
+                    <a:p>
+                      <a:r>
+                        <a:rPr sz="1300" b="0">
+                          <a:solidFill>
+                            <a:srgbClr val="1A1A1A"/>
+                          </a:solidFill>
+                          <a:latin typeface="Calibri"/>
+                        </a:rPr>
+                        <a:t>Boxoban</a:t>
                       </a:r>
                     </a:p>
                   </a:txBody>
@@ -9425,13 +11780,13 @@
                     <a:lstStyle/>
                     <a:p>
                       <a:r>
-                        <a:rPr sz="1500" b="0">
-                          <a:solidFill>
-                            <a:srgbClr val="1A1A1A"/>
-                          </a:solidFill>
-                          <a:latin typeface="Calibri"/>
-                        </a:rPr>
-                        <a:t>Per-move cost from progress, confidence and budget</a:t>
+                        <a:rPr sz="1300" b="0">
+                          <a:solidFill>
+                            <a:srgbClr val="1A1A1A"/>
+                          </a:solidFill>
+                          <a:latin typeface="Calibri"/>
+                        </a:rPr>
+                        <a:t>3,000 real levels, 4 boxes</a:t>
                       </a:r>
                     </a:p>
                   </a:txBody>
@@ -9447,13 +11802,13 @@
                     <a:lstStyle/>
                     <a:p>
                       <a:r>
-                        <a:rPr sz="1500" b="0">
-                          <a:solidFill>
-                            <a:srgbClr val="1A1A1A"/>
-                          </a:solidFill>
-                          <a:latin typeface="Calibri"/>
-                        </a:rPr>
-                        <a:t>Done</a:t>
+                        <a:rPr sz="1300" b="0">
+                          <a:solidFill>
+                            <a:srgbClr val="1A1A1A"/>
+                          </a:solidFill>
+                          <a:latin typeface="Calibri"/>
+                        </a:rPr>
+                        <a:t>Dead corner rule (prunes search)</a:t>
                       </a:r>
                     </a:p>
                   </a:txBody>
@@ -9463,21 +11818,43 @@
                     </a:solidFill>
                   </a:tcPr>
                 </a:tc>
+                <a:tc>
+                  <a:txBody>
+                    <a:bodyPr/>
+                    <a:lstStyle/>
+                    <a:p>
+                      <a:r>
+                        <a:rPr sz="1300" b="0">
+                          <a:solidFill>
+                            <a:srgbClr val="1A1A1A"/>
+                          </a:solidFill>
+                          <a:latin typeface="Calibri"/>
+                        </a:rPr>
+                        <a:t>Weighted A*</a:t>
+                      </a:r>
+                    </a:p>
+                  </a:txBody>
+                  <a:tcPr>
+                    <a:solidFill>
+                      <a:srgbClr val="F6F6F6"/>
+                    </a:solidFill>
+                  </a:tcPr>
+                </a:tc>
               </a:tr>
-              <a:tr h="502920">
-                <a:tc>
-                  <a:txBody>
-                    <a:bodyPr/>
-                    <a:lstStyle/>
-                    <a:p>
-                      <a:r>
-                        <a:rPr sz="1500" b="0">
-                          <a:solidFill>
-                            <a:srgbClr val="1A1A1A"/>
-                          </a:solidFill>
-                          <a:latin typeface="Calibri"/>
-                        </a:rPr>
-                        <a:t>5  Adaptive selection</a:t>
+              <a:tr h="475488">
+                <a:tc>
+                  <a:txBody>
+                    <a:bodyPr/>
+                    <a:lstStyle/>
+                    <a:p>
+                      <a:r>
+                        <a:rPr sz="1300" b="0">
+                          <a:solidFill>
+                            <a:srgbClr val="1A1A1A"/>
+                          </a:solidFill>
+                          <a:latin typeface="Calibri"/>
+                        </a:rPr>
+                        <a:t>Peg Solitaire</a:t>
                       </a:r>
                     </a:p>
                   </a:txBody>
@@ -9493,13 +11870,13 @@
                     <a:lstStyle/>
                     <a:p>
                       <a:r>
-                        <a:rPr sz="1500" b="0">
-                          <a:solidFill>
-                            <a:srgbClr val="1A1A1A"/>
-                          </a:solidFill>
-                          <a:latin typeface="Calibri"/>
-                        </a:rPr>
-                        <a:t>A* and CP-SAT, chosen by task complexity</a:t>
+                        <a:rPr sz="1300" b="0">
+                          <a:solidFill>
+                            <a:srgbClr val="1A1A1A"/>
+                          </a:solidFill>
+                          <a:latin typeface="Calibri"/>
+                        </a:rPr>
+                        <a:t>About 3.6 million reachable positions</a:t>
                       </a:r>
                     </a:p>
                   </a:txBody>
@@ -9515,13 +11892,13 @@
                     <a:lstStyle/>
                     <a:p>
                       <a:r>
-                        <a:rPr sz="1500" b="0">
-                          <a:solidFill>
-                            <a:srgbClr val="1A1A1A"/>
-                          </a:solidFill>
-                          <a:latin typeface="Calibri"/>
-                        </a:rPr>
-                        <a:t>Done</a:t>
+                        <a:rPr sz="1300" b="0">
+                          <a:solidFill>
+                            <a:srgbClr val="1A1A1A"/>
+                          </a:solidFill>
+                          <a:latin typeface="Calibri"/>
+                        </a:rPr>
+                        <a:t>Pagoda bound (proof)</a:t>
                       </a:r>
                     </a:p>
                   </a:txBody>
@@ -9531,21 +11908,43 @@
                     </a:solidFill>
                   </a:tcPr>
                 </a:tc>
+                <a:tc>
+                  <a:txBody>
+                    <a:bodyPr/>
+                    <a:lstStyle/>
+                    <a:p>
+                      <a:r>
+                        <a:rPr sz="1300" b="0">
+                          <a:solidFill>
+                            <a:srgbClr val="1A1A1A"/>
+                          </a:solidFill>
+                          <a:latin typeface="Calibri"/>
+                        </a:rPr>
+                        <a:t>Weighted A*, DFS</a:t>
+                      </a:r>
+                    </a:p>
+                  </a:txBody>
+                  <a:tcPr>
+                    <a:solidFill>
+                      <a:srgbClr val="FFFFFF"/>
+                    </a:solidFill>
+                  </a:tcPr>
+                </a:tc>
               </a:tr>
-              <a:tr h="502920">
-                <a:tc>
-                  <a:txBody>
-                    <a:bodyPr/>
-                    <a:lstStyle/>
-                    <a:p>
-                      <a:r>
-                        <a:rPr sz="1500" b="0">
-                          <a:solidFill>
-                            <a:srgbClr val="1A1A1A"/>
-                          </a:solidFill>
-                          <a:latin typeface="Calibri"/>
-                        </a:rPr>
-                        <a:t>6  Evaluation</a:t>
+              <a:tr h="475488">
+                <a:tc>
+                  <a:txBody>
+                    <a:bodyPr/>
+                    <a:lstStyle/>
+                    <a:p>
+                      <a:r>
+                        <a:rPr sz="1300" b="0">
+                          <a:solidFill>
+                            <a:srgbClr val="1A1A1A"/>
+                          </a:solidFill>
+                          <a:latin typeface="Calibri"/>
+                        </a:rPr>
+                        <a:t>24-puzzle</a:t>
                       </a:r>
                     </a:p>
                   </a:txBody>
@@ -9561,13 +11960,13 @@
                     <a:lstStyle/>
                     <a:p>
                       <a:r>
-                        <a:rPr sz="1500" b="0">
-                          <a:solidFill>
-                            <a:srgbClr val="1A1A1A"/>
-                          </a:solidFill>
-                          <a:latin typeface="Calibri"/>
-                        </a:rPr>
-                        <a:t>Ablation, memory test, weight tuning, proposer sweep, Boxoban</a:t>
+                        <a:rPr sz="1300" b="0">
+                          <a:solidFill>
+                            <a:srgbClr val="1A1A1A"/>
+                          </a:solidFill>
+                          <a:latin typeface="Calibri"/>
+                        </a:rPr>
+                        <a:t>About 7.8 x 10^24 states</a:t>
                       </a:r>
                     </a:p>
                   </a:txBody>
@@ -9583,19 +11982,131 @@
                     <a:lstStyle/>
                     <a:p>
                       <a:r>
-                        <a:rPr sz="1500" b="0">
-                          <a:solidFill>
-                            <a:srgbClr val="1A1A1A"/>
-                          </a:solidFill>
-                          <a:latin typeface="Calibri"/>
-                        </a:rPr>
-                        <a:t>Core done</a:t>
+                        <a:rPr sz="1300" b="0">
+                          <a:solidFill>
+                            <a:srgbClr val="1A1A1A"/>
+                          </a:solidFill>
+                          <a:latin typeface="Calibri"/>
+                        </a:rPr>
+                        <a:t>Parity rule (guards the start)</a:t>
                       </a:r>
                     </a:p>
                   </a:txBody>
                   <a:tcPr>
                     <a:solidFill>
                       <a:srgbClr val="F6F6F6"/>
+                    </a:solidFill>
+                  </a:tcPr>
+                </a:tc>
+                <a:tc>
+                  <a:txBody>
+                    <a:bodyPr/>
+                    <a:lstStyle/>
+                    <a:p>
+                      <a:r>
+                        <a:rPr sz="1300" b="0">
+                          <a:solidFill>
+                            <a:srgbClr val="1A1A1A"/>
+                          </a:solidFill>
+                          <a:latin typeface="Calibri"/>
+                        </a:rPr>
+                        <a:t>Weighted A*</a:t>
+                      </a:r>
+                    </a:p>
+                  </a:txBody>
+                  <a:tcPr>
+                    <a:solidFill>
+                      <a:srgbClr val="F6F6F6"/>
+                    </a:solidFill>
+                  </a:tcPr>
+                </a:tc>
+              </a:tr>
+              <a:tr h="475488">
+                <a:tc>
+                  <a:txBody>
+                    <a:bodyPr/>
+                    <a:lstStyle/>
+                    <a:p>
+                      <a:r>
+                        <a:rPr sz="1300" b="0">
+                          <a:solidFill>
+                            <a:srgbClr val="1A1A1A"/>
+                          </a:solidFill>
+                          <a:latin typeface="Calibri"/>
+                        </a:rPr>
+                        <a:t>Rubik's cube 3x3x3</a:t>
+                      </a:r>
+                    </a:p>
+                  </a:txBody>
+                  <a:tcPr>
+                    <a:solidFill>
+                      <a:srgbClr val="FFFFFF"/>
+                    </a:solidFill>
+                  </a:tcPr>
+                </a:tc>
+                <a:tc>
+                  <a:txBody>
+                    <a:bodyPr/>
+                    <a:lstStyle/>
+                    <a:p>
+                      <a:r>
+                        <a:rPr sz="1300" b="0">
+                          <a:solidFill>
+                            <a:srgbClr val="1A1A1A"/>
+                          </a:solidFill>
+                          <a:latin typeface="Calibri"/>
+                        </a:rPr>
+                        <a:t>About 4.3 x 10^19 states</a:t>
+                      </a:r>
+                    </a:p>
+                  </a:txBody>
+                  <a:tcPr>
+                    <a:solidFill>
+                      <a:srgbClr val="FFFFFF"/>
+                    </a:solidFill>
+                  </a:tcPr>
+                </a:tc>
+                <a:tc>
+                  <a:txBody>
+                    <a:bodyPr/>
+                    <a:lstStyle/>
+                    <a:p>
+                      <a:r>
+                        <a:rPr sz="1300" b="0">
+                          <a:solidFill>
+                            <a:srgbClr val="1A1A1A"/>
+                          </a:solidFill>
+                          <a:latin typeface="Calibri"/>
+                        </a:rPr>
+                        <a:t>Cubie invariants (guards the start)</a:t>
+                      </a:r>
+                    </a:p>
+                  </a:txBody>
+                  <a:tcPr>
+                    <a:solidFill>
+                      <a:srgbClr val="FFFFFF"/>
+                    </a:solidFill>
+                  </a:tcPr>
+                </a:tc>
+                <a:tc>
+                  <a:txBody>
+                    <a:bodyPr/>
+                    <a:lstStyle/>
+                    <a:p>
+                      <a:r>
+                        <a:rPr sz="1300" b="0">
+                          <a:solidFill>
+                            <a:srgbClr val="1A1A1A"/>
+                          </a:solidFill>
+                          <a:latin typeface="Calibri"/>
+                        </a:rPr>
+                        <a:t>Meet in the middle</a:t>
+                      </a:r>
+                    </a:p>
+                  </a:txBody>
+                  <a:tcPr>
+                    <a:solidFill>
+                      <a:srgbClr val="FFFFFF"/>
                     </a:solidFill>
                   </a:tcPr>
                 </a:tc>
@@ -9612,8 +12123,8 @@
         </p:nvSpPr>
         <p:spPr>
           <a:xfrm>
-            <a:off x="548640" y="5486400"/>
-            <a:ext cx="11064240" cy="914400"/>
+            <a:off x="548640" y="5760720"/>
+            <a:ext cx="11064240" cy="731520"/>
           </a:xfrm>
           <a:prstGeom prst="rect">
             <a:avLst/>
@@ -9632,13 +12143,13 @@
               </a:spcAft>
             </a:pPr>
             <a:r>
-              <a:rPr sz="1600" b="0">
+              <a:rPr sz="1500" b="0">
                 <a:solidFill>
                   <a:srgbClr val="5A5A5A"/>
                 </a:solidFill>
                 <a:latin typeface="Calibri"/>
               </a:rPr>
-              <a:t>About 1,600 lines in src/tape, 1,050 in experiments, 750 in tests. 66 automated tests pass. Code: github.com/Harsh-v69/MachineLearningCP</a:t>
+              <a:t>No language model is used anywhere. Proposers are programs: noisy walks, weighted A*, DFS, or a meet in the middle search.</a:t>
             </a:r>
           </a:p>
         </p:txBody>
@@ -9695,7 +12206,7 @@
                 </a:solidFill>
                 <a:latin typeface="Calibri"/>
               </a:rPr>
-              <a:t>Coding: Key Components</a:t>
+              <a:t>Coding Progress</a:t>
             </a:r>
           </a:p>
         </p:txBody>
@@ -9743,8 +12254,8 @@
         </p:nvSpPr>
         <p:spPr>
           <a:xfrm>
-            <a:off x="548640" y="1325880"/>
-            <a:ext cx="5486400" cy="457200"/>
+            <a:off x="548640" y="1115568"/>
+            <a:ext cx="10972800" cy="457200"/>
           </a:xfrm>
           <a:prstGeom prst="rect">
             <a:avLst/>
@@ -9763,27 +12274,530 @@
               </a:spcAft>
             </a:pPr>
             <a:r>
-              <a:rPr sz="1800" b="1">
-                <a:solidFill>
-                  <a:srgbClr val="1F4FC8"/>
-                </a:solidFill>
-                <a:latin typeface="Calibri"/>
-              </a:rPr>
-              <a:t>Validator, Sokoban (simplified)</a:t>
+              <a:rPr sz="1600" b="0">
+                <a:solidFill>
+                  <a:srgbClr val="5A5A5A"/>
+                </a:solidFill>
+                <a:latin typeface="Calibri"/>
+              </a:rPr>
+              <a:t>Target for this review: 40%. Completed: all five pipeline phases, the evaluation experiments and an interactive demo.</a:t>
             </a:r>
           </a:p>
         </p:txBody>
       </p:sp>
+      <p:graphicFrame>
+        <p:nvGraphicFramePr>
+          <p:cNvPr id="5" name="Table 4"/>
+          <p:cNvGraphicFramePr>
+            <a:graphicFrameLocks noGrp="1"/>
+          </p:cNvGraphicFramePr>
+          <p:nvPr/>
+        </p:nvGraphicFramePr>
+        <p:xfrm>
+          <a:off x="548640" y="1737360"/>
+          <a:ext cx="11064240" cy="3520440"/>
+        </p:xfrm>
+        <a:graphic>
+          <a:graphicData uri="http://schemas.openxmlformats.org/drawingml/2006/table">
+            <a:tbl>
+              <a:tblPr firstRow="1" bandRow="1">
+                <a:tableStyleId>{5C22544A-7EE6-4342-B048-85BDC9FD1C3A}</a:tableStyleId>
+              </a:tblPr>
+              <a:tblGrid>
+                <a:gridCol w="2743200"/>
+                <a:gridCol w="6675120"/>
+                <a:gridCol w="1645920"/>
+              </a:tblGrid>
+              <a:tr h="502920">
+                <a:tc>
+                  <a:txBody>
+                    <a:bodyPr/>
+                    <a:lstStyle/>
+                    <a:p>
+                      <a:r>
+                        <a:rPr sz="1500" b="1">
+                          <a:solidFill>
+                            <a:srgbClr val="FFFFFF"/>
+                          </a:solidFill>
+                          <a:latin typeface="Calibri"/>
+                        </a:rPr>
+                        <a:t>Phase</a:t>
+                      </a:r>
+                    </a:p>
+                  </a:txBody>
+                  <a:tcPr>
+                    <a:solidFill>
+                      <a:srgbClr val="1F4FC8"/>
+                    </a:solidFill>
+                  </a:tcPr>
+                </a:tc>
+                <a:tc>
+                  <a:txBody>
+                    <a:bodyPr/>
+                    <a:lstStyle/>
+                    <a:p>
+                      <a:r>
+                        <a:rPr sz="1500" b="1">
+                          <a:solidFill>
+                            <a:srgbClr val="FFFFFF"/>
+                          </a:solidFill>
+                          <a:latin typeface="Calibri"/>
+                        </a:rPr>
+                        <a:t>What was coded</a:t>
+                      </a:r>
+                    </a:p>
+                  </a:txBody>
+                  <a:tcPr>
+                    <a:solidFill>
+                      <a:srgbClr val="1F4FC8"/>
+                    </a:solidFill>
+                  </a:tcPr>
+                </a:tc>
+                <a:tc>
+                  <a:txBody>
+                    <a:bodyPr/>
+                    <a:lstStyle/>
+                    <a:p>
+                      <a:r>
+                        <a:rPr sz="1500" b="1">
+                          <a:solidFill>
+                            <a:srgbClr val="FFFFFF"/>
+                          </a:solidFill>
+                          <a:latin typeface="Calibri"/>
+                        </a:rPr>
+                        <a:t>Status</a:t>
+                      </a:r>
+                    </a:p>
+                  </a:txBody>
+                  <a:tcPr>
+                    <a:solidFill>
+                      <a:srgbClr val="1F4FC8"/>
+                    </a:solidFill>
+                  </a:tcPr>
+                </a:tc>
+              </a:tr>
+              <a:tr h="502920">
+                <a:tc>
+                  <a:txBody>
+                    <a:bodyPr/>
+                    <a:lstStyle/>
+                    <a:p>
+                      <a:r>
+                        <a:rPr sz="1500" b="0">
+                          <a:solidFill>
+                            <a:srgbClr val="1A1A1A"/>
+                          </a:solidFill>
+                          <a:latin typeface="Calibri"/>
+                        </a:rPr>
+                        <a:t>1  TAPE baseline</a:t>
+                      </a:r>
+                    </a:p>
+                  </a:txBody>
+                  <a:tcPr>
+                    <a:solidFill>
+                      <a:srgbClr val="FFFFFF"/>
+                    </a:solidFill>
+                  </a:tcPr>
+                </a:tc>
+                <a:tc>
+                  <a:txBody>
+                    <a:bodyPr/>
+                    <a:lstStyle/>
+                    <a:p>
+                      <a:r>
+                        <a:rPr sz="1500" b="0">
+                          <a:solidFill>
+                            <a:srgbClr val="1A1A1A"/>
+                          </a:solidFill>
+                          <a:latin typeface="Calibri"/>
+                        </a:rPr>
+                        <a:t>Environment interface, plan graph, CP-SAT solver, constrained execution, replanning</a:t>
+                      </a:r>
+                    </a:p>
+                  </a:txBody>
+                  <a:tcPr>
+                    <a:solidFill>
+                      <a:srgbClr val="FFFFFF"/>
+                    </a:solidFill>
+                  </a:tcPr>
+                </a:tc>
+                <a:tc>
+                  <a:txBody>
+                    <a:bodyPr/>
+                    <a:lstStyle/>
+                    <a:p>
+                      <a:r>
+                        <a:rPr sz="1500" b="0">
+                          <a:solidFill>
+                            <a:srgbClr val="1A1A1A"/>
+                          </a:solidFill>
+                          <a:latin typeface="Calibri"/>
+                        </a:rPr>
+                        <a:t>Done</a:t>
+                      </a:r>
+                    </a:p>
+                  </a:txBody>
+                  <a:tcPr>
+                    <a:solidFill>
+                      <a:srgbClr val="FFFFFF"/>
+                    </a:solidFill>
+                  </a:tcPr>
+                </a:tc>
+              </a:tr>
+              <a:tr h="502920">
+                <a:tc>
+                  <a:txBody>
+                    <a:bodyPr/>
+                    <a:lstStyle/>
+                    <a:p>
+                      <a:r>
+                        <a:rPr sz="1500" b="0">
+                          <a:solidFill>
+                            <a:srgbClr val="1A1A1A"/>
+                          </a:solidFill>
+                          <a:latin typeface="Calibri"/>
+                        </a:rPr>
+                        <a:t>2  Graph validation</a:t>
+                      </a:r>
+                    </a:p>
+                  </a:txBody>
+                  <a:tcPr>
+                    <a:solidFill>
+                      <a:srgbClr val="F6F6F6"/>
+                    </a:solidFill>
+                  </a:tcPr>
+                </a:tc>
+                <a:tc>
+                  <a:txBody>
+                    <a:bodyPr/>
+                    <a:lstStyle/>
+                    <a:p>
+                      <a:r>
+                        <a:rPr sz="1500" b="0">
+                          <a:solidFill>
+                            <a:srgbClr val="1A1A1A"/>
+                          </a:solidFill>
+                          <a:latin typeface="Calibri"/>
+                        </a:rPr>
+                        <a:t>Rule checkers for every game: corners, safety, gridlock, pagoda bound, parity, cubie invariants</a:t>
+                      </a:r>
+                    </a:p>
+                  </a:txBody>
+                  <a:tcPr>
+                    <a:solidFill>
+                      <a:srgbClr val="F6F6F6"/>
+                    </a:solidFill>
+                  </a:tcPr>
+                </a:tc>
+                <a:tc>
+                  <a:txBody>
+                    <a:bodyPr/>
+                    <a:lstStyle/>
+                    <a:p>
+                      <a:r>
+                        <a:rPr sz="1500" b="0">
+                          <a:solidFill>
+                            <a:srgbClr val="1A1A1A"/>
+                          </a:solidFill>
+                          <a:latin typeface="Calibri"/>
+                        </a:rPr>
+                        <a:t>Done</a:t>
+                      </a:r>
+                    </a:p>
+                  </a:txBody>
+                  <a:tcPr>
+                    <a:solidFill>
+                      <a:srgbClr val="F6F6F6"/>
+                    </a:solidFill>
+                  </a:tcPr>
+                </a:tc>
+              </a:tr>
+              <a:tr h="502920">
+                <a:tc>
+                  <a:txBody>
+                    <a:bodyPr/>
+                    <a:lstStyle/>
+                    <a:p>
+                      <a:r>
+                        <a:rPr sz="1500" b="0">
+                          <a:solidFill>
+                            <a:srgbClr val="1A1A1A"/>
+                          </a:solidFill>
+                          <a:latin typeface="Calibri"/>
+                        </a:rPr>
+                        <a:t>3  Self-improving graph</a:t>
+                      </a:r>
+                    </a:p>
+                  </a:txBody>
+                  <a:tcPr>
+                    <a:solidFill>
+                      <a:srgbClr val="FFFFFF"/>
+                    </a:solidFill>
+                  </a:tcPr>
+                </a:tc>
+                <a:tc>
+                  <a:txBody>
+                    <a:bodyPr/>
+                    <a:lstStyle/>
+                    <a:p>
+                      <a:r>
+                        <a:rPr sz="1500" b="0">
+                          <a:solidFill>
+                            <a:srgbClr val="1A1A1A"/>
+                          </a:solidFill>
+                          <a:latin typeface="Calibri"/>
+                        </a:rPr>
+                        <a:t>SQLite experience store with smoothed confidence</a:t>
+                      </a:r>
+                    </a:p>
+                  </a:txBody>
+                  <a:tcPr>
+                    <a:solidFill>
+                      <a:srgbClr val="FFFFFF"/>
+                    </a:solidFill>
+                  </a:tcPr>
+                </a:tc>
+                <a:tc>
+                  <a:txBody>
+                    <a:bodyPr/>
+                    <a:lstStyle/>
+                    <a:p>
+                      <a:r>
+                        <a:rPr sz="1500" b="0">
+                          <a:solidFill>
+                            <a:srgbClr val="1A1A1A"/>
+                          </a:solidFill>
+                          <a:latin typeface="Calibri"/>
+                        </a:rPr>
+                        <a:t>Done</a:t>
+                      </a:r>
+                    </a:p>
+                  </a:txBody>
+                  <a:tcPr>
+                    <a:solidFill>
+                      <a:srgbClr val="FFFFFF"/>
+                    </a:solidFill>
+                  </a:tcPr>
+                </a:tc>
+              </a:tr>
+              <a:tr h="502920">
+                <a:tc>
+                  <a:txBody>
+                    <a:bodyPr/>
+                    <a:lstStyle/>
+                    <a:p>
+                      <a:r>
+                        <a:rPr sz="1500" b="0">
+                          <a:solidFill>
+                            <a:srgbClr val="1A1A1A"/>
+                          </a:solidFill>
+                          <a:latin typeface="Calibri"/>
+                        </a:rPr>
+                        <a:t>4  Dynamic score</a:t>
+                      </a:r>
+                    </a:p>
+                  </a:txBody>
+                  <a:tcPr>
+                    <a:solidFill>
+                      <a:srgbClr val="F6F6F6"/>
+                    </a:solidFill>
+                  </a:tcPr>
+                </a:tc>
+                <a:tc>
+                  <a:txBody>
+                    <a:bodyPr/>
+                    <a:lstStyle/>
+                    <a:p>
+                      <a:r>
+                        <a:rPr sz="1500" b="0">
+                          <a:solidFill>
+                            <a:srgbClr val="1A1A1A"/>
+                          </a:solidFill>
+                          <a:latin typeface="Calibri"/>
+                        </a:rPr>
+                        <a:t>Per-move cost from progress, confidence and budget</a:t>
+                      </a:r>
+                    </a:p>
+                  </a:txBody>
+                  <a:tcPr>
+                    <a:solidFill>
+                      <a:srgbClr val="F6F6F6"/>
+                    </a:solidFill>
+                  </a:tcPr>
+                </a:tc>
+                <a:tc>
+                  <a:txBody>
+                    <a:bodyPr/>
+                    <a:lstStyle/>
+                    <a:p>
+                      <a:r>
+                        <a:rPr sz="1500" b="0">
+                          <a:solidFill>
+                            <a:srgbClr val="1A1A1A"/>
+                          </a:solidFill>
+                          <a:latin typeface="Calibri"/>
+                        </a:rPr>
+                        <a:t>Done</a:t>
+                      </a:r>
+                    </a:p>
+                  </a:txBody>
+                  <a:tcPr>
+                    <a:solidFill>
+                      <a:srgbClr val="F6F6F6"/>
+                    </a:solidFill>
+                  </a:tcPr>
+                </a:tc>
+              </a:tr>
+              <a:tr h="502920">
+                <a:tc>
+                  <a:txBody>
+                    <a:bodyPr/>
+                    <a:lstStyle/>
+                    <a:p>
+                      <a:r>
+                        <a:rPr sz="1500" b="0">
+                          <a:solidFill>
+                            <a:srgbClr val="1A1A1A"/>
+                          </a:solidFill>
+                          <a:latin typeface="Calibri"/>
+                        </a:rPr>
+                        <a:t>5  Adaptive selection</a:t>
+                      </a:r>
+                    </a:p>
+                  </a:txBody>
+                  <a:tcPr>
+                    <a:solidFill>
+                      <a:srgbClr val="FFFFFF"/>
+                    </a:solidFill>
+                  </a:tcPr>
+                </a:tc>
+                <a:tc>
+                  <a:txBody>
+                    <a:bodyPr/>
+                    <a:lstStyle/>
+                    <a:p>
+                      <a:r>
+                        <a:rPr sz="1500" b="0">
+                          <a:solidFill>
+                            <a:srgbClr val="1A1A1A"/>
+                          </a:solidFill>
+                          <a:latin typeface="Calibri"/>
+                        </a:rPr>
+                        <a:t>A* and CP-SAT, chosen by task complexity</a:t>
+                      </a:r>
+                    </a:p>
+                  </a:txBody>
+                  <a:tcPr>
+                    <a:solidFill>
+                      <a:srgbClr val="FFFFFF"/>
+                    </a:solidFill>
+                  </a:tcPr>
+                </a:tc>
+                <a:tc>
+                  <a:txBody>
+                    <a:bodyPr/>
+                    <a:lstStyle/>
+                    <a:p>
+                      <a:r>
+                        <a:rPr sz="1500" b="0">
+                          <a:solidFill>
+                            <a:srgbClr val="1A1A1A"/>
+                          </a:solidFill>
+                          <a:latin typeface="Calibri"/>
+                        </a:rPr>
+                        <a:t>Done</a:t>
+                      </a:r>
+                    </a:p>
+                  </a:txBody>
+                  <a:tcPr>
+                    <a:solidFill>
+                      <a:srgbClr val="FFFFFF"/>
+                    </a:solidFill>
+                  </a:tcPr>
+                </a:tc>
+              </a:tr>
+              <a:tr h="502920">
+                <a:tc>
+                  <a:txBody>
+                    <a:bodyPr/>
+                    <a:lstStyle/>
+                    <a:p>
+                      <a:r>
+                        <a:rPr sz="1500" b="0">
+                          <a:solidFill>
+                            <a:srgbClr val="1A1A1A"/>
+                          </a:solidFill>
+                          <a:latin typeface="Calibri"/>
+                        </a:rPr>
+                        <a:t>6  Evaluation</a:t>
+                      </a:r>
+                    </a:p>
+                  </a:txBody>
+                  <a:tcPr>
+                    <a:solidFill>
+                      <a:srgbClr val="F6F6F6"/>
+                    </a:solidFill>
+                  </a:tcPr>
+                </a:tc>
+                <a:tc>
+                  <a:txBody>
+                    <a:bodyPr/>
+                    <a:lstStyle/>
+                    <a:p>
+                      <a:r>
+                        <a:rPr sz="1500" b="0">
+                          <a:solidFill>
+                            <a:srgbClr val="1A1A1A"/>
+                          </a:solidFill>
+                          <a:latin typeface="Calibri"/>
+                        </a:rPr>
+                        <a:t>Ablation, memory, tuning, proposer sweep, Boxoban, three harder games, search methods</a:t>
+                      </a:r>
+                    </a:p>
+                  </a:txBody>
+                  <a:tcPr>
+                    <a:solidFill>
+                      <a:srgbClr val="F6F6F6"/>
+                    </a:solidFill>
+                  </a:tcPr>
+                </a:tc>
+                <a:tc>
+                  <a:txBody>
+                    <a:bodyPr/>
+                    <a:lstStyle/>
+                    <a:p>
+                      <a:r>
+                        <a:rPr sz="1500" b="0">
+                          <a:solidFill>
+                            <a:srgbClr val="1A1A1A"/>
+                          </a:solidFill>
+                          <a:latin typeface="Calibri"/>
+                        </a:rPr>
+                        <a:t>Core done</a:t>
+                      </a:r>
+                    </a:p>
+                  </a:txBody>
+                  <a:tcPr>
+                    <a:solidFill>
+                      <a:srgbClr val="F6F6F6"/>
+                    </a:solidFill>
+                  </a:tcPr>
+                </a:tc>
+              </a:tr>
+            </a:tbl>
+          </a:graphicData>
+        </a:graphic>
+      </p:graphicFrame>
       <p:sp>
         <p:nvSpPr>
-          <p:cNvPr id="5" name="TextBox 4"/>
+          <p:cNvPr id="6" name="TextBox 5"/>
           <p:cNvSpPr txBox="1"/>
           <p:nvPr/>
         </p:nvSpPr>
         <p:spPr>
           <a:xfrm>
-            <a:off x="548640" y="1783080"/>
-            <a:ext cx="5486400" cy="4206240"/>
+            <a:off x="548640" y="5486400"/>
+            <a:ext cx="11064240" cy="914400"/>
           </a:xfrm>
           <a:prstGeom prst="rect">
             <a:avLst/>
@@ -9802,331 +12816,13 @@
               </a:spcAft>
             </a:pPr>
             <a:r>
-              <a:rPr sz="1400" b="0">
-                <a:solidFill>
-                  <a:srgbClr val="1A1A1A"/>
-                </a:solidFill>
-                <a:latin typeface="Consolas"/>
-              </a:rPr>
-              <a:t>for box in moved_boxes:</a:t>
-            </a:r>
-          </a:p>
-          <a:p>
-            <a:pPr>
-              <a:spcAft>
-                <a:spcPts val="600"/>
-              </a:spcAft>
-            </a:pPr>
-            <a:r>
-              <a:rPr sz="1400" b="0">
-                <a:solidFill>
-                  <a:srgbClr val="1A1A1A"/>
-                </a:solidFill>
-                <a:latin typeface="Consolas"/>
-              </a:rPr>
-              <a:t>    if box in goals: continue</a:t>
-            </a:r>
-          </a:p>
-          <a:p>
-            <a:pPr>
-              <a:spcAft>
-                <a:spcPts val="600"/>
-              </a:spcAft>
-            </a:pPr>
-            <a:r>
-              <a:rPr sz="1400" b="0">
-                <a:solidFill>
-                  <a:srgbClr val="1A1A1A"/>
-                </a:solidFill>
-                <a:latin typeface="Consolas"/>
-              </a:rPr>
-              <a:t>    if is_corner(box):</a:t>
-            </a:r>
-          </a:p>
-          <a:p>
-            <a:pPr>
-              <a:spcAft>
-                <a:spcPts val="600"/>
-              </a:spcAft>
-            </a:pPr>
-            <a:r>
-              <a:rPr sz="1400" b="0">
-                <a:solidFill>
-                  <a:srgbClr val="1A1A1A"/>
-                </a:solidFill>
-                <a:latin typeface="Consolas"/>
-              </a:rPr>
-              <a:t>        return reject("corner deadlock")</a:t>
-            </a:r>
-          </a:p>
-          <a:p>
-            <a:pPr>
-              <a:spcAft>
-                <a:spcPts val="600"/>
-              </a:spcAft>
-            </a:pPr>
-            <a:r>
-              <a:rPr sz="1400" b="0">
-                <a:solidFill>
-                  <a:srgbClr val="1A1A1A"/>
-                </a:solidFill>
-                <a:latin typeface="Consolas"/>
-              </a:rPr>
-              <a:t>    if against_wall(box):</a:t>
-            </a:r>
-          </a:p>
-          <a:p>
-            <a:pPr>
-              <a:spcAft>
-                <a:spcPts val="600"/>
-              </a:spcAft>
-            </a:pPr>
-            <a:r>
-              <a:rPr sz="1400" b="0">
-                <a:solidFill>
-                  <a:srgbClr val="1A1A1A"/>
-                </a:solidFill>
-                <a:latin typeface="Consolas"/>
-              </a:rPr>
-              <a:t>        return accept(conf=0.5)</a:t>
-            </a:r>
-          </a:p>
-          <a:p>
-            <a:pPr>
-              <a:spcAft>
-                <a:spcPts val="600"/>
-              </a:spcAft>
-            </a:pPr>
-            <a:r>
-              <a:rPr sz="1400" b="0">
-                <a:solidFill>
-                  <a:srgbClr val="1A1A1A"/>
-                </a:solidFill>
-                <a:latin typeface="Consolas"/>
-              </a:rPr>
-              <a:t>return accept(conf=1.0)</a:t>
-            </a:r>
-          </a:p>
-          <a:p>
-            <a:pPr>
-              <a:spcAft>
-                <a:spcPts val="600"/>
-              </a:spcAft>
-            </a:pPr>
-            <a:r>
-              <a:rPr sz="800" b="0">
-                <a:solidFill>
-                  <a:srgbClr val="1A1A1A"/>
-                </a:solidFill>
-                <a:latin typeface="Calibri"/>
-              </a:rPr>
-              <a:t/>
-            </a:r>
-          </a:p>
-          <a:p>
-            <a:pPr>
-              <a:spcAft>
-                <a:spcPts val="600"/>
-              </a:spcAft>
-            </a:pPr>
-            <a:r>
               <a:rPr sz="1600" b="0">
                 <a:solidFill>
                   <a:srgbClr val="5A5A5A"/>
                 </a:solidFill>
                 <a:latin typeface="Calibri"/>
               </a:rPr>
-              <a:t>Rejected moves never enter the plan graph. Doubtful moves stay in, but cost more.</a:t>
-            </a:r>
-          </a:p>
-        </p:txBody>
-      </p:sp>
-      <p:sp>
-        <p:nvSpPr>
-          <p:cNvPr id="6" name="TextBox 5"/>
-          <p:cNvSpPr txBox="1"/>
-          <p:nvPr/>
-        </p:nvSpPr>
-        <p:spPr>
-          <a:xfrm>
-            <a:off x="6309360" y="1325880"/>
-            <a:ext cx="5303520" cy="457200"/>
-          </a:xfrm>
-          <a:prstGeom prst="rect">
-            <a:avLst/>
-          </a:prstGeom>
-          <a:noFill/>
-        </p:spPr>
-        <p:txBody>
-          <a:bodyPr wrap="square">
-            <a:spAutoFit/>
-          </a:bodyPr>
-          <a:lstStyle/>
-          <a:p>
-            <a:pPr>
-              <a:spcAft>
-                <a:spcPts val="600"/>
-              </a:spcAft>
-            </a:pPr>
-            <a:r>
-              <a:rPr sz="1800" b="1">
-                <a:solidFill>
-                  <a:srgbClr val="1F4FC8"/>
-                </a:solidFill>
-                <a:latin typeface="Calibri"/>
-              </a:rPr>
-              <a:t>Adaptive solver choice (simplified)</a:t>
-            </a:r>
-          </a:p>
-        </p:txBody>
-      </p:sp>
-      <p:sp>
-        <p:nvSpPr>
-          <p:cNvPr id="7" name="TextBox 6"/>
-          <p:cNvSpPr txBox="1"/>
-          <p:nvPr/>
-        </p:nvSpPr>
-        <p:spPr>
-          <a:xfrm>
-            <a:off x="6309360" y="1783080"/>
-            <a:ext cx="5303520" cy="4206240"/>
-          </a:xfrm>
-          <a:prstGeom prst="rect">
-            <a:avLst/>
-          </a:prstGeom>
-          <a:noFill/>
-        </p:spPr>
-        <p:txBody>
-          <a:bodyPr wrap="square">
-            <a:spAutoFit/>
-          </a:bodyPr>
-          <a:lstStyle/>
-          <a:p>
-            <a:pPr>
-              <a:spcAft>
-                <a:spcPts val="600"/>
-              </a:spcAft>
-            </a:pPr>
-            <a:r>
-              <a:rPr sz="1400" b="0">
-                <a:solidFill>
-                  <a:srgbClr val="1A1A1A"/>
-                </a:solidFill>
-                <a:latin typeface="Consolas"/>
-              </a:rPr>
-              <a:t>def decide_method(level, graph):</a:t>
-            </a:r>
-          </a:p>
-          <a:p>
-            <a:pPr>
-              <a:spcAft>
-                <a:spcPts val="600"/>
-              </a:spcAft>
-            </a:pPr>
-            <a:r>
-              <a:rPr sz="1400" b="0">
-                <a:solidFill>
-                  <a:srgbClr val="1A1A1A"/>
-                </a:solidFill>
-                <a:latin typeface="Consolas"/>
-              </a:rPr>
-              <a:t>    if level.complexity(graph.start) &gt; 1:</a:t>
-            </a:r>
-          </a:p>
-          <a:p>
-            <a:pPr>
-              <a:spcAft>
-                <a:spcPts val="600"/>
-              </a:spcAft>
-            </a:pPr>
-            <a:r>
-              <a:rPr sz="1400" b="0">
-                <a:solidFill>
-                  <a:srgbClr val="1A1A1A"/>
-                </a:solidFill>
-                <a:latin typeface="Consolas"/>
-              </a:rPr>
-              <a:t>        return CP_SAT</a:t>
-            </a:r>
-          </a:p>
-          <a:p>
-            <a:pPr>
-              <a:spcAft>
-                <a:spcPts val="600"/>
-              </a:spcAft>
-            </a:pPr>
-            <a:r>
-              <a:rPr sz="1400" b="0">
-                <a:solidFill>
-                  <a:srgbClr val="1A1A1A"/>
-                </a:solidFill>
-                <a:latin typeface="Consolas"/>
-              </a:rPr>
-              <a:t>    return ASTAR</a:t>
-            </a:r>
-          </a:p>
-          <a:p>
-            <a:pPr>
-              <a:spcAft>
-                <a:spcPts val="600"/>
-              </a:spcAft>
-            </a:pPr>
-            <a:r>
-              <a:rPr sz="800" b="0">
-                <a:solidFill>
-                  <a:srgbClr val="1A1A1A"/>
-                </a:solidFill>
-                <a:latin typeface="Calibri"/>
-              </a:rPr>
-              <a:t/>
-            </a:r>
-          </a:p>
-          <a:p>
-            <a:pPr>
-              <a:spcAft>
-                <a:spcPts val="600"/>
-              </a:spcAft>
-            </a:pPr>
-            <a:r>
-              <a:rPr sz="1600" b="0">
-                <a:solidFill>
-                  <a:srgbClr val="5A5A5A"/>
-                </a:solidFill>
-                <a:latin typeface="Calibri"/>
-              </a:rPr>
-              <a:t>Every game implements one interface: ACTIONS, step, is_goal, heuristic, complexity, render. A new game plugs in without touching the pipeline.</a:t>
-            </a:r>
-          </a:p>
-          <a:p>
-            <a:pPr>
-              <a:spcAft>
-                <a:spcPts val="600"/>
-              </a:spcAft>
-            </a:pPr>
-            <a:r>
-              <a:rPr sz="800" b="0">
-                <a:solidFill>
-                  <a:srgbClr val="1A1A1A"/>
-                </a:solidFill>
-                <a:latin typeface="Calibri"/>
-              </a:rPr>
-              <a:t/>
-            </a:r>
-          </a:p>
-          <a:p>
-            <a:pPr>
-              <a:spcAft>
-                <a:spcPts val="600"/>
-              </a:spcAft>
-            </a:pPr>
-            <a:r>
-              <a:rPr sz="1600" b="0">
-                <a:solidFill>
-                  <a:srgbClr val="5A5A5A"/>
-                </a:solidFill>
-                <a:latin typeface="Calibri"/>
-              </a:rPr>
-              <a:t>Benchmarks: Sokoban (4 levels), River Crossing, Rush Hour, Boxoban (3,000 real levels).</a:t>
+              <a:t>About 2,300 lines in src/tape, 1,500 in experiments, 1,000 in tests. 90 automated tests pass. Interactive demo with a tab per game and a 3D Rubik's cube. Code: github.com/Harsh-v69/MachineLearningCP</a:t>
             </a:r>
           </a:p>
         </p:txBody>

</xml_diff>

<commit_message>
Review deck: interactive demo slide and slip-vs-wrong-move failure handling slide
Co-Authored-By: Claude Sonnet 5.5 <noreply@anthropic.com>
</commit_message>
<xml_diff>
--- a/docs/CP_Project_Review.pptx
+++ b/docs/CP_Project_Review.pptx
@@ -22,6 +22,8 @@
     <p:sldId id="270" r:id="rId21"/>
     <p:sldId id="271" r:id="rId22"/>
     <p:sldId id="272" r:id="rId23"/>
+    <p:sldId id="273" r:id="rId24"/>
+    <p:sldId id="274" r:id="rId25"/>
   </p:sldIdLst>
   <p:sldSz cx="12191695" cy="6858000" type="screen4x3"/>
   <p:notesSz cx="6858000" cy="9144000"/>
@@ -3935,7 +3937,7 @@
                 </a:solidFill>
                 <a:latin typeface="Calibri"/>
               </a:rPr>
-              <a:t>Results and Discussion: Safety and Speed</a:t>
+              <a:t>Interactive Demo</a:t>
             </a:r>
           </a:p>
         </p:txBody>
@@ -4009,598 +4011,21 @@
                 </a:solidFill>
                 <a:latin typeface="Calibri"/>
               </a:rPr>
-              <a:t>Ablation, 30 episodes per cell, 15% slip, synthetic proposer</a:t>
+              <a:t>A browser walkthrough, generated from live runs of the project code.</a:t>
             </a:r>
           </a:p>
         </p:txBody>
       </p:sp>
-      <p:graphicFrame>
-        <p:nvGraphicFramePr>
-          <p:cNvPr id="5" name="Table 4"/>
-          <p:cNvGraphicFramePr>
-            <a:graphicFrameLocks noGrp="1"/>
-          </p:cNvGraphicFramePr>
-          <p:nvPr/>
-        </p:nvGraphicFramePr>
-        <p:xfrm>
-          <a:off x="548640" y="1737360"/>
-          <a:ext cx="5303520" cy="2011680"/>
-        </p:xfrm>
-        <a:graphic>
-          <a:graphicData uri="http://schemas.openxmlformats.org/drawingml/2006/table">
-            <a:tbl>
-              <a:tblPr firstRow="1" bandRow="1">
-                <a:tableStyleId>{5C22544A-7EE6-4342-B048-85BDC9FD1C3A}</a:tableStyleId>
-              </a:tblPr>
-              <a:tblGrid>
-                <a:gridCol w="3291840"/>
-                <a:gridCol w="2011680"/>
-              </a:tblGrid>
-              <a:tr h="502920">
-                <a:tc>
-                  <a:txBody>
-                    <a:bodyPr/>
-                    <a:lstStyle/>
-                    <a:p>
-                      <a:r>
-                        <a:rPr sz="1500" b="1">
-                          <a:solidFill>
-                            <a:srgbClr val="FFFFFF"/>
-                          </a:solidFill>
-                          <a:latin typeface="Calibri"/>
-                        </a:rPr>
-                        <a:t>River Crossing</a:t>
-                      </a:r>
-                    </a:p>
-                  </a:txBody>
-                  <a:tcPr>
-                    <a:solidFill>
-                      <a:srgbClr val="1F4FC8"/>
-                    </a:solidFill>
-                  </a:tcPr>
-                </a:tc>
-                <a:tc>
-                  <a:txBody>
-                    <a:bodyPr/>
-                    <a:lstStyle/>
-                    <a:p>
-                      <a:r>
-                        <a:rPr sz="1500" b="1">
-                          <a:solidFill>
-                            <a:srgbClr val="FFFFFF"/>
-                          </a:solidFill>
-                          <a:latin typeface="Calibri"/>
-                        </a:rPr>
-                        <a:t>Safe success</a:t>
-                      </a:r>
-                    </a:p>
-                  </a:txBody>
-                  <a:tcPr>
-                    <a:solidFill>
-                      <a:srgbClr val="1F4FC8"/>
-                    </a:solidFill>
-                  </a:tcPr>
-                </a:tc>
-              </a:tr>
-              <a:tr h="502920">
-                <a:tc>
-                  <a:txBody>
-                    <a:bodyPr/>
-                    <a:lstStyle/>
-                    <a:p>
-                      <a:r>
-                        <a:rPr sz="1500" b="0">
-                          <a:solidFill>
-                            <a:srgbClr val="1A1A1A"/>
-                          </a:solidFill>
-                          <a:latin typeface="Calibri"/>
-                        </a:rPr>
-                        <a:t>Baseline (no checker)</a:t>
-                      </a:r>
-                    </a:p>
-                  </a:txBody>
-                  <a:tcPr>
-                    <a:solidFill>
-                      <a:srgbClr val="FFFFFF"/>
-                    </a:solidFill>
-                  </a:tcPr>
-                </a:tc>
-                <a:tc>
-                  <a:txBody>
-                    <a:bodyPr/>
-                    <a:lstStyle/>
-                    <a:p>
-                      <a:r>
-                        <a:rPr sz="1500" b="0">
-                          <a:solidFill>
-                            <a:srgbClr val="1A1A1A"/>
-                          </a:solidFill>
-                          <a:latin typeface="Calibri"/>
-                        </a:rPr>
-                        <a:t>0%</a:t>
-                      </a:r>
-                    </a:p>
-                  </a:txBody>
-                  <a:tcPr>
-                    <a:solidFill>
-                      <a:srgbClr val="FFFFFF"/>
-                    </a:solidFill>
-                  </a:tcPr>
-                </a:tc>
-              </a:tr>
-              <a:tr h="502920">
-                <a:tc>
-                  <a:txBody>
-                    <a:bodyPr/>
-                    <a:lstStyle/>
-                    <a:p>
-                      <a:r>
-                        <a:rPr sz="1500" b="0">
-                          <a:solidFill>
-                            <a:srgbClr val="1A1A1A"/>
-                          </a:solidFill>
-                          <a:latin typeface="Calibri"/>
-                        </a:rPr>
-                        <a:t>With validator</a:t>
-                      </a:r>
-                    </a:p>
-                  </a:txBody>
-                  <a:tcPr>
-                    <a:solidFill>
-                      <a:srgbClr val="F6F6F6"/>
-                    </a:solidFill>
-                  </a:tcPr>
-                </a:tc>
-                <a:tc>
-                  <a:txBody>
-                    <a:bodyPr/>
-                    <a:lstStyle/>
-                    <a:p>
-                      <a:r>
-                        <a:rPr sz="1500" b="0">
-                          <a:solidFill>
-                            <a:srgbClr val="1A1A1A"/>
-                          </a:solidFill>
-                          <a:latin typeface="Calibri"/>
-                        </a:rPr>
-                        <a:t>100%</a:t>
-                      </a:r>
-                    </a:p>
-                  </a:txBody>
-                  <a:tcPr>
-                    <a:solidFill>
-                      <a:srgbClr val="F6F6F6"/>
-                    </a:solidFill>
-                  </a:tcPr>
-                </a:tc>
-              </a:tr>
-              <a:tr h="502920">
-                <a:tc>
-                  <a:txBody>
-                    <a:bodyPr/>
-                    <a:lstStyle/>
-                    <a:p>
-                      <a:r>
-                        <a:rPr sz="1500" b="0">
-                          <a:solidFill>
-                            <a:srgbClr val="1A1A1A"/>
-                          </a:solidFill>
-                          <a:latin typeface="Calibri"/>
-                        </a:rPr>
-                        <a:t>Goal reached, baseline</a:t>
-                      </a:r>
-                    </a:p>
-                  </a:txBody>
-                  <a:tcPr>
-                    <a:solidFill>
-                      <a:srgbClr val="FFFFFF"/>
-                    </a:solidFill>
-                  </a:tcPr>
-                </a:tc>
-                <a:tc>
-                  <a:txBody>
-                    <a:bodyPr/>
-                    <a:lstStyle/>
-                    <a:p>
-                      <a:r>
-                        <a:rPr sz="1500" b="0">
-                          <a:solidFill>
-                            <a:srgbClr val="1A1A1A"/>
-                          </a:solidFill>
-                          <a:latin typeface="Calibri"/>
-                        </a:rPr>
-                        <a:t>100% (unsafely)</a:t>
-                      </a:r>
-                    </a:p>
-                  </a:txBody>
-                  <a:tcPr>
-                    <a:solidFill>
-                      <a:srgbClr val="FFFFFF"/>
-                    </a:solidFill>
-                  </a:tcPr>
-                </a:tc>
-              </a:tr>
-            </a:tbl>
-          </a:graphicData>
-        </a:graphic>
-      </p:graphicFrame>
-      <p:graphicFrame>
-        <p:nvGraphicFramePr>
-          <p:cNvPr id="6" name="Table 5"/>
-          <p:cNvGraphicFramePr>
-            <a:graphicFrameLocks noGrp="1"/>
-          </p:cNvGraphicFramePr>
-          <p:nvPr/>
-        </p:nvGraphicFramePr>
-        <p:xfrm>
-          <a:off x="6217920" y="1737360"/>
-          <a:ext cx="5394960" cy="2286000"/>
-        </p:xfrm>
-        <a:graphic>
-          <a:graphicData uri="http://schemas.openxmlformats.org/drawingml/2006/table">
-            <a:tbl>
-              <a:tblPr firstRow="1" bandRow="1">
-                <a:tableStyleId>{5C22544A-7EE6-4342-B048-85BDC9FD1C3A}</a:tableStyleId>
-              </a:tblPr>
-              <a:tblGrid>
-                <a:gridCol w="2468880"/>
-                <a:gridCol w="1554480"/>
-                <a:gridCol w="1371600"/>
-              </a:tblGrid>
-              <a:tr h="457200">
-                <a:tc>
-                  <a:txBody>
-                    <a:bodyPr/>
-                    <a:lstStyle/>
-                    <a:p>
-                      <a:r>
-                        <a:rPr sz="1500" b="1">
-                          <a:solidFill>
-                            <a:srgbClr val="FFFFFF"/>
-                          </a:solidFill>
-                          <a:latin typeface="Calibri"/>
-                        </a:rPr>
-                        <a:t>Planning time (ms)</a:t>
-                      </a:r>
-                    </a:p>
-                  </a:txBody>
-                  <a:tcPr>
-                    <a:solidFill>
-                      <a:srgbClr val="1F4FC8"/>
-                    </a:solidFill>
-                  </a:tcPr>
-                </a:tc>
-                <a:tc>
-                  <a:txBody>
-                    <a:bodyPr/>
-                    <a:lstStyle/>
-                    <a:p>
-                      <a:r>
-                        <a:rPr sz="1500" b="1">
-                          <a:solidFill>
-                            <a:srgbClr val="FFFFFF"/>
-                          </a:solidFill>
-                          <a:latin typeface="Calibri"/>
-                        </a:rPr>
-                        <a:t>Always CP-SAT</a:t>
-                      </a:r>
-                    </a:p>
-                  </a:txBody>
-                  <a:tcPr>
-                    <a:solidFill>
-                      <a:srgbClr val="1F4FC8"/>
-                    </a:solidFill>
-                  </a:tcPr>
-                </a:tc>
-                <a:tc>
-                  <a:txBody>
-                    <a:bodyPr/>
-                    <a:lstStyle/>
-                    <a:p>
-                      <a:r>
-                        <a:rPr sz="1500" b="1">
-                          <a:solidFill>
-                            <a:srgbClr val="FFFFFF"/>
-                          </a:solidFill>
-                          <a:latin typeface="Calibri"/>
-                        </a:rPr>
-                        <a:t>Adaptive</a:t>
-                      </a:r>
-                    </a:p>
-                  </a:txBody>
-                  <a:tcPr>
-                    <a:solidFill>
-                      <a:srgbClr val="1F4FC8"/>
-                    </a:solidFill>
-                  </a:tcPr>
-                </a:tc>
-              </a:tr>
-              <a:tr h="457200">
-                <a:tc>
-                  <a:txBody>
-                    <a:bodyPr/>
-                    <a:lstStyle/>
-                    <a:p>
-                      <a:r>
-                        <a:rPr sz="1500" b="0">
-                          <a:solidFill>
-                            <a:srgbClr val="1A1A1A"/>
-                          </a:solidFill>
-                          <a:latin typeface="Calibri"/>
-                        </a:rPr>
-                        <a:t>Sokoban, 1 box</a:t>
-                      </a:r>
-                    </a:p>
-                  </a:txBody>
-                  <a:tcPr>
-                    <a:solidFill>
-                      <a:srgbClr val="FFFFFF"/>
-                    </a:solidFill>
-                  </a:tcPr>
-                </a:tc>
-                <a:tc>
-                  <a:txBody>
-                    <a:bodyPr/>
-                    <a:lstStyle/>
-                    <a:p>
-                      <a:r>
-                        <a:rPr sz="1500" b="0">
-                          <a:solidFill>
-                            <a:srgbClr val="1A1A1A"/>
-                          </a:solidFill>
-                          <a:latin typeface="Calibri"/>
-                        </a:rPr>
-                        <a:t>51.8</a:t>
-                      </a:r>
-                    </a:p>
-                  </a:txBody>
-                  <a:tcPr>
-                    <a:solidFill>
-                      <a:srgbClr val="FFFFFF"/>
-                    </a:solidFill>
-                  </a:tcPr>
-                </a:tc>
-                <a:tc>
-                  <a:txBody>
-                    <a:bodyPr/>
-                    <a:lstStyle/>
-                    <a:p>
-                      <a:r>
-                        <a:rPr sz="1500" b="0">
-                          <a:solidFill>
-                            <a:srgbClr val="1A1A1A"/>
-                          </a:solidFill>
-                          <a:latin typeface="Calibri"/>
-                        </a:rPr>
-                        <a:t>7.6</a:t>
-                      </a:r>
-                    </a:p>
-                  </a:txBody>
-                  <a:tcPr>
-                    <a:solidFill>
-                      <a:srgbClr val="FFFFFF"/>
-                    </a:solidFill>
-                  </a:tcPr>
-                </a:tc>
-              </a:tr>
-              <a:tr h="457200">
-                <a:tc>
-                  <a:txBody>
-                    <a:bodyPr/>
-                    <a:lstStyle/>
-                    <a:p>
-                      <a:r>
-                        <a:rPr sz="1500" b="0">
-                          <a:solidFill>
-                            <a:srgbClr val="1A1A1A"/>
-                          </a:solidFill>
-                          <a:latin typeface="Calibri"/>
-                        </a:rPr>
-                        <a:t>River Crossing</a:t>
-                      </a:r>
-                    </a:p>
-                  </a:txBody>
-                  <a:tcPr>
-                    <a:solidFill>
-                      <a:srgbClr val="F6F6F6"/>
-                    </a:solidFill>
-                  </a:tcPr>
-                </a:tc>
-                <a:tc>
-                  <a:txBody>
-                    <a:bodyPr/>
-                    <a:lstStyle/>
-                    <a:p>
-                      <a:r>
-                        <a:rPr sz="1500" b="0">
-                          <a:solidFill>
-                            <a:srgbClr val="1A1A1A"/>
-                          </a:solidFill>
-                          <a:latin typeface="Calibri"/>
-                        </a:rPr>
-                        <a:t>62.1</a:t>
-                      </a:r>
-                    </a:p>
-                  </a:txBody>
-                  <a:tcPr>
-                    <a:solidFill>
-                      <a:srgbClr val="F6F6F6"/>
-                    </a:solidFill>
-                  </a:tcPr>
-                </a:tc>
-                <a:tc>
-                  <a:txBody>
-                    <a:bodyPr/>
-                    <a:lstStyle/>
-                    <a:p>
-                      <a:r>
-                        <a:rPr sz="1500" b="0">
-                          <a:solidFill>
-                            <a:srgbClr val="1A1A1A"/>
-                          </a:solidFill>
-                          <a:latin typeface="Calibri"/>
-                        </a:rPr>
-                        <a:t>3.6</a:t>
-                      </a:r>
-                    </a:p>
-                  </a:txBody>
-                  <a:tcPr>
-                    <a:solidFill>
-                      <a:srgbClr val="F6F6F6"/>
-                    </a:solidFill>
-                  </a:tcPr>
-                </a:tc>
-              </a:tr>
-              <a:tr h="457200">
-                <a:tc>
-                  <a:txBody>
-                    <a:bodyPr/>
-                    <a:lstStyle/>
-                    <a:p>
-                      <a:r>
-                        <a:rPr sz="1500" b="0">
-                          <a:solidFill>
-                            <a:srgbClr val="1A1A1A"/>
-                          </a:solidFill>
-                          <a:latin typeface="Calibri"/>
-                        </a:rPr>
-                        <a:t>Sokoban, 2 boxes</a:t>
-                      </a:r>
-                    </a:p>
-                  </a:txBody>
-                  <a:tcPr>
-                    <a:solidFill>
-                      <a:srgbClr val="FFFFFF"/>
-                    </a:solidFill>
-                  </a:tcPr>
-                </a:tc>
-                <a:tc>
-                  <a:txBody>
-                    <a:bodyPr/>
-                    <a:lstStyle/>
-                    <a:p>
-                      <a:r>
-                        <a:rPr sz="1500" b="0">
-                          <a:solidFill>
-                            <a:srgbClr val="1A1A1A"/>
-                          </a:solidFill>
-                          <a:latin typeface="Calibri"/>
-                        </a:rPr>
-                        <a:t>99.9</a:t>
-                      </a:r>
-                    </a:p>
-                  </a:txBody>
-                  <a:tcPr>
-                    <a:solidFill>
-                      <a:srgbClr val="FFFFFF"/>
-                    </a:solidFill>
-                  </a:tcPr>
-                </a:tc>
-                <a:tc>
-                  <a:txBody>
-                    <a:bodyPr/>
-                    <a:lstStyle/>
-                    <a:p>
-                      <a:r>
-                        <a:rPr sz="1500" b="0">
-                          <a:solidFill>
-                            <a:srgbClr val="1A1A1A"/>
-                          </a:solidFill>
-                          <a:latin typeface="Calibri"/>
-                        </a:rPr>
-                        <a:t>96.4</a:t>
-                      </a:r>
-                    </a:p>
-                  </a:txBody>
-                  <a:tcPr>
-                    <a:solidFill>
-                      <a:srgbClr val="FFFFFF"/>
-                    </a:solidFill>
-                  </a:tcPr>
-                </a:tc>
-              </a:tr>
-              <a:tr h="457200">
-                <a:tc>
-                  <a:txBody>
-                    <a:bodyPr/>
-                    <a:lstStyle/>
-                    <a:p>
-                      <a:r>
-                        <a:rPr sz="1500" b="0">
-                          <a:solidFill>
-                            <a:srgbClr val="1A1A1A"/>
-                          </a:solidFill>
-                          <a:latin typeface="Calibri"/>
-                        </a:rPr>
-                        <a:t>Rush Hour</a:t>
-                      </a:r>
-                    </a:p>
-                  </a:txBody>
-                  <a:tcPr>
-                    <a:solidFill>
-                      <a:srgbClr val="F6F6F6"/>
-                    </a:solidFill>
-                  </a:tcPr>
-                </a:tc>
-                <a:tc>
-                  <a:txBody>
-                    <a:bodyPr/>
-                    <a:lstStyle/>
-                    <a:p>
-                      <a:r>
-                        <a:rPr sz="1500" b="0">
-                          <a:solidFill>
-                            <a:srgbClr val="1A1A1A"/>
-                          </a:solidFill>
-                          <a:latin typeface="Calibri"/>
-                        </a:rPr>
-                        <a:t>36.2</a:t>
-                      </a:r>
-                    </a:p>
-                  </a:txBody>
-                  <a:tcPr>
-                    <a:solidFill>
-                      <a:srgbClr val="F6F6F6"/>
-                    </a:solidFill>
-                  </a:tcPr>
-                </a:tc>
-                <a:tc>
-                  <a:txBody>
-                    <a:bodyPr/>
-                    <a:lstStyle/>
-                    <a:p>
-                      <a:r>
-                        <a:rPr sz="1500" b="0">
-                          <a:solidFill>
-                            <a:srgbClr val="1A1A1A"/>
-                          </a:solidFill>
-                          <a:latin typeface="Calibri"/>
-                        </a:rPr>
-                        <a:t>36.1</a:t>
-                      </a:r>
-                    </a:p>
-                  </a:txBody>
-                  <a:tcPr>
-                    <a:solidFill>
-                      <a:srgbClr val="F6F6F6"/>
-                    </a:solidFill>
-                  </a:tcPr>
-                </a:tc>
-              </a:tr>
-            </a:tbl>
-          </a:graphicData>
-        </a:graphic>
-      </p:graphicFrame>
       <p:sp>
         <p:nvSpPr>
-          <p:cNvPr id="7" name="TextBox 6"/>
+          <p:cNvPr id="5" name="TextBox 4"/>
           <p:cNvSpPr txBox="1"/>
           <p:nvPr/>
         </p:nvSpPr>
         <p:spPr>
           <a:xfrm>
-            <a:off x="548640" y="4206240"/>
-            <a:ext cx="11064240" cy="2194560"/>
+            <a:off x="548640" y="1737360"/>
+            <a:ext cx="5669280" cy="4754880"/>
           </a:xfrm>
           <a:prstGeom prst="rect">
             <a:avLst/>
@@ -4619,13 +4044,13 @@
               </a:spcAft>
             </a:pPr>
             <a:r>
-              <a:rPr sz="1800" b="0">
+              <a:rPr sz="1900" b="0">
                 <a:solidFill>
                   <a:srgbClr val="1A1A1A"/>
                 </a:solidFill>
                 <a:latin typeface="Calibri"/>
               </a:rPr>
-              <a:t>•  Safe success means the goal was reached and no move broke a rule, judged by an independent auditor.</a:t>
+              <a:t>•  One tab per game: Sokoban, River Crossing, Rush Hour, Boxoban, Peg Solitaire, 24-puzzle, Rubik's cube.</a:t>
             </a:r>
           </a:p>
           <a:p>
@@ -4635,13 +4060,13 @@
               </a:spcAft>
             </a:pPr>
             <a:r>
-              <a:rPr sz="1800" b="0">
+              <a:rPr sz="1900" b="0">
                 <a:solidFill>
                   <a:srgbClr val="1A1A1A"/>
                 </a:solidFill>
                 <a:latin typeface="Calibri"/>
               </a:rPr>
-              <a:t>•  The validator turns unsafe successes into safe ones. The adaptive solver saves time where one piece moves and ties elsewhere.</a:t>
+              <a:t>•  Every board is 3D and draggable: sliding crates, jumping marbles, sliding tiles, a turning cube.</a:t>
             </a:r>
           </a:p>
           <a:p>
@@ -4651,13 +4076,171 @@
               </a:spcAft>
             </a:pPr>
             <a:r>
-              <a:rPr sz="1800" b="0">
+              <a:rPr sz="1900" b="0">
                 <a:solidFill>
                   <a:srgbClr val="1A1A1A"/>
                 </a:solidFill>
                 <a:latin typeface="Calibri"/>
               </a:rPr>
-              <a:t>•  Hard Sokoban stays near 53% in every configuration: our extensions do not change it.</a:t>
+              <a:t>•  Five steps per game: Propose, Merge, Check, Choose, Run.</a:t>
+            </a:r>
+          </a:p>
+          <a:p>
+            <a:pPr>
+              <a:spcAft>
+                <a:spcPts val="600"/>
+              </a:spcAft>
+            </a:pPr>
+            <a:r>
+              <a:rPr sz="1900" b="0">
+                <a:solidFill>
+                  <a:srgbClr val="1A1A1A"/>
+                </a:solidFill>
+                <a:latin typeface="Calibri"/>
+              </a:rPr>
+              <a:t>•  Light and dark theme, and a project map on the first page.</a:t>
+            </a:r>
+          </a:p>
+        </p:txBody>
+      </p:sp>
+      <p:sp>
+        <p:nvSpPr>
+          <p:cNvPr id="6" name="TextBox 5"/>
+          <p:cNvSpPr txBox="1"/>
+          <p:nvPr/>
+        </p:nvSpPr>
+        <p:spPr>
+          <a:xfrm>
+            <a:off x="6492240" y="1737360"/>
+            <a:ext cx="5120640" cy="457200"/>
+          </a:xfrm>
+          <a:prstGeom prst="rect">
+            <a:avLst/>
+          </a:prstGeom>
+          <a:noFill/>
+        </p:spPr>
+        <p:txBody>
+          <a:bodyPr wrap="square">
+            <a:spAutoFit/>
+          </a:bodyPr>
+          <a:lstStyle/>
+          <a:p>
+            <a:pPr>
+              <a:spcAft>
+                <a:spcPts val="600"/>
+              </a:spcAft>
+            </a:pPr>
+            <a:r>
+              <a:rPr sz="2000" b="1">
+                <a:solidFill>
+                  <a:srgbClr val="1F4FC8"/>
+                </a:solidFill>
+                <a:latin typeface="Calibri"/>
+              </a:rPr>
+              <a:t>Try it yourself</a:t>
+            </a:r>
+          </a:p>
+        </p:txBody>
+      </p:sp>
+      <p:sp>
+        <p:nvSpPr>
+          <p:cNvPr id="7" name="TextBox 6"/>
+          <p:cNvSpPr txBox="1"/>
+          <p:nvPr/>
+        </p:nvSpPr>
+        <p:spPr>
+          <a:xfrm>
+            <a:off x="6492240" y="2286000"/>
+            <a:ext cx="5120640" cy="4206240"/>
+          </a:xfrm>
+          <a:prstGeom prst="rect">
+            <a:avLst/>
+          </a:prstGeom>
+          <a:noFill/>
+        </p:spPr>
+        <p:txBody>
+          <a:bodyPr wrap="square">
+            <a:spAutoFit/>
+          </a:bodyPr>
+          <a:lstStyle/>
+          <a:p>
+            <a:pPr>
+              <a:spcAft>
+                <a:spcPts val="600"/>
+              </a:spcAft>
+            </a:pPr>
+            <a:r>
+              <a:rPr sz="1900" b="0">
+                <a:solidFill>
+                  <a:srgbClr val="1A1A1A"/>
+                </a:solidFill>
+                <a:latin typeface="Calibri"/>
+              </a:rPr>
+              <a:t>•  Check: switch the rule checker on and off and watch the bad plan.</a:t>
+            </a:r>
+          </a:p>
+          <a:p>
+            <a:pPr>
+              <a:spcAft>
+                <a:spcPts val="600"/>
+              </a:spcAft>
+            </a:pPr>
+            <a:r>
+              <a:rPr sz="1900" b="0">
+                <a:solidFill>
+                  <a:srgbClr val="1A1A1A"/>
+                </a:solidFill>
+                <a:latin typeface="Calibri"/>
+              </a:rPr>
+              <a:t>•  Choose: A* and CP-SAT timed on the same graph.</a:t>
+            </a:r>
+          </a:p>
+          <a:p>
+            <a:pPr>
+              <a:spcAft>
+                <a:spcPts val="600"/>
+              </a:spcAft>
+            </a:pPr>
+            <a:r>
+              <a:rPr sz="1900" b="0">
+                <a:solidFill>
+                  <a:srgbClr val="1A1A1A"/>
+                </a:solidFill>
+                <a:latin typeface="Calibri"/>
+              </a:rPr>
+              <a:t>•  Randomize: scramble the Rubik's cube or the 24-puzzle and watch it solve itself, in the browser.</a:t>
+            </a:r>
+          </a:p>
+          <a:p>
+            <a:pPr>
+              <a:spcAft>
+                <a:spcPts val="600"/>
+              </a:spcAft>
+            </a:pPr>
+            <a:r>
+              <a:rPr sz="1900" b="0">
+                <a:solidFill>
+                  <a:srgbClr val="1A1A1A"/>
+                </a:solidFill>
+                <a:latin typeface="Calibri"/>
+              </a:rPr>
+              <a:t>•  Run: a slip, or a wrong move (next slide).</a:t>
+            </a:r>
+          </a:p>
+          <a:p>
+            <a:pPr>
+              <a:spcAft>
+                <a:spcPts val="600"/>
+              </a:spcAft>
+            </a:pPr>
+            <a:r>
+              <a:rPr sz="1900" b="0">
+                <a:solidFill>
+                  <a:srgbClr val="1A1A1A"/>
+                </a:solidFill>
+                <a:latin typeface="Calibri"/>
+              </a:rPr>
+              <a:t>•  Results: every chart is read from the experiment files.</a:t>
             </a:r>
           </a:p>
         </p:txBody>
@@ -4714,7 +4297,7 @@
                 </a:solidFill>
                 <a:latin typeface="Calibri"/>
               </a:rPr>
-              <a:t>Results and Discussion: Boxoban</a:t>
+              <a:t>Failure Handling: Slip vs Wrong Move</a:t>
             </a:r>
           </a:p>
         </p:txBody>
@@ -4788,7 +4371,7 @@
                 </a:solidFill>
                 <a:latin typeface="Calibri"/>
               </a:rPr>
-              <a:t>Share of 1,000 real levels per set solved within a node budget: no pruning vs with checker</a:t>
+              <a:t>A slip means nothing happened. A wrong move means a different legal move happened. The demo shows the worst one found for each game.</a:t>
             </a:r>
           </a:p>
         </p:txBody>
@@ -4802,8 +4385,8 @@
           <p:nvPr/>
         </p:nvGraphicFramePr>
         <p:xfrm>
-          <a:off x="548640" y="1783080"/>
-          <a:ext cx="11064240" cy="2743200"/>
+          <a:off x="548640" y="1828800"/>
+          <a:ext cx="11064240" cy="3584448"/>
         </p:xfrm>
         <a:graphic>
           <a:graphicData uri="http://schemas.openxmlformats.org/drawingml/2006/table">
@@ -4812,25 +4395,25 @@
                 <a:tableStyleId>{5C22544A-7EE6-4342-B048-85BDC9FD1C3A}</a:tableStyleId>
               </a:tblPr>
               <a:tblGrid>
-                <a:gridCol w="2834640"/>
-                <a:gridCol w="2743200"/>
-                <a:gridCol w="2743200"/>
-                <a:gridCol w="2743200"/>
+                <a:gridCol w="1920240"/>
+                <a:gridCol w="2468880"/>
+                <a:gridCol w="1188720"/>
+                <a:gridCol w="5486400"/>
               </a:tblGrid>
-              <a:tr h="457200">
-                <a:tc>
-                  <a:txBody>
-                    <a:bodyPr/>
-                    <a:lstStyle/>
-                    <a:p>
-                      <a:r>
-                        <a:rPr sz="1600" b="1">
+              <a:tr h="512064">
+                <a:tc>
+                  <a:txBody>
+                    <a:bodyPr/>
+                    <a:lstStyle/>
+                    <a:p>
+                      <a:r>
+                        <a:rPr sz="1300" b="1">
                           <a:solidFill>
                             <a:srgbClr val="FFFFFF"/>
                           </a:solidFill>
                           <a:latin typeface="Calibri"/>
                         </a:rPr>
-                        <a:t>Nodes per search</a:t>
+                        <a:t>Game</a:t>
                       </a:r>
                     </a:p>
                   </a:txBody>
@@ -4846,13 +4429,13 @@
                     <a:lstStyle/>
                     <a:p>
                       <a:r>
-                        <a:rPr sz="1600" b="1">
+                        <a:rPr sz="1300" b="1">
                           <a:solidFill>
                             <a:srgbClr val="FFFFFF"/>
                           </a:solidFill>
                           <a:latin typeface="Calibri"/>
                         </a:rPr>
-                        <a:t>Unfiltered</a:t>
+                        <a:t>What happens</a:t>
                       </a:r>
                     </a:p>
                   </a:txBody>
@@ -4868,13 +4451,13 @@
                     <a:lstStyle/>
                     <a:p>
                       <a:r>
-                        <a:rPr sz="1600" b="1">
+                        <a:rPr sz="1300" b="1">
                           <a:solidFill>
                             <a:srgbClr val="FFFFFF"/>
                           </a:solidFill>
                           <a:latin typeface="Calibri"/>
                         </a:rPr>
-                        <a:t>Medium</a:t>
+                        <a:t>Kind</a:t>
                       </a:r>
                     </a:p>
                   </a:txBody>
@@ -4890,13 +4473,13 @@
                     <a:lstStyle/>
                     <a:p>
                       <a:r>
-                        <a:rPr sz="1600" b="1">
+                        <a:rPr sz="1300" b="1">
                           <a:solidFill>
                             <a:srgbClr val="FFFFFF"/>
                           </a:solidFill>
                           <a:latin typeface="Calibri"/>
                         </a:rPr>
-                        <a:t>Hard</a:t>
+                        <a:t>Result</a:t>
                       </a:r>
                     </a:p>
                   </a:txBody>
@@ -4907,20 +4490,20 @@
                   </a:tcPr>
                 </a:tc>
               </a:tr>
-              <a:tr h="457200">
-                <a:tc>
-                  <a:txBody>
-                    <a:bodyPr/>
-                    <a:lstStyle/>
-                    <a:p>
-                      <a:r>
-                        <a:rPr sz="1600" b="0">
-                          <a:solidFill>
-                            <a:srgbClr val="1A1A1A"/>
-                          </a:solidFill>
-                          <a:latin typeface="Calibri"/>
-                        </a:rPr>
-                        <a:t>2,000</a:t>
+              <a:tr h="512064">
+                <a:tc>
+                  <a:txBody>
+                    <a:bodyPr/>
+                    <a:lstStyle/>
+                    <a:p>
+                      <a:r>
+                        <a:rPr sz="1300" b="0">
+                          <a:solidFill>
+                            <a:srgbClr val="1A1A1A"/>
+                          </a:solidFill>
+                          <a:latin typeface="Calibri"/>
+                        </a:rPr>
+                        <a:t>Sokoban</a:t>
                       </a:r>
                     </a:p>
                   </a:txBody>
@@ -4936,13 +4519,13 @@
                     <a:lstStyle/>
                     <a:p>
                       <a:r>
-                        <a:rPr sz="1600" b="0">
-                          <a:solidFill>
-                            <a:srgbClr val="1A1A1A"/>
-                          </a:solidFill>
-                          <a:latin typeface="Calibri"/>
-                        </a:rPr>
-                        <a:t>57% vs 65%</a:t>
+                        <a:rPr sz="1300" b="0">
+                          <a:solidFill>
+                            <a:srgbClr val="1A1A1A"/>
+                          </a:solidFill>
+                          <a:latin typeface="Calibri"/>
+                        </a:rPr>
+                        <a:t>L planned, U happens</a:t>
                       </a:r>
                     </a:p>
                   </a:txBody>
@@ -4958,13 +4541,13 @@
                     <a:lstStyle/>
                     <a:p>
                       <a:r>
-                        <a:rPr sz="1600" b="0">
-                          <a:solidFill>
-                            <a:srgbClr val="1A1A1A"/>
-                          </a:solidFill>
-                          <a:latin typeface="Calibri"/>
-                        </a:rPr>
-                        <a:t>14% vs 23%</a:t>
+                        <a:rPr sz="1300" b="0">
+                          <a:solidFill>
+                            <a:srgbClr val="1A1A1A"/>
+                          </a:solidFill>
+                          <a:latin typeface="Calibri"/>
+                        </a:rPr>
+                        <a:t>Dead end</a:t>
                       </a:r>
                     </a:p>
                   </a:txBody>
@@ -4980,13 +4563,13 @@
                     <a:lstStyle/>
                     <a:p>
                       <a:r>
-                        <a:rPr sz="1600" b="0">
-                          <a:solidFill>
-                            <a:srgbClr val="1A1A1A"/>
-                          </a:solidFill>
-                          <a:latin typeface="Calibri"/>
-                        </a:rPr>
-                        <a:t>6% vs 13%</a:t>
+                        <a:rPr sz="1300" b="0">
+                          <a:solidFill>
+                            <a:srgbClr val="1A1A1A"/>
+                          </a:solidFill>
+                          <a:latin typeface="Calibri"/>
+                        </a:rPr>
+                        <a:t>No plan exists. Search proves it in 120 nodes (72 with the checker)</a:t>
                       </a:r>
                     </a:p>
                   </a:txBody>
@@ -4997,20 +4580,20 @@
                   </a:tcPr>
                 </a:tc>
               </a:tr>
-              <a:tr h="457200">
-                <a:tc>
-                  <a:txBody>
-                    <a:bodyPr/>
-                    <a:lstStyle/>
-                    <a:p>
-                      <a:r>
-                        <a:rPr sz="1600" b="0">
-                          <a:solidFill>
-                            <a:srgbClr val="1A1A1A"/>
-                          </a:solidFill>
-                          <a:latin typeface="Calibri"/>
-                        </a:rPr>
-                        <a:t>5,000</a:t>
+              <a:tr h="512064">
+                <a:tc>
+                  <a:txBody>
+                    <a:bodyPr/>
+                    <a:lstStyle/>
+                    <a:p>
+                      <a:r>
+                        <a:rPr sz="1300" b="0">
+                          <a:solidFill>
+                            <a:srgbClr val="1A1A1A"/>
+                          </a:solidFill>
+                          <a:latin typeface="Calibri"/>
+                        </a:rPr>
+                        <a:t>River Crossing</a:t>
                       </a:r>
                     </a:p>
                   </a:txBody>
@@ -5026,13 +4609,13 @@
                     <a:lstStyle/>
                     <a:p>
                       <a:r>
-                        <a:rPr sz="1600" b="0">
-                          <a:solidFill>
-                            <a:srgbClr val="1A1A1A"/>
-                          </a:solidFill>
-                          <a:latin typeface="Calibri"/>
-                        </a:rPr>
-                        <a:t>73% vs 82%</a:t>
+                        <a:rPr sz="1300" b="0">
+                          <a:solidFill>
+                            <a:srgbClr val="1A1A1A"/>
+                          </a:solidFill>
+                          <a:latin typeface="Calibri"/>
+                        </a:rPr>
+                        <a:t>2C planned, 2M happens</a:t>
                       </a:r>
                     </a:p>
                   </a:txBody>
@@ -5048,13 +4631,13 @@
                     <a:lstStyle/>
                     <a:p>
                       <a:r>
-                        <a:rPr sz="1600" b="0">
-                          <a:solidFill>
-                            <a:srgbClr val="1A1A1A"/>
-                          </a:solidFill>
-                          <a:latin typeface="Calibri"/>
-                        </a:rPr>
-                        <a:t>29% vs 45%</a:t>
+                        <a:rPr sz="1300" b="0">
+                          <a:solidFill>
+                            <a:srgbClr val="1A1A1A"/>
+                          </a:solidFill>
+                          <a:latin typeface="Calibri"/>
+                        </a:rPr>
+                        <a:t>Lost</a:t>
                       </a:r>
                     </a:p>
                   </a:txBody>
@@ -5070,13 +4653,13 @@
                     <a:lstStyle/>
                     <a:p>
                       <a:r>
-                        <a:rPr sz="1600" b="0">
-                          <a:solidFill>
-                            <a:srgbClr val="1A1A1A"/>
-                          </a:solidFill>
-                          <a:latin typeface="Calibri"/>
-                        </a:rPr>
-                        <a:t>16% vs 29%</a:t>
+                        <a:rPr sz="1300" b="0">
+                          <a:solidFill>
+                            <a:srgbClr val="1A1A1A"/>
+                          </a:solidFill>
+                          <a:latin typeface="Calibri"/>
+                        </a:rPr>
+                        <a:t>Checker flags the position at once; an unchecked planner plans on</a:t>
                       </a:r>
                     </a:p>
                   </a:txBody>
@@ -5087,20 +4670,20 @@
                   </a:tcPr>
                 </a:tc>
               </a:tr>
-              <a:tr h="457200">
-                <a:tc>
-                  <a:txBody>
-                    <a:bodyPr/>
-                    <a:lstStyle/>
-                    <a:p>
-                      <a:r>
-                        <a:rPr sz="1600" b="0">
-                          <a:solidFill>
-                            <a:srgbClr val="1A1A1A"/>
-                          </a:solidFill>
-                          <a:latin typeface="Calibri"/>
-                        </a:rPr>
-                        <a:t>10,000</a:t>
+              <a:tr h="512064">
+                <a:tc>
+                  <a:txBody>
+                    <a:bodyPr/>
+                    <a:lstStyle/>
+                    <a:p>
+                      <a:r>
+                        <a:rPr sz="1300" b="0">
+                          <a:solidFill>
+                            <a:srgbClr val="1A1A1A"/>
+                          </a:solidFill>
+                          <a:latin typeface="Calibri"/>
+                        </a:rPr>
+                        <a:t>Rush Hour</a:t>
                       </a:r>
                     </a:p>
                   </a:txBody>
@@ -5116,13 +4699,13 @@
                     <a:lstStyle/>
                     <a:p>
                       <a:r>
-                        <a:rPr sz="1600" b="0">
-                          <a:solidFill>
-                            <a:srgbClr val="1A1A1A"/>
-                          </a:solidFill>
-                          <a:latin typeface="Calibri"/>
-                        </a:rPr>
-                        <a:t>84% vs 92%</a:t>
+                        <a:rPr sz="1300" b="0">
+                          <a:solidFill>
+                            <a:srgbClr val="1A1A1A"/>
+                          </a:solidFill>
+                          <a:latin typeface="Calibri"/>
+                        </a:rPr>
+                        <a:t>B+ planned, B- happens</a:t>
                       </a:r>
                     </a:p>
                   </a:txBody>
@@ -5138,13 +4721,13 @@
                     <a:lstStyle/>
                     <a:p>
                       <a:r>
-                        <a:rPr sz="1600" b="0">
-                          <a:solidFill>
-                            <a:srgbClr val="1A1A1A"/>
-                          </a:solidFill>
-                          <a:latin typeface="Calibri"/>
-                        </a:rPr>
-                        <a:t>46% vs 65%</a:t>
+                        <a:rPr sz="1300" b="0">
+                          <a:solidFill>
+                            <a:srgbClr val="1A1A1A"/>
+                          </a:solidFill>
+                          <a:latin typeface="Calibri"/>
+                        </a:rPr>
+                        <a:t>Detour</a:t>
                       </a:r>
                     </a:p>
                   </a:txBody>
@@ -5160,13 +4743,13 @@
                     <a:lstStyle/>
                     <a:p>
                       <a:r>
-                        <a:rPr sz="1600" b="0">
-                          <a:solidFill>
-                            <a:srgbClr val="1A1A1A"/>
-                          </a:solidFill>
-                          <a:latin typeface="Calibri"/>
-                        </a:rPr>
-                        <a:t>27% vs 49%</a:t>
+                        <a:rPr sz="1300" b="0">
+                          <a:solidFill>
+                            <a:srgbClr val="1A1A1A"/>
+                          </a:solidFill>
+                          <a:latin typeface="Calibri"/>
+                        </a:rPr>
+                        <a:t>Still solvable: 6 moves to go, was 4</a:t>
                       </a:r>
                     </a:p>
                   </a:txBody>
@@ -5177,20 +4760,20 @@
                   </a:tcPr>
                 </a:tc>
               </a:tr>
-              <a:tr h="457200">
-                <a:tc>
-                  <a:txBody>
-                    <a:bodyPr/>
-                    <a:lstStyle/>
-                    <a:p>
-                      <a:r>
-                        <a:rPr sz="1600" b="0">
-                          <a:solidFill>
-                            <a:srgbClr val="1A1A1A"/>
-                          </a:solidFill>
-                          <a:latin typeface="Calibri"/>
-                        </a:rPr>
-                        <a:t>20,000</a:t>
+              <a:tr h="512064">
+                <a:tc>
+                  <a:txBody>
+                    <a:bodyPr/>
+                    <a:lstStyle/>
+                    <a:p>
+                      <a:r>
+                        <a:rPr sz="1300" b="0">
+                          <a:solidFill>
+                            <a:srgbClr val="1A1A1A"/>
+                          </a:solidFill>
+                          <a:latin typeface="Calibri"/>
+                        </a:rPr>
+                        <a:t>Peg Solitaire</a:t>
                       </a:r>
                     </a:p>
                   </a:txBody>
@@ -5206,13 +4789,13 @@
                     <a:lstStyle/>
                     <a:p>
                       <a:r>
-                        <a:rPr sz="1600" b="0">
-                          <a:solidFill>
-                            <a:srgbClr val="1A1A1A"/>
-                          </a:solidFill>
-                          <a:latin typeface="Calibri"/>
-                        </a:rPr>
-                        <a:t>92% vs 96%</a:t>
+                        <a:rPr sz="1300" b="0">
+                          <a:solidFill>
+                            <a:srgbClr val="1A1A1A"/>
+                          </a:solidFill>
+                          <a:latin typeface="Calibri"/>
+                        </a:rPr>
+                        <a:t>32U planned, 33L happens</a:t>
                       </a:r>
                     </a:p>
                   </a:txBody>
@@ -5228,13 +4811,13 @@
                     <a:lstStyle/>
                     <a:p>
                       <a:r>
-                        <a:rPr sz="1600" b="0">
-                          <a:solidFill>
-                            <a:srgbClr val="1A1A1A"/>
-                          </a:solidFill>
-                          <a:latin typeface="Calibri"/>
-                        </a:rPr>
-                        <a:t>61% vs 82%</a:t>
+                        <a:rPr sz="1300" b="0">
+                          <a:solidFill>
+                            <a:srgbClr val="1A1A1A"/>
+                          </a:solidFill>
+                          <a:latin typeface="Calibri"/>
+                        </a:rPr>
+                        <a:t>Dead end</a:t>
                       </a:r>
                     </a:p>
                   </a:txBody>
@@ -5250,13 +4833,13 @@
                     <a:lstStyle/>
                     <a:p>
                       <a:r>
-                        <a:rPr sz="1600" b="0">
-                          <a:solidFill>
-                            <a:srgbClr val="1A1A1A"/>
-                          </a:solidFill>
-                          <a:latin typeface="Calibri"/>
-                        </a:rPr>
-                        <a:t>44% vs 70%</a:t>
+                        <a:rPr sz="1300" b="0">
+                          <a:solidFill>
+                            <a:srgbClr val="1A1A1A"/>
+                          </a:solidFill>
+                          <a:latin typeface="Calibri"/>
+                        </a:rPr>
+                        <a:t>No plan exists. Search proves it in 38,920 nodes (16,978 with the checker)</a:t>
                       </a:r>
                     </a:p>
                   </a:txBody>
@@ -5267,20 +4850,20 @@
                   </a:tcPr>
                 </a:tc>
               </a:tr>
-              <a:tr h="457200">
-                <a:tc>
-                  <a:txBody>
-                    <a:bodyPr/>
-                    <a:lstStyle/>
-                    <a:p>
-                      <a:r>
-                        <a:rPr sz="1600" b="0">
-                          <a:solidFill>
-                            <a:srgbClr val="1A1A1A"/>
-                          </a:solidFill>
-                          <a:latin typeface="Calibri"/>
-                        </a:rPr>
-                        <a:t>30,000</a:t>
+              <a:tr h="512064">
+                <a:tc>
+                  <a:txBody>
+                    <a:bodyPr/>
+                    <a:lstStyle/>
+                    <a:p>
+                      <a:r>
+                        <a:rPr sz="1300" b="0">
+                          <a:solidFill>
+                            <a:srgbClr val="1A1A1A"/>
+                          </a:solidFill>
+                          <a:latin typeface="Calibri"/>
+                        </a:rPr>
+                        <a:t>24-puzzle</a:t>
                       </a:r>
                     </a:p>
                   </a:txBody>
@@ -5296,13 +4879,13 @@
                     <a:lstStyle/>
                     <a:p>
                       <a:r>
-                        <a:rPr sz="1600" b="0">
-                          <a:solidFill>
-                            <a:srgbClr val="1A1A1A"/>
-                          </a:solidFill>
-                          <a:latin typeface="Calibri"/>
-                        </a:rPr>
-                        <a:t>95% vs 98%</a:t>
+                        <a:rPr sz="1300" b="0">
+                          <a:solidFill>
+                            <a:srgbClr val="1A1A1A"/>
+                          </a:solidFill>
+                          <a:latin typeface="Calibri"/>
+                        </a:rPr>
+                        <a:t>D planned, U happens</a:t>
                       </a:r>
                     </a:p>
                   </a:txBody>
@@ -5318,13 +4901,13 @@
                     <a:lstStyle/>
                     <a:p>
                       <a:r>
-                        <a:rPr sz="1600" b="0">
-                          <a:solidFill>
-                            <a:srgbClr val="1A1A1A"/>
-                          </a:solidFill>
-                          <a:latin typeface="Calibri"/>
-                        </a:rPr>
-                        <a:t>71% vs 88%</a:t>
+                        <a:rPr sz="1300" b="0">
+                          <a:solidFill>
+                            <a:srgbClr val="1A1A1A"/>
+                          </a:solidFill>
+                          <a:latin typeface="Calibri"/>
+                        </a:rPr>
+                        <a:t>Detour</a:t>
                       </a:r>
                     </a:p>
                   </a:txBody>
@@ -5340,19 +4923,109 @@
                     <a:lstStyle/>
                     <a:p>
                       <a:r>
-                        <a:rPr sz="1600" b="0">
-                          <a:solidFill>
-                            <a:srgbClr val="1A1A1A"/>
-                          </a:solidFill>
-                          <a:latin typeface="Calibri"/>
-                        </a:rPr>
-                        <a:t>54% vs 82%</a:t>
+                        <a:rPr sz="1300" b="0">
+                          <a:solidFill>
+                            <a:srgbClr val="1A1A1A"/>
+                          </a:solidFill>
+                          <a:latin typeface="Calibri"/>
+                        </a:rPr>
+                        <a:t>Still solvable: 14 moves to go, was 12</a:t>
                       </a:r>
                     </a:p>
                   </a:txBody>
                   <a:tcPr>
                     <a:solidFill>
                       <a:srgbClr val="FFFFFF"/>
+                    </a:solidFill>
+                  </a:tcPr>
+                </a:tc>
+              </a:tr>
+              <a:tr h="512064">
+                <a:tc>
+                  <a:txBody>
+                    <a:bodyPr/>
+                    <a:lstStyle/>
+                    <a:p>
+                      <a:r>
+                        <a:rPr sz="1300" b="0">
+                          <a:solidFill>
+                            <a:srgbClr val="1A1A1A"/>
+                          </a:solidFill>
+                          <a:latin typeface="Calibri"/>
+                        </a:rPr>
+                        <a:t>Rubik's cube</a:t>
+                      </a:r>
+                    </a:p>
+                  </a:txBody>
+                  <a:tcPr>
+                    <a:solidFill>
+                      <a:srgbClr val="F6F6F6"/>
+                    </a:solidFill>
+                  </a:tcPr>
+                </a:tc>
+                <a:tc>
+                  <a:txBody>
+                    <a:bodyPr/>
+                    <a:lstStyle/>
+                    <a:p>
+                      <a:r>
+                        <a:rPr sz="1300" b="0">
+                          <a:solidFill>
+                            <a:srgbClr val="1A1A1A"/>
+                          </a:solidFill>
+                          <a:latin typeface="Calibri"/>
+                        </a:rPr>
+                        <a:t>F planned, U happens</a:t>
+                      </a:r>
+                    </a:p>
+                  </a:txBody>
+                  <a:tcPr>
+                    <a:solidFill>
+                      <a:srgbClr val="F6F6F6"/>
+                    </a:solidFill>
+                  </a:tcPr>
+                </a:tc>
+                <a:tc>
+                  <a:txBody>
+                    <a:bodyPr/>
+                    <a:lstStyle/>
+                    <a:p>
+                      <a:r>
+                        <a:rPr sz="1300" b="0">
+                          <a:solidFill>
+                            <a:srgbClr val="1A1A1A"/>
+                          </a:solidFill>
+                          <a:latin typeface="Calibri"/>
+                        </a:rPr>
+                        <a:t>Detour</a:t>
+                      </a:r>
+                    </a:p>
+                  </a:txBody>
+                  <a:tcPr>
+                    <a:solidFill>
+                      <a:srgbClr val="F6F6F6"/>
+                    </a:solidFill>
+                  </a:tcPr>
+                </a:tc>
+                <a:tc>
+                  <a:txBody>
+                    <a:bodyPr/>
+                    <a:lstStyle/>
+                    <a:p>
+                      <a:r>
+                        <a:rPr sz="1300" b="0">
+                          <a:solidFill>
+                            <a:srgbClr val="1A1A1A"/>
+                          </a:solidFill>
+                          <a:latin typeface="Calibri"/>
+                        </a:rPr>
+                        <a:t>Still solvable: 4 moves to go, was 2</a:t>
+                      </a:r>
+                    </a:p>
+                  </a:txBody>
+                  <a:tcPr>
+                    <a:solidFill>
+                      <a:srgbClr val="F6F6F6"/>
                     </a:solidFill>
                   </a:tcPr>
                 </a:tc>
@@ -5369,8 +5042,8 @@
         </p:nvSpPr>
         <p:spPr>
           <a:xfrm>
-            <a:off x="548640" y="4754880"/>
-            <a:ext cx="11064240" cy="1828800"/>
+            <a:off x="548640" y="5623560"/>
+            <a:ext cx="11064240" cy="914400"/>
           </a:xfrm>
           <a:prstGeom prst="rect">
             <a:avLst/>
@@ -5389,29 +5062,13 @@
               </a:spcAft>
             </a:pPr>
             <a:r>
-              <a:rPr sz="1800" b="0">
-                <a:solidFill>
-                  <a:srgbClr val="1A1A1A"/>
-                </a:solidFill>
-                <a:latin typeface="Calibri"/>
-              </a:rPr>
-              <a:t>•  The checker wins in all 15 cells, with non-overlapping 95% intervals. It never missed a level the other search solved.</a:t>
-            </a:r>
-          </a:p>
-          <a:p>
-            <a:pPr>
-              <a:spcAft>
-                <a:spcPts val="600"/>
-              </a:spcAft>
-            </a:pPr>
-            <a:r>
-              <a:rPr sz="1800" b="0">
-                <a:solidFill>
-                  <a:srgbClr val="1A1A1A"/>
-                </a:solidFill>
-                <a:latin typeface="Calibri"/>
-              </a:rPr>
-              <a:t>•  It also expands 20% to 25% fewer nodes. Pruning dead corners is standard in Sokoban solvers; this shows our checker works as one on real levels.</a:t>
+              <a:rPr sz="1500" b="0">
+                <a:solidFill>
+                  <a:srgbClr val="5A5A5A"/>
+                </a:solidFill>
+                <a:latin typeface="Calibri"/>
+              </a:rPr>
+              <a:t>Lost: the checker flags it. Dead end: the checker's rules miss it, but a full search shows no plan exists. Detour: still solvable, only longer.</a:t>
             </a:r>
           </a:p>
         </p:txBody>
@@ -5468,7 +5125,7 @@
                 </a:solidFill>
                 <a:latin typeface="Calibri"/>
               </a:rPr>
-              <a:t>Results and Discussion: Harder Games</a:t>
+              <a:t>Results and Discussion: Safety and Speed</a:t>
             </a:r>
           </a:p>
         </p:txBody>
@@ -5542,7 +5199,7 @@
                 </a:solidFill>
                 <a:latin typeface="Calibri"/>
               </a:rPr>
-              <a:t>Peg Solitaire, 24-puzzle and Rubik's cube. 60 instances per row, 30 for the cube.</a:t>
+              <a:t>Ablation, 30 episodes per cell, 15% slip, synthetic proposer</a:t>
             </a:r>
           </a:p>
         </p:txBody>
@@ -5557,7 +5214,7 @@
         </p:nvGraphicFramePr>
         <p:xfrm>
           <a:off x="548640" y="1737360"/>
-          <a:ext cx="11064240" cy="2103120"/>
+          <a:ext cx="5303520" cy="2011680"/>
         </p:xfrm>
         <a:graphic>
           <a:graphicData uri="http://schemas.openxmlformats.org/drawingml/2006/table">
@@ -5566,12 +5223,10 @@
                 <a:tableStyleId>{5C22544A-7EE6-4342-B048-85BDC9FD1C3A}</a:tableStyleId>
               </a:tblPr>
               <a:tblGrid>
-                <a:gridCol w="2651760"/>
-                <a:gridCol w="2651760"/>
-                <a:gridCol w="2743200"/>
-                <a:gridCol w="3017520"/>
+                <a:gridCol w="3291840"/>
+                <a:gridCol w="2011680"/>
               </a:tblGrid>
-              <a:tr h="420624">
+              <a:tr h="502920">
                 <a:tc>
                   <a:txBody>
                     <a:bodyPr/>
@@ -5584,7 +5239,7 @@
                           </a:solidFill>
                           <a:latin typeface="Calibri"/>
                         </a:rPr>
-                        <a:t>Jumps from the goal</a:t>
+                        <a:t>River Crossing</a:t>
                       </a:r>
                     </a:p>
                   </a:txBody>
@@ -5606,7 +5261,7 @@
                           </a:solidFill>
                           <a:latin typeface="Calibri"/>
                         </a:rPr>
-                        <a:t>Solved, no checker</a:t>
+                        <a:t>Safe success</a:t>
                       </a:r>
                     </a:p>
                   </a:txBody>
@@ -5616,6 +5271,173 @@
                     </a:solidFill>
                   </a:tcPr>
                 </a:tc>
+              </a:tr>
+              <a:tr h="502920">
+                <a:tc>
+                  <a:txBody>
+                    <a:bodyPr/>
+                    <a:lstStyle/>
+                    <a:p>
+                      <a:r>
+                        <a:rPr sz="1500" b="0">
+                          <a:solidFill>
+                            <a:srgbClr val="1A1A1A"/>
+                          </a:solidFill>
+                          <a:latin typeface="Calibri"/>
+                        </a:rPr>
+                        <a:t>Baseline (no checker)</a:t>
+                      </a:r>
+                    </a:p>
+                  </a:txBody>
+                  <a:tcPr>
+                    <a:solidFill>
+                      <a:srgbClr val="FFFFFF"/>
+                    </a:solidFill>
+                  </a:tcPr>
+                </a:tc>
+                <a:tc>
+                  <a:txBody>
+                    <a:bodyPr/>
+                    <a:lstStyle/>
+                    <a:p>
+                      <a:r>
+                        <a:rPr sz="1500" b="0">
+                          <a:solidFill>
+                            <a:srgbClr val="1A1A1A"/>
+                          </a:solidFill>
+                          <a:latin typeface="Calibri"/>
+                        </a:rPr>
+                        <a:t>0%</a:t>
+                      </a:r>
+                    </a:p>
+                  </a:txBody>
+                  <a:tcPr>
+                    <a:solidFill>
+                      <a:srgbClr val="FFFFFF"/>
+                    </a:solidFill>
+                  </a:tcPr>
+                </a:tc>
+              </a:tr>
+              <a:tr h="502920">
+                <a:tc>
+                  <a:txBody>
+                    <a:bodyPr/>
+                    <a:lstStyle/>
+                    <a:p>
+                      <a:r>
+                        <a:rPr sz="1500" b="0">
+                          <a:solidFill>
+                            <a:srgbClr val="1A1A1A"/>
+                          </a:solidFill>
+                          <a:latin typeface="Calibri"/>
+                        </a:rPr>
+                        <a:t>With validator</a:t>
+                      </a:r>
+                    </a:p>
+                  </a:txBody>
+                  <a:tcPr>
+                    <a:solidFill>
+                      <a:srgbClr val="F6F6F6"/>
+                    </a:solidFill>
+                  </a:tcPr>
+                </a:tc>
+                <a:tc>
+                  <a:txBody>
+                    <a:bodyPr/>
+                    <a:lstStyle/>
+                    <a:p>
+                      <a:r>
+                        <a:rPr sz="1500" b="0">
+                          <a:solidFill>
+                            <a:srgbClr val="1A1A1A"/>
+                          </a:solidFill>
+                          <a:latin typeface="Calibri"/>
+                        </a:rPr>
+                        <a:t>100%</a:t>
+                      </a:r>
+                    </a:p>
+                  </a:txBody>
+                  <a:tcPr>
+                    <a:solidFill>
+                      <a:srgbClr val="F6F6F6"/>
+                    </a:solidFill>
+                  </a:tcPr>
+                </a:tc>
+              </a:tr>
+              <a:tr h="502920">
+                <a:tc>
+                  <a:txBody>
+                    <a:bodyPr/>
+                    <a:lstStyle/>
+                    <a:p>
+                      <a:r>
+                        <a:rPr sz="1500" b="0">
+                          <a:solidFill>
+                            <a:srgbClr val="1A1A1A"/>
+                          </a:solidFill>
+                          <a:latin typeface="Calibri"/>
+                        </a:rPr>
+                        <a:t>Goal reached, baseline</a:t>
+                      </a:r>
+                    </a:p>
+                  </a:txBody>
+                  <a:tcPr>
+                    <a:solidFill>
+                      <a:srgbClr val="FFFFFF"/>
+                    </a:solidFill>
+                  </a:tcPr>
+                </a:tc>
+                <a:tc>
+                  <a:txBody>
+                    <a:bodyPr/>
+                    <a:lstStyle/>
+                    <a:p>
+                      <a:r>
+                        <a:rPr sz="1500" b="0">
+                          <a:solidFill>
+                            <a:srgbClr val="1A1A1A"/>
+                          </a:solidFill>
+                          <a:latin typeface="Calibri"/>
+                        </a:rPr>
+                        <a:t>100% (unsafely)</a:t>
+                      </a:r>
+                    </a:p>
+                  </a:txBody>
+                  <a:tcPr>
+                    <a:solidFill>
+                      <a:srgbClr val="FFFFFF"/>
+                    </a:solidFill>
+                  </a:tcPr>
+                </a:tc>
+              </a:tr>
+            </a:tbl>
+          </a:graphicData>
+        </a:graphic>
+      </p:graphicFrame>
+      <p:graphicFrame>
+        <p:nvGraphicFramePr>
+          <p:cNvPr id="6" name="Table 5"/>
+          <p:cNvGraphicFramePr>
+            <a:graphicFrameLocks noGrp="1"/>
+          </p:cNvGraphicFramePr>
+          <p:nvPr/>
+        </p:nvGraphicFramePr>
+        <p:xfrm>
+          <a:off x="6217920" y="1737360"/>
+          <a:ext cx="5394960" cy="2286000"/>
+        </p:xfrm>
+        <a:graphic>
+          <a:graphicData uri="http://schemas.openxmlformats.org/drawingml/2006/table">
+            <a:tbl>
+              <a:tblPr firstRow="1" bandRow="1">
+                <a:tableStyleId>{5C22544A-7EE6-4342-B048-85BDC9FD1C3A}</a:tableStyleId>
+              </a:tblPr>
+              <a:tblGrid>
+                <a:gridCol w="2468880"/>
+                <a:gridCol w="1554480"/>
+                <a:gridCol w="1371600"/>
+              </a:tblGrid>
+              <a:tr h="457200">
                 <a:tc>
                   <a:txBody>
                     <a:bodyPr/>
@@ -5628,7 +5450,7 @@
                           </a:solidFill>
                           <a:latin typeface="Calibri"/>
                         </a:rPr>
-                        <a:t>Solved, pagoda checker</a:t>
+                        <a:t>Planning time (ms)</a:t>
                       </a:r>
                     </a:p>
                   </a:txBody>
@@ -5650,7 +5472,7 @@
                           </a:solidFill>
                           <a:latin typeface="Calibri"/>
                         </a:rPr>
-                        <a:t>Mean nodes, no checker / checker</a:t>
+                        <a:t>Always CP-SAT</a:t>
                       </a:r>
                     </a:p>
                   </a:txBody>
@@ -5660,8 +5482,30 @@
                     </a:solidFill>
                   </a:tcPr>
                 </a:tc>
+                <a:tc>
+                  <a:txBody>
+                    <a:bodyPr/>
+                    <a:lstStyle/>
+                    <a:p>
+                      <a:r>
+                        <a:rPr sz="1500" b="1">
+                          <a:solidFill>
+                            <a:srgbClr val="FFFFFF"/>
+                          </a:solidFill>
+                          <a:latin typeface="Calibri"/>
+                        </a:rPr>
+                        <a:t>Adaptive</a:t>
+                      </a:r>
+                    </a:p>
+                  </a:txBody>
+                  <a:tcPr>
+                    <a:solidFill>
+                      <a:srgbClr val="1F4FC8"/>
+                    </a:solidFill>
+                  </a:tcPr>
+                </a:tc>
               </a:tr>
-              <a:tr h="420624">
+              <a:tr h="457200">
                 <a:tc>
                   <a:txBody>
                     <a:bodyPr/>
@@ -5674,7 +5518,7 @@
                           </a:solidFill>
                           <a:latin typeface="Calibri"/>
                         </a:rPr>
-                        <a:t>12</a:t>
+                        <a:t>Sokoban, 1 box</a:t>
                       </a:r>
                     </a:p>
                   </a:txBody>
@@ -5696,7 +5540,7 @@
                           </a:solidFill>
                           <a:latin typeface="Calibri"/>
                         </a:rPr>
-                        <a:t>100%</a:t>
+                        <a:t>51.8</a:t>
                       </a:r>
                     </a:p>
                   </a:txBody>
@@ -5718,7 +5562,7 @@
                           </a:solidFill>
                           <a:latin typeface="Calibri"/>
                         </a:rPr>
-                        <a:t>100%</a:t>
+                        <a:t>7.6</a:t>
                       </a:r>
                     </a:p>
                   </a:txBody>
@@ -5728,6 +5572,8 @@
                     </a:solidFill>
                   </a:tcPr>
                 </a:tc>
+              </a:tr>
+              <a:tr h="457200">
                 <a:tc>
                   <a:txBody>
                     <a:bodyPr/>
@@ -5740,7 +5586,75 @@
                           </a:solidFill>
                           <a:latin typeface="Calibri"/>
                         </a:rPr>
-                        <a:t>296 / 237</a:t>
+                        <a:t>River Crossing</a:t>
+                      </a:r>
+                    </a:p>
+                  </a:txBody>
+                  <a:tcPr>
+                    <a:solidFill>
+                      <a:srgbClr val="F6F6F6"/>
+                    </a:solidFill>
+                  </a:tcPr>
+                </a:tc>
+                <a:tc>
+                  <a:txBody>
+                    <a:bodyPr/>
+                    <a:lstStyle/>
+                    <a:p>
+                      <a:r>
+                        <a:rPr sz="1500" b="0">
+                          <a:solidFill>
+                            <a:srgbClr val="1A1A1A"/>
+                          </a:solidFill>
+                          <a:latin typeface="Calibri"/>
+                        </a:rPr>
+                        <a:t>62.1</a:t>
+                      </a:r>
+                    </a:p>
+                  </a:txBody>
+                  <a:tcPr>
+                    <a:solidFill>
+                      <a:srgbClr val="F6F6F6"/>
+                    </a:solidFill>
+                  </a:tcPr>
+                </a:tc>
+                <a:tc>
+                  <a:txBody>
+                    <a:bodyPr/>
+                    <a:lstStyle/>
+                    <a:p>
+                      <a:r>
+                        <a:rPr sz="1500" b="0">
+                          <a:solidFill>
+                            <a:srgbClr val="1A1A1A"/>
+                          </a:solidFill>
+                          <a:latin typeface="Calibri"/>
+                        </a:rPr>
+                        <a:t>3.6</a:t>
+                      </a:r>
+                    </a:p>
+                  </a:txBody>
+                  <a:tcPr>
+                    <a:solidFill>
+                      <a:srgbClr val="F6F6F6"/>
+                    </a:solidFill>
+                  </a:tcPr>
+                </a:tc>
+              </a:tr>
+              <a:tr h="457200">
+                <a:tc>
+                  <a:txBody>
+                    <a:bodyPr/>
+                    <a:lstStyle/>
+                    <a:p>
+                      <a:r>
+                        <a:rPr sz="1500" b="0">
+                          <a:solidFill>
+                            <a:srgbClr val="1A1A1A"/>
+                          </a:solidFill>
+                          <a:latin typeface="Calibri"/>
+                        </a:rPr>
+                        <a:t>Sokoban, 2 boxes</a:t>
                       </a:r>
                     </a:p>
                   </a:txBody>
@@ -5750,8 +5664,52 @@
                     </a:solidFill>
                   </a:tcPr>
                 </a:tc>
+                <a:tc>
+                  <a:txBody>
+                    <a:bodyPr/>
+                    <a:lstStyle/>
+                    <a:p>
+                      <a:r>
+                        <a:rPr sz="1500" b="0">
+                          <a:solidFill>
+                            <a:srgbClr val="1A1A1A"/>
+                          </a:solidFill>
+                          <a:latin typeface="Calibri"/>
+                        </a:rPr>
+                        <a:t>99.9</a:t>
+                      </a:r>
+                    </a:p>
+                  </a:txBody>
+                  <a:tcPr>
+                    <a:solidFill>
+                      <a:srgbClr val="FFFFFF"/>
+                    </a:solidFill>
+                  </a:tcPr>
+                </a:tc>
+                <a:tc>
+                  <a:txBody>
+                    <a:bodyPr/>
+                    <a:lstStyle/>
+                    <a:p>
+                      <a:r>
+                        <a:rPr sz="1500" b="0">
+                          <a:solidFill>
+                            <a:srgbClr val="1A1A1A"/>
+                          </a:solidFill>
+                          <a:latin typeface="Calibri"/>
+                        </a:rPr>
+                        <a:t>96.4</a:t>
+                      </a:r>
+                    </a:p>
+                  </a:txBody>
+                  <a:tcPr>
+                    <a:solidFill>
+                      <a:srgbClr val="FFFFFF"/>
+                    </a:solidFill>
+                  </a:tcPr>
+                </a:tc>
               </a:tr>
-              <a:tr h="420624">
+              <a:tr h="457200">
                 <a:tc>
                   <a:txBody>
                     <a:bodyPr/>
@@ -5764,7 +5722,7 @@
                           </a:solidFill>
                           <a:latin typeface="Calibri"/>
                         </a:rPr>
-                        <a:t>18</a:t>
+                        <a:t>Rush Hour</a:t>
                       </a:r>
                     </a:p>
                   </a:txBody>
@@ -5786,7 +5744,7 @@
                           </a:solidFill>
                           <a:latin typeface="Calibri"/>
                         </a:rPr>
-                        <a:t>100%</a:t>
+                        <a:t>36.2</a:t>
                       </a:r>
                     </a:p>
                   </a:txBody>
@@ -5808,209 +5766,7 @@
                           </a:solidFill>
                           <a:latin typeface="Calibri"/>
                         </a:rPr>
-                        <a:t>100%</a:t>
-                      </a:r>
-                    </a:p>
-                  </a:txBody>
-                  <a:tcPr>
-                    <a:solidFill>
-                      <a:srgbClr val="F6F6F6"/>
-                    </a:solidFill>
-                  </a:tcPr>
-                </a:tc>
-                <a:tc>
-                  <a:txBody>
-                    <a:bodyPr/>
-                    <a:lstStyle/>
-                    <a:p>
-                      <a:r>
-                        <a:rPr sz="1500" b="0">
-                          <a:solidFill>
-                            <a:srgbClr val="1A1A1A"/>
-                          </a:solidFill>
-                          <a:latin typeface="Calibri"/>
-                        </a:rPr>
-                        <a:t>2,776 / 1,914</a:t>
-                      </a:r>
-                    </a:p>
-                  </a:txBody>
-                  <a:tcPr>
-                    <a:solidFill>
-                      <a:srgbClr val="F6F6F6"/>
-                    </a:solidFill>
-                  </a:tcPr>
-                </a:tc>
-              </a:tr>
-              <a:tr h="420624">
-                <a:tc>
-                  <a:txBody>
-                    <a:bodyPr/>
-                    <a:lstStyle/>
-                    <a:p>
-                      <a:r>
-                        <a:rPr sz="1500" b="0">
-                          <a:solidFill>
-                            <a:srgbClr val="1A1A1A"/>
-                          </a:solidFill>
-                          <a:latin typeface="Calibri"/>
-                        </a:rPr>
-                        <a:t>22</a:t>
-                      </a:r>
-                    </a:p>
-                  </a:txBody>
-                  <a:tcPr>
-                    <a:solidFill>
-                      <a:srgbClr val="FFFFFF"/>
-                    </a:solidFill>
-                  </a:tcPr>
-                </a:tc>
-                <a:tc>
-                  <a:txBody>
-                    <a:bodyPr/>
-                    <a:lstStyle/>
-                    <a:p>
-                      <a:r>
-                        <a:rPr sz="1500" b="0">
-                          <a:solidFill>
-                            <a:srgbClr val="1A1A1A"/>
-                          </a:solidFill>
-                          <a:latin typeface="Calibri"/>
-                        </a:rPr>
-                        <a:t>93%</a:t>
-                      </a:r>
-                    </a:p>
-                  </a:txBody>
-                  <a:tcPr>
-                    <a:solidFill>
-                      <a:srgbClr val="FFFFFF"/>
-                    </a:solidFill>
-                  </a:tcPr>
-                </a:tc>
-                <a:tc>
-                  <a:txBody>
-                    <a:bodyPr/>
-                    <a:lstStyle/>
-                    <a:p>
-                      <a:r>
-                        <a:rPr sz="1500" b="0">
-                          <a:solidFill>
-                            <a:srgbClr val="1A1A1A"/>
-                          </a:solidFill>
-                          <a:latin typeface="Calibri"/>
-                        </a:rPr>
-                        <a:t>98%</a:t>
-                      </a:r>
-                    </a:p>
-                  </a:txBody>
-                  <a:tcPr>
-                    <a:solidFill>
-                      <a:srgbClr val="FFFFFF"/>
-                    </a:solidFill>
-                  </a:tcPr>
-                </a:tc>
-                <a:tc>
-                  <a:txBody>
-                    <a:bodyPr/>
-                    <a:lstStyle/>
-                    <a:p>
-                      <a:r>
-                        <a:rPr sz="1500" b="0">
-                          <a:solidFill>
-                            <a:srgbClr val="1A1A1A"/>
-                          </a:solidFill>
-                          <a:latin typeface="Calibri"/>
-                        </a:rPr>
-                        <a:t>13,780 / 9,663</a:t>
-                      </a:r>
-                    </a:p>
-                  </a:txBody>
-                  <a:tcPr>
-                    <a:solidFill>
-                      <a:srgbClr val="FFFFFF"/>
-                    </a:solidFill>
-                  </a:tcPr>
-                </a:tc>
-              </a:tr>
-              <a:tr h="420624">
-                <a:tc>
-                  <a:txBody>
-                    <a:bodyPr/>
-                    <a:lstStyle/>
-                    <a:p>
-                      <a:r>
-                        <a:rPr sz="1500" b="0">
-                          <a:solidFill>
-                            <a:srgbClr val="1A1A1A"/>
-                          </a:solidFill>
-                          <a:latin typeface="Calibri"/>
-                        </a:rPr>
-                        <a:t>26</a:t>
-                      </a:r>
-                    </a:p>
-                  </a:txBody>
-                  <a:tcPr>
-                    <a:solidFill>
-                      <a:srgbClr val="F6F6F6"/>
-                    </a:solidFill>
-                  </a:tcPr>
-                </a:tc>
-                <a:tc>
-                  <a:txBody>
-                    <a:bodyPr/>
-                    <a:lstStyle/>
-                    <a:p>
-                      <a:r>
-                        <a:rPr sz="1500" b="0">
-                          <a:solidFill>
-                            <a:srgbClr val="1A1A1A"/>
-                          </a:solidFill>
-                          <a:latin typeface="Calibri"/>
-                        </a:rPr>
-                        <a:t>58%</a:t>
-                      </a:r>
-                    </a:p>
-                  </a:txBody>
-                  <a:tcPr>
-                    <a:solidFill>
-                      <a:srgbClr val="F6F6F6"/>
-                    </a:solidFill>
-                  </a:tcPr>
-                </a:tc>
-                <a:tc>
-                  <a:txBody>
-                    <a:bodyPr/>
-                    <a:lstStyle/>
-                    <a:p>
-                      <a:r>
-                        <a:rPr sz="1500" b="0">
-                          <a:solidFill>
-                            <a:srgbClr val="1A1A1A"/>
-                          </a:solidFill>
-                          <a:latin typeface="Calibri"/>
-                        </a:rPr>
-                        <a:t>75%</a:t>
-                      </a:r>
-                    </a:p>
-                  </a:txBody>
-                  <a:tcPr>
-                    <a:solidFill>
-                      <a:srgbClr val="F6F6F6"/>
-                    </a:solidFill>
-                  </a:tcPr>
-                </a:tc>
-                <a:tc>
-                  <a:txBody>
-                    <a:bodyPr/>
-                    <a:lstStyle/>
-                    <a:p>
-                      <a:r>
-                        <a:rPr sz="1500" b="0">
-                          <a:solidFill>
-                            <a:srgbClr val="1A1A1A"/>
-                          </a:solidFill>
-                          <a:latin typeface="Calibri"/>
-                        </a:rPr>
-                        <a:t>39,170 / 31,817</a:t>
+                        <a:t>36.1</a:t>
                       </a:r>
                     </a:p>
                   </a:txBody>
@@ -6027,14 +5783,14 @@
       </p:graphicFrame>
       <p:sp>
         <p:nvSpPr>
-          <p:cNvPr id="6" name="TextBox 5"/>
+          <p:cNvPr id="7" name="TextBox 6"/>
           <p:cNvSpPr txBox="1"/>
           <p:nvPr/>
         </p:nvSpPr>
         <p:spPr>
           <a:xfrm>
-            <a:off x="548640" y="4023360"/>
-            <a:ext cx="11064240" cy="2651760"/>
+            <a:off x="548640" y="4206240"/>
+            <a:ext cx="11064240" cy="2194560"/>
           </a:xfrm>
           <a:prstGeom prst="rect">
             <a:avLst/>
@@ -6053,13 +5809,13 @@
               </a:spcAft>
             </a:pPr>
             <a:r>
-              <a:rPr sz="1600" b="0">
+              <a:rPr sz="1800" b="0">
                 <a:solidFill>
                   <a:srgbClr val="1A1A1A"/>
                 </a:solidFill>
                 <a:latin typeface="Calibri"/>
               </a:rPr>
-              <a:t>•  Peg Solitaire: the pagoda bound proves positions lost. From the real start it cuts the search from 139,048 to 82,009 nodes.</a:t>
+              <a:t>•  Safe success means the goal was reached and no move broke a rule, judged by an independent auditor.</a:t>
             </a:r>
           </a:p>
           <a:p>
@@ -6069,13 +5825,13 @@
               </a:spcAft>
             </a:pPr>
             <a:r>
-              <a:rPr sz="1600" b="0">
+              <a:rPr sz="1800" b="0">
                 <a:solidFill>
                   <a:srgbClr val="1A1A1A"/>
                 </a:solidFill>
                 <a:latin typeface="Calibri"/>
               </a:rPr>
-              <a:t>•  24-puzzle and cube: the checker only guards the start. On an unsolvable start the plain search spends its whole budget (60,000 and 400,000 nodes), the check uses at most 1.</a:t>
+              <a:t>•  The validator turns unsafe successes into safe ones. The adaptive solver saves time where one piece moves and ties elsewhere.</a:t>
             </a:r>
           </a:p>
           <a:p>
@@ -6085,13 +5841,13 @@
               </a:spcAft>
             </a:pPr>
             <a:r>
-              <a:rPr sz="1600" b="0">
+              <a:rPr sz="1800" b="0">
                 <a:solidFill>
                   <a:srgbClr val="1A1A1A"/>
                 </a:solidFill>
                 <a:latin typeface="Calibri"/>
               </a:rPr>
-              <a:t>•  Weighted A* solves 100%, 95%, 73% and 57% of 24-puzzle scrambles of 20, 40, 60 and 80 moves. Meet in the middle solves every cube scramble of 4 to 8 moves.</a:t>
+              <a:t>•  Hard Sokoban stays near 53% in every configuration: our extensions do not change it.</a:t>
             </a:r>
           </a:p>
         </p:txBody>
@@ -6148,7 +5904,7 @@
                 </a:solidFill>
                 <a:latin typeface="Calibri"/>
               </a:rPr>
-              <a:t>Results and Discussion: Other Search Methods</a:t>
+              <a:t>Results and Discussion: Boxoban</a:t>
             </a:r>
           </a:p>
         </p:txBody>
@@ -6222,6 +5978,1440 @@
                 </a:solidFill>
                 <a:latin typeface="Calibri"/>
               </a:rPr>
+              <a:t>Share of 1,000 real levels per set solved within a node budget: no pruning vs with checker</a:t>
+            </a:r>
+          </a:p>
+        </p:txBody>
+      </p:sp>
+      <p:graphicFrame>
+        <p:nvGraphicFramePr>
+          <p:cNvPr id="5" name="Table 4"/>
+          <p:cNvGraphicFramePr>
+            <a:graphicFrameLocks noGrp="1"/>
+          </p:cNvGraphicFramePr>
+          <p:nvPr/>
+        </p:nvGraphicFramePr>
+        <p:xfrm>
+          <a:off x="548640" y="1783080"/>
+          <a:ext cx="11064240" cy="2743200"/>
+        </p:xfrm>
+        <a:graphic>
+          <a:graphicData uri="http://schemas.openxmlformats.org/drawingml/2006/table">
+            <a:tbl>
+              <a:tblPr firstRow="1" bandRow="1">
+                <a:tableStyleId>{5C22544A-7EE6-4342-B048-85BDC9FD1C3A}</a:tableStyleId>
+              </a:tblPr>
+              <a:tblGrid>
+                <a:gridCol w="2834640"/>
+                <a:gridCol w="2743200"/>
+                <a:gridCol w="2743200"/>
+                <a:gridCol w="2743200"/>
+              </a:tblGrid>
+              <a:tr h="457200">
+                <a:tc>
+                  <a:txBody>
+                    <a:bodyPr/>
+                    <a:lstStyle/>
+                    <a:p>
+                      <a:r>
+                        <a:rPr sz="1600" b="1">
+                          <a:solidFill>
+                            <a:srgbClr val="FFFFFF"/>
+                          </a:solidFill>
+                          <a:latin typeface="Calibri"/>
+                        </a:rPr>
+                        <a:t>Nodes per search</a:t>
+                      </a:r>
+                    </a:p>
+                  </a:txBody>
+                  <a:tcPr>
+                    <a:solidFill>
+                      <a:srgbClr val="1F4FC8"/>
+                    </a:solidFill>
+                  </a:tcPr>
+                </a:tc>
+                <a:tc>
+                  <a:txBody>
+                    <a:bodyPr/>
+                    <a:lstStyle/>
+                    <a:p>
+                      <a:r>
+                        <a:rPr sz="1600" b="1">
+                          <a:solidFill>
+                            <a:srgbClr val="FFFFFF"/>
+                          </a:solidFill>
+                          <a:latin typeface="Calibri"/>
+                        </a:rPr>
+                        <a:t>Unfiltered</a:t>
+                      </a:r>
+                    </a:p>
+                  </a:txBody>
+                  <a:tcPr>
+                    <a:solidFill>
+                      <a:srgbClr val="1F4FC8"/>
+                    </a:solidFill>
+                  </a:tcPr>
+                </a:tc>
+                <a:tc>
+                  <a:txBody>
+                    <a:bodyPr/>
+                    <a:lstStyle/>
+                    <a:p>
+                      <a:r>
+                        <a:rPr sz="1600" b="1">
+                          <a:solidFill>
+                            <a:srgbClr val="FFFFFF"/>
+                          </a:solidFill>
+                          <a:latin typeface="Calibri"/>
+                        </a:rPr>
+                        <a:t>Medium</a:t>
+                      </a:r>
+                    </a:p>
+                  </a:txBody>
+                  <a:tcPr>
+                    <a:solidFill>
+                      <a:srgbClr val="1F4FC8"/>
+                    </a:solidFill>
+                  </a:tcPr>
+                </a:tc>
+                <a:tc>
+                  <a:txBody>
+                    <a:bodyPr/>
+                    <a:lstStyle/>
+                    <a:p>
+                      <a:r>
+                        <a:rPr sz="1600" b="1">
+                          <a:solidFill>
+                            <a:srgbClr val="FFFFFF"/>
+                          </a:solidFill>
+                          <a:latin typeface="Calibri"/>
+                        </a:rPr>
+                        <a:t>Hard</a:t>
+                      </a:r>
+                    </a:p>
+                  </a:txBody>
+                  <a:tcPr>
+                    <a:solidFill>
+                      <a:srgbClr val="1F4FC8"/>
+                    </a:solidFill>
+                  </a:tcPr>
+                </a:tc>
+              </a:tr>
+              <a:tr h="457200">
+                <a:tc>
+                  <a:txBody>
+                    <a:bodyPr/>
+                    <a:lstStyle/>
+                    <a:p>
+                      <a:r>
+                        <a:rPr sz="1600" b="0">
+                          <a:solidFill>
+                            <a:srgbClr val="1A1A1A"/>
+                          </a:solidFill>
+                          <a:latin typeface="Calibri"/>
+                        </a:rPr>
+                        <a:t>2,000</a:t>
+                      </a:r>
+                    </a:p>
+                  </a:txBody>
+                  <a:tcPr>
+                    <a:solidFill>
+                      <a:srgbClr val="FFFFFF"/>
+                    </a:solidFill>
+                  </a:tcPr>
+                </a:tc>
+                <a:tc>
+                  <a:txBody>
+                    <a:bodyPr/>
+                    <a:lstStyle/>
+                    <a:p>
+                      <a:r>
+                        <a:rPr sz="1600" b="0">
+                          <a:solidFill>
+                            <a:srgbClr val="1A1A1A"/>
+                          </a:solidFill>
+                          <a:latin typeface="Calibri"/>
+                        </a:rPr>
+                        <a:t>57% vs 65%</a:t>
+                      </a:r>
+                    </a:p>
+                  </a:txBody>
+                  <a:tcPr>
+                    <a:solidFill>
+                      <a:srgbClr val="FFFFFF"/>
+                    </a:solidFill>
+                  </a:tcPr>
+                </a:tc>
+                <a:tc>
+                  <a:txBody>
+                    <a:bodyPr/>
+                    <a:lstStyle/>
+                    <a:p>
+                      <a:r>
+                        <a:rPr sz="1600" b="0">
+                          <a:solidFill>
+                            <a:srgbClr val="1A1A1A"/>
+                          </a:solidFill>
+                          <a:latin typeface="Calibri"/>
+                        </a:rPr>
+                        <a:t>14% vs 23%</a:t>
+                      </a:r>
+                    </a:p>
+                  </a:txBody>
+                  <a:tcPr>
+                    <a:solidFill>
+                      <a:srgbClr val="FFFFFF"/>
+                    </a:solidFill>
+                  </a:tcPr>
+                </a:tc>
+                <a:tc>
+                  <a:txBody>
+                    <a:bodyPr/>
+                    <a:lstStyle/>
+                    <a:p>
+                      <a:r>
+                        <a:rPr sz="1600" b="0">
+                          <a:solidFill>
+                            <a:srgbClr val="1A1A1A"/>
+                          </a:solidFill>
+                          <a:latin typeface="Calibri"/>
+                        </a:rPr>
+                        <a:t>6% vs 13%</a:t>
+                      </a:r>
+                    </a:p>
+                  </a:txBody>
+                  <a:tcPr>
+                    <a:solidFill>
+                      <a:srgbClr val="FFFFFF"/>
+                    </a:solidFill>
+                  </a:tcPr>
+                </a:tc>
+              </a:tr>
+              <a:tr h="457200">
+                <a:tc>
+                  <a:txBody>
+                    <a:bodyPr/>
+                    <a:lstStyle/>
+                    <a:p>
+                      <a:r>
+                        <a:rPr sz="1600" b="0">
+                          <a:solidFill>
+                            <a:srgbClr val="1A1A1A"/>
+                          </a:solidFill>
+                          <a:latin typeface="Calibri"/>
+                        </a:rPr>
+                        <a:t>5,000</a:t>
+                      </a:r>
+                    </a:p>
+                  </a:txBody>
+                  <a:tcPr>
+                    <a:solidFill>
+                      <a:srgbClr val="F6F6F6"/>
+                    </a:solidFill>
+                  </a:tcPr>
+                </a:tc>
+                <a:tc>
+                  <a:txBody>
+                    <a:bodyPr/>
+                    <a:lstStyle/>
+                    <a:p>
+                      <a:r>
+                        <a:rPr sz="1600" b="0">
+                          <a:solidFill>
+                            <a:srgbClr val="1A1A1A"/>
+                          </a:solidFill>
+                          <a:latin typeface="Calibri"/>
+                        </a:rPr>
+                        <a:t>73% vs 82%</a:t>
+                      </a:r>
+                    </a:p>
+                  </a:txBody>
+                  <a:tcPr>
+                    <a:solidFill>
+                      <a:srgbClr val="F6F6F6"/>
+                    </a:solidFill>
+                  </a:tcPr>
+                </a:tc>
+                <a:tc>
+                  <a:txBody>
+                    <a:bodyPr/>
+                    <a:lstStyle/>
+                    <a:p>
+                      <a:r>
+                        <a:rPr sz="1600" b="0">
+                          <a:solidFill>
+                            <a:srgbClr val="1A1A1A"/>
+                          </a:solidFill>
+                          <a:latin typeface="Calibri"/>
+                        </a:rPr>
+                        <a:t>29% vs 45%</a:t>
+                      </a:r>
+                    </a:p>
+                  </a:txBody>
+                  <a:tcPr>
+                    <a:solidFill>
+                      <a:srgbClr val="F6F6F6"/>
+                    </a:solidFill>
+                  </a:tcPr>
+                </a:tc>
+                <a:tc>
+                  <a:txBody>
+                    <a:bodyPr/>
+                    <a:lstStyle/>
+                    <a:p>
+                      <a:r>
+                        <a:rPr sz="1600" b="0">
+                          <a:solidFill>
+                            <a:srgbClr val="1A1A1A"/>
+                          </a:solidFill>
+                          <a:latin typeface="Calibri"/>
+                        </a:rPr>
+                        <a:t>16% vs 29%</a:t>
+                      </a:r>
+                    </a:p>
+                  </a:txBody>
+                  <a:tcPr>
+                    <a:solidFill>
+                      <a:srgbClr val="F6F6F6"/>
+                    </a:solidFill>
+                  </a:tcPr>
+                </a:tc>
+              </a:tr>
+              <a:tr h="457200">
+                <a:tc>
+                  <a:txBody>
+                    <a:bodyPr/>
+                    <a:lstStyle/>
+                    <a:p>
+                      <a:r>
+                        <a:rPr sz="1600" b="0">
+                          <a:solidFill>
+                            <a:srgbClr val="1A1A1A"/>
+                          </a:solidFill>
+                          <a:latin typeface="Calibri"/>
+                        </a:rPr>
+                        <a:t>10,000</a:t>
+                      </a:r>
+                    </a:p>
+                  </a:txBody>
+                  <a:tcPr>
+                    <a:solidFill>
+                      <a:srgbClr val="FFFFFF"/>
+                    </a:solidFill>
+                  </a:tcPr>
+                </a:tc>
+                <a:tc>
+                  <a:txBody>
+                    <a:bodyPr/>
+                    <a:lstStyle/>
+                    <a:p>
+                      <a:r>
+                        <a:rPr sz="1600" b="0">
+                          <a:solidFill>
+                            <a:srgbClr val="1A1A1A"/>
+                          </a:solidFill>
+                          <a:latin typeface="Calibri"/>
+                        </a:rPr>
+                        <a:t>84% vs 92%</a:t>
+                      </a:r>
+                    </a:p>
+                  </a:txBody>
+                  <a:tcPr>
+                    <a:solidFill>
+                      <a:srgbClr val="FFFFFF"/>
+                    </a:solidFill>
+                  </a:tcPr>
+                </a:tc>
+                <a:tc>
+                  <a:txBody>
+                    <a:bodyPr/>
+                    <a:lstStyle/>
+                    <a:p>
+                      <a:r>
+                        <a:rPr sz="1600" b="0">
+                          <a:solidFill>
+                            <a:srgbClr val="1A1A1A"/>
+                          </a:solidFill>
+                          <a:latin typeface="Calibri"/>
+                        </a:rPr>
+                        <a:t>46% vs 65%</a:t>
+                      </a:r>
+                    </a:p>
+                  </a:txBody>
+                  <a:tcPr>
+                    <a:solidFill>
+                      <a:srgbClr val="FFFFFF"/>
+                    </a:solidFill>
+                  </a:tcPr>
+                </a:tc>
+                <a:tc>
+                  <a:txBody>
+                    <a:bodyPr/>
+                    <a:lstStyle/>
+                    <a:p>
+                      <a:r>
+                        <a:rPr sz="1600" b="0">
+                          <a:solidFill>
+                            <a:srgbClr val="1A1A1A"/>
+                          </a:solidFill>
+                          <a:latin typeface="Calibri"/>
+                        </a:rPr>
+                        <a:t>27% vs 49%</a:t>
+                      </a:r>
+                    </a:p>
+                  </a:txBody>
+                  <a:tcPr>
+                    <a:solidFill>
+                      <a:srgbClr val="FFFFFF"/>
+                    </a:solidFill>
+                  </a:tcPr>
+                </a:tc>
+              </a:tr>
+              <a:tr h="457200">
+                <a:tc>
+                  <a:txBody>
+                    <a:bodyPr/>
+                    <a:lstStyle/>
+                    <a:p>
+                      <a:r>
+                        <a:rPr sz="1600" b="0">
+                          <a:solidFill>
+                            <a:srgbClr val="1A1A1A"/>
+                          </a:solidFill>
+                          <a:latin typeface="Calibri"/>
+                        </a:rPr>
+                        <a:t>20,000</a:t>
+                      </a:r>
+                    </a:p>
+                  </a:txBody>
+                  <a:tcPr>
+                    <a:solidFill>
+                      <a:srgbClr val="F6F6F6"/>
+                    </a:solidFill>
+                  </a:tcPr>
+                </a:tc>
+                <a:tc>
+                  <a:txBody>
+                    <a:bodyPr/>
+                    <a:lstStyle/>
+                    <a:p>
+                      <a:r>
+                        <a:rPr sz="1600" b="0">
+                          <a:solidFill>
+                            <a:srgbClr val="1A1A1A"/>
+                          </a:solidFill>
+                          <a:latin typeface="Calibri"/>
+                        </a:rPr>
+                        <a:t>92% vs 96%</a:t>
+                      </a:r>
+                    </a:p>
+                  </a:txBody>
+                  <a:tcPr>
+                    <a:solidFill>
+                      <a:srgbClr val="F6F6F6"/>
+                    </a:solidFill>
+                  </a:tcPr>
+                </a:tc>
+                <a:tc>
+                  <a:txBody>
+                    <a:bodyPr/>
+                    <a:lstStyle/>
+                    <a:p>
+                      <a:r>
+                        <a:rPr sz="1600" b="0">
+                          <a:solidFill>
+                            <a:srgbClr val="1A1A1A"/>
+                          </a:solidFill>
+                          <a:latin typeface="Calibri"/>
+                        </a:rPr>
+                        <a:t>61% vs 82%</a:t>
+                      </a:r>
+                    </a:p>
+                  </a:txBody>
+                  <a:tcPr>
+                    <a:solidFill>
+                      <a:srgbClr val="F6F6F6"/>
+                    </a:solidFill>
+                  </a:tcPr>
+                </a:tc>
+                <a:tc>
+                  <a:txBody>
+                    <a:bodyPr/>
+                    <a:lstStyle/>
+                    <a:p>
+                      <a:r>
+                        <a:rPr sz="1600" b="0">
+                          <a:solidFill>
+                            <a:srgbClr val="1A1A1A"/>
+                          </a:solidFill>
+                          <a:latin typeface="Calibri"/>
+                        </a:rPr>
+                        <a:t>44% vs 70%</a:t>
+                      </a:r>
+                    </a:p>
+                  </a:txBody>
+                  <a:tcPr>
+                    <a:solidFill>
+                      <a:srgbClr val="F6F6F6"/>
+                    </a:solidFill>
+                  </a:tcPr>
+                </a:tc>
+              </a:tr>
+              <a:tr h="457200">
+                <a:tc>
+                  <a:txBody>
+                    <a:bodyPr/>
+                    <a:lstStyle/>
+                    <a:p>
+                      <a:r>
+                        <a:rPr sz="1600" b="0">
+                          <a:solidFill>
+                            <a:srgbClr val="1A1A1A"/>
+                          </a:solidFill>
+                          <a:latin typeface="Calibri"/>
+                        </a:rPr>
+                        <a:t>30,000</a:t>
+                      </a:r>
+                    </a:p>
+                  </a:txBody>
+                  <a:tcPr>
+                    <a:solidFill>
+                      <a:srgbClr val="FFFFFF"/>
+                    </a:solidFill>
+                  </a:tcPr>
+                </a:tc>
+                <a:tc>
+                  <a:txBody>
+                    <a:bodyPr/>
+                    <a:lstStyle/>
+                    <a:p>
+                      <a:r>
+                        <a:rPr sz="1600" b="0">
+                          <a:solidFill>
+                            <a:srgbClr val="1A1A1A"/>
+                          </a:solidFill>
+                          <a:latin typeface="Calibri"/>
+                        </a:rPr>
+                        <a:t>95% vs 98%</a:t>
+                      </a:r>
+                    </a:p>
+                  </a:txBody>
+                  <a:tcPr>
+                    <a:solidFill>
+                      <a:srgbClr val="FFFFFF"/>
+                    </a:solidFill>
+                  </a:tcPr>
+                </a:tc>
+                <a:tc>
+                  <a:txBody>
+                    <a:bodyPr/>
+                    <a:lstStyle/>
+                    <a:p>
+                      <a:r>
+                        <a:rPr sz="1600" b="0">
+                          <a:solidFill>
+                            <a:srgbClr val="1A1A1A"/>
+                          </a:solidFill>
+                          <a:latin typeface="Calibri"/>
+                        </a:rPr>
+                        <a:t>71% vs 88%</a:t>
+                      </a:r>
+                    </a:p>
+                  </a:txBody>
+                  <a:tcPr>
+                    <a:solidFill>
+                      <a:srgbClr val="FFFFFF"/>
+                    </a:solidFill>
+                  </a:tcPr>
+                </a:tc>
+                <a:tc>
+                  <a:txBody>
+                    <a:bodyPr/>
+                    <a:lstStyle/>
+                    <a:p>
+                      <a:r>
+                        <a:rPr sz="1600" b="0">
+                          <a:solidFill>
+                            <a:srgbClr val="1A1A1A"/>
+                          </a:solidFill>
+                          <a:latin typeface="Calibri"/>
+                        </a:rPr>
+                        <a:t>54% vs 82%</a:t>
+                      </a:r>
+                    </a:p>
+                  </a:txBody>
+                  <a:tcPr>
+                    <a:solidFill>
+                      <a:srgbClr val="FFFFFF"/>
+                    </a:solidFill>
+                  </a:tcPr>
+                </a:tc>
+              </a:tr>
+            </a:tbl>
+          </a:graphicData>
+        </a:graphic>
+      </p:graphicFrame>
+      <p:sp>
+        <p:nvSpPr>
+          <p:cNvPr id="6" name="TextBox 5"/>
+          <p:cNvSpPr txBox="1"/>
+          <p:nvPr/>
+        </p:nvSpPr>
+        <p:spPr>
+          <a:xfrm>
+            <a:off x="548640" y="4754880"/>
+            <a:ext cx="11064240" cy="1828800"/>
+          </a:xfrm>
+          <a:prstGeom prst="rect">
+            <a:avLst/>
+          </a:prstGeom>
+          <a:noFill/>
+        </p:spPr>
+        <p:txBody>
+          <a:bodyPr wrap="square">
+            <a:spAutoFit/>
+          </a:bodyPr>
+          <a:lstStyle/>
+          <a:p>
+            <a:pPr>
+              <a:spcAft>
+                <a:spcPts val="600"/>
+              </a:spcAft>
+            </a:pPr>
+            <a:r>
+              <a:rPr sz="1800" b="0">
+                <a:solidFill>
+                  <a:srgbClr val="1A1A1A"/>
+                </a:solidFill>
+                <a:latin typeface="Calibri"/>
+              </a:rPr>
+              <a:t>•  The checker wins in all 15 cells, with non-overlapping 95% intervals. It never missed a level the other search solved.</a:t>
+            </a:r>
+          </a:p>
+          <a:p>
+            <a:pPr>
+              <a:spcAft>
+                <a:spcPts val="600"/>
+              </a:spcAft>
+            </a:pPr>
+            <a:r>
+              <a:rPr sz="1800" b="0">
+                <a:solidFill>
+                  <a:srgbClr val="1A1A1A"/>
+                </a:solidFill>
+                <a:latin typeface="Calibri"/>
+              </a:rPr>
+              <a:t>•  It also expands 20% to 25% fewer nodes. Pruning dead corners is standard in Sokoban solvers; this shows our checker works as one on real levels.</a:t>
+            </a:r>
+          </a:p>
+        </p:txBody>
+      </p:sp>
+    </p:spTree>
+  </p:cSld>
+  <p:clrMapOvr>
+    <a:masterClrMapping/>
+  </p:clrMapOvr>
+</p:sld>
+</file>
+
+<file path=ppt/slides/slide15.xml><?xml version="1.0" encoding="utf-8"?>
+<p:sld xmlns:a="http://schemas.openxmlformats.org/drawingml/2006/main" xmlns:p="http://schemas.openxmlformats.org/presentationml/2006/main" xmlns:r="http://schemas.openxmlformats.org/officeDocument/2006/relationships">
+  <p:cSld>
+    <p:spTree>
+      <p:nvGrpSpPr>
+        <p:cNvPr id="1" name=""/>
+        <p:cNvGrpSpPr/>
+        <p:nvPr/>
+      </p:nvGrpSpPr>
+      <p:grpSpPr/>
+      <p:sp>
+        <p:nvSpPr>
+          <p:cNvPr id="2" name="TextBox 1"/>
+          <p:cNvSpPr txBox="1"/>
+          <p:nvPr/>
+        </p:nvSpPr>
+        <p:spPr>
+          <a:xfrm>
+            <a:off x="548640" y="320040"/>
+            <a:ext cx="10972800" cy="731520"/>
+          </a:xfrm>
+          <a:prstGeom prst="rect">
+            <a:avLst/>
+          </a:prstGeom>
+          <a:noFill/>
+        </p:spPr>
+        <p:txBody>
+          <a:bodyPr wrap="square">
+            <a:spAutoFit/>
+          </a:bodyPr>
+          <a:lstStyle/>
+          <a:p>
+            <a:pPr>
+              <a:spcAft>
+                <a:spcPts val="600"/>
+              </a:spcAft>
+            </a:pPr>
+            <a:r>
+              <a:rPr sz="3400" b="1">
+                <a:solidFill>
+                  <a:srgbClr val="1A1A1A"/>
+                </a:solidFill>
+                <a:latin typeface="Calibri"/>
+              </a:rPr>
+              <a:t>Results and Discussion: Harder Games</a:t>
+            </a:r>
+          </a:p>
+        </p:txBody>
+      </p:sp>
+      <p:cxnSp>
+        <p:nvCxnSpPr>
+          <p:cNvPr id="3" name="Connector 2"/>
+          <p:cNvCxnSpPr/>
+          <p:nvPr/>
+        </p:nvCxnSpPr>
+        <p:spPr>
+          <a:xfrm>
+            <a:off x="548640" y="1051560"/>
+            <a:ext cx="11064240" cy="0"/>
+          </a:xfrm>
+          <a:prstGeom prst="line">
+            <a:avLst/>
+          </a:prstGeom>
+          <a:ln w="25400">
+            <a:solidFill>
+              <a:srgbClr val="1F4FC8"/>
+            </a:solidFill>
+          </a:ln>
+        </p:spPr>
+        <p:style>
+          <a:lnRef idx="2">
+            <a:schemeClr val="accent1"/>
+          </a:lnRef>
+          <a:fillRef idx="0">
+            <a:schemeClr val="accent1"/>
+          </a:fillRef>
+          <a:effectRef idx="1">
+            <a:schemeClr val="accent1"/>
+          </a:effectRef>
+          <a:fontRef idx="minor">
+            <a:schemeClr val="tx1"/>
+          </a:fontRef>
+        </p:style>
+      </p:cxnSp>
+      <p:sp>
+        <p:nvSpPr>
+          <p:cNvPr id="4" name="TextBox 3"/>
+          <p:cNvSpPr txBox="1"/>
+          <p:nvPr/>
+        </p:nvSpPr>
+        <p:spPr>
+          <a:xfrm>
+            <a:off x="548640" y="1115568"/>
+            <a:ext cx="10972800" cy="457200"/>
+          </a:xfrm>
+          <a:prstGeom prst="rect">
+            <a:avLst/>
+          </a:prstGeom>
+          <a:noFill/>
+        </p:spPr>
+        <p:txBody>
+          <a:bodyPr wrap="square">
+            <a:spAutoFit/>
+          </a:bodyPr>
+          <a:lstStyle/>
+          <a:p>
+            <a:pPr>
+              <a:spcAft>
+                <a:spcPts val="600"/>
+              </a:spcAft>
+            </a:pPr>
+            <a:r>
+              <a:rPr sz="1600" b="0">
+                <a:solidFill>
+                  <a:srgbClr val="5A5A5A"/>
+                </a:solidFill>
+                <a:latin typeface="Calibri"/>
+              </a:rPr>
+              <a:t>Peg Solitaire, 24-puzzle and Rubik's cube. 60 instances per row, 30 for the cube.</a:t>
+            </a:r>
+          </a:p>
+        </p:txBody>
+      </p:sp>
+      <p:graphicFrame>
+        <p:nvGraphicFramePr>
+          <p:cNvPr id="5" name="Table 4"/>
+          <p:cNvGraphicFramePr>
+            <a:graphicFrameLocks noGrp="1"/>
+          </p:cNvGraphicFramePr>
+          <p:nvPr/>
+        </p:nvGraphicFramePr>
+        <p:xfrm>
+          <a:off x="548640" y="1737360"/>
+          <a:ext cx="11064240" cy="2103120"/>
+        </p:xfrm>
+        <a:graphic>
+          <a:graphicData uri="http://schemas.openxmlformats.org/drawingml/2006/table">
+            <a:tbl>
+              <a:tblPr firstRow="1" bandRow="1">
+                <a:tableStyleId>{5C22544A-7EE6-4342-B048-85BDC9FD1C3A}</a:tableStyleId>
+              </a:tblPr>
+              <a:tblGrid>
+                <a:gridCol w="2651760"/>
+                <a:gridCol w="2651760"/>
+                <a:gridCol w="2743200"/>
+                <a:gridCol w="3017520"/>
+              </a:tblGrid>
+              <a:tr h="420624">
+                <a:tc>
+                  <a:txBody>
+                    <a:bodyPr/>
+                    <a:lstStyle/>
+                    <a:p>
+                      <a:r>
+                        <a:rPr sz="1500" b="1">
+                          <a:solidFill>
+                            <a:srgbClr val="FFFFFF"/>
+                          </a:solidFill>
+                          <a:latin typeface="Calibri"/>
+                        </a:rPr>
+                        <a:t>Jumps from the goal</a:t>
+                      </a:r>
+                    </a:p>
+                  </a:txBody>
+                  <a:tcPr>
+                    <a:solidFill>
+                      <a:srgbClr val="1F4FC8"/>
+                    </a:solidFill>
+                  </a:tcPr>
+                </a:tc>
+                <a:tc>
+                  <a:txBody>
+                    <a:bodyPr/>
+                    <a:lstStyle/>
+                    <a:p>
+                      <a:r>
+                        <a:rPr sz="1500" b="1">
+                          <a:solidFill>
+                            <a:srgbClr val="FFFFFF"/>
+                          </a:solidFill>
+                          <a:latin typeface="Calibri"/>
+                        </a:rPr>
+                        <a:t>Solved, no checker</a:t>
+                      </a:r>
+                    </a:p>
+                  </a:txBody>
+                  <a:tcPr>
+                    <a:solidFill>
+                      <a:srgbClr val="1F4FC8"/>
+                    </a:solidFill>
+                  </a:tcPr>
+                </a:tc>
+                <a:tc>
+                  <a:txBody>
+                    <a:bodyPr/>
+                    <a:lstStyle/>
+                    <a:p>
+                      <a:r>
+                        <a:rPr sz="1500" b="1">
+                          <a:solidFill>
+                            <a:srgbClr val="FFFFFF"/>
+                          </a:solidFill>
+                          <a:latin typeface="Calibri"/>
+                        </a:rPr>
+                        <a:t>Solved, pagoda checker</a:t>
+                      </a:r>
+                    </a:p>
+                  </a:txBody>
+                  <a:tcPr>
+                    <a:solidFill>
+                      <a:srgbClr val="1F4FC8"/>
+                    </a:solidFill>
+                  </a:tcPr>
+                </a:tc>
+                <a:tc>
+                  <a:txBody>
+                    <a:bodyPr/>
+                    <a:lstStyle/>
+                    <a:p>
+                      <a:r>
+                        <a:rPr sz="1500" b="1">
+                          <a:solidFill>
+                            <a:srgbClr val="FFFFFF"/>
+                          </a:solidFill>
+                          <a:latin typeface="Calibri"/>
+                        </a:rPr>
+                        <a:t>Mean nodes, no checker / checker</a:t>
+                      </a:r>
+                    </a:p>
+                  </a:txBody>
+                  <a:tcPr>
+                    <a:solidFill>
+                      <a:srgbClr val="1F4FC8"/>
+                    </a:solidFill>
+                  </a:tcPr>
+                </a:tc>
+              </a:tr>
+              <a:tr h="420624">
+                <a:tc>
+                  <a:txBody>
+                    <a:bodyPr/>
+                    <a:lstStyle/>
+                    <a:p>
+                      <a:r>
+                        <a:rPr sz="1500" b="0">
+                          <a:solidFill>
+                            <a:srgbClr val="1A1A1A"/>
+                          </a:solidFill>
+                          <a:latin typeface="Calibri"/>
+                        </a:rPr>
+                        <a:t>12</a:t>
+                      </a:r>
+                    </a:p>
+                  </a:txBody>
+                  <a:tcPr>
+                    <a:solidFill>
+                      <a:srgbClr val="FFFFFF"/>
+                    </a:solidFill>
+                  </a:tcPr>
+                </a:tc>
+                <a:tc>
+                  <a:txBody>
+                    <a:bodyPr/>
+                    <a:lstStyle/>
+                    <a:p>
+                      <a:r>
+                        <a:rPr sz="1500" b="0">
+                          <a:solidFill>
+                            <a:srgbClr val="1A1A1A"/>
+                          </a:solidFill>
+                          <a:latin typeface="Calibri"/>
+                        </a:rPr>
+                        <a:t>100%</a:t>
+                      </a:r>
+                    </a:p>
+                  </a:txBody>
+                  <a:tcPr>
+                    <a:solidFill>
+                      <a:srgbClr val="FFFFFF"/>
+                    </a:solidFill>
+                  </a:tcPr>
+                </a:tc>
+                <a:tc>
+                  <a:txBody>
+                    <a:bodyPr/>
+                    <a:lstStyle/>
+                    <a:p>
+                      <a:r>
+                        <a:rPr sz="1500" b="0">
+                          <a:solidFill>
+                            <a:srgbClr val="1A1A1A"/>
+                          </a:solidFill>
+                          <a:latin typeface="Calibri"/>
+                        </a:rPr>
+                        <a:t>100%</a:t>
+                      </a:r>
+                    </a:p>
+                  </a:txBody>
+                  <a:tcPr>
+                    <a:solidFill>
+                      <a:srgbClr val="FFFFFF"/>
+                    </a:solidFill>
+                  </a:tcPr>
+                </a:tc>
+                <a:tc>
+                  <a:txBody>
+                    <a:bodyPr/>
+                    <a:lstStyle/>
+                    <a:p>
+                      <a:r>
+                        <a:rPr sz="1500" b="0">
+                          <a:solidFill>
+                            <a:srgbClr val="1A1A1A"/>
+                          </a:solidFill>
+                          <a:latin typeface="Calibri"/>
+                        </a:rPr>
+                        <a:t>296 / 237</a:t>
+                      </a:r>
+                    </a:p>
+                  </a:txBody>
+                  <a:tcPr>
+                    <a:solidFill>
+                      <a:srgbClr val="FFFFFF"/>
+                    </a:solidFill>
+                  </a:tcPr>
+                </a:tc>
+              </a:tr>
+              <a:tr h="420624">
+                <a:tc>
+                  <a:txBody>
+                    <a:bodyPr/>
+                    <a:lstStyle/>
+                    <a:p>
+                      <a:r>
+                        <a:rPr sz="1500" b="0">
+                          <a:solidFill>
+                            <a:srgbClr val="1A1A1A"/>
+                          </a:solidFill>
+                          <a:latin typeface="Calibri"/>
+                        </a:rPr>
+                        <a:t>18</a:t>
+                      </a:r>
+                    </a:p>
+                  </a:txBody>
+                  <a:tcPr>
+                    <a:solidFill>
+                      <a:srgbClr val="F6F6F6"/>
+                    </a:solidFill>
+                  </a:tcPr>
+                </a:tc>
+                <a:tc>
+                  <a:txBody>
+                    <a:bodyPr/>
+                    <a:lstStyle/>
+                    <a:p>
+                      <a:r>
+                        <a:rPr sz="1500" b="0">
+                          <a:solidFill>
+                            <a:srgbClr val="1A1A1A"/>
+                          </a:solidFill>
+                          <a:latin typeface="Calibri"/>
+                        </a:rPr>
+                        <a:t>100%</a:t>
+                      </a:r>
+                    </a:p>
+                  </a:txBody>
+                  <a:tcPr>
+                    <a:solidFill>
+                      <a:srgbClr val="F6F6F6"/>
+                    </a:solidFill>
+                  </a:tcPr>
+                </a:tc>
+                <a:tc>
+                  <a:txBody>
+                    <a:bodyPr/>
+                    <a:lstStyle/>
+                    <a:p>
+                      <a:r>
+                        <a:rPr sz="1500" b="0">
+                          <a:solidFill>
+                            <a:srgbClr val="1A1A1A"/>
+                          </a:solidFill>
+                          <a:latin typeface="Calibri"/>
+                        </a:rPr>
+                        <a:t>100%</a:t>
+                      </a:r>
+                    </a:p>
+                  </a:txBody>
+                  <a:tcPr>
+                    <a:solidFill>
+                      <a:srgbClr val="F6F6F6"/>
+                    </a:solidFill>
+                  </a:tcPr>
+                </a:tc>
+                <a:tc>
+                  <a:txBody>
+                    <a:bodyPr/>
+                    <a:lstStyle/>
+                    <a:p>
+                      <a:r>
+                        <a:rPr sz="1500" b="0">
+                          <a:solidFill>
+                            <a:srgbClr val="1A1A1A"/>
+                          </a:solidFill>
+                          <a:latin typeface="Calibri"/>
+                        </a:rPr>
+                        <a:t>2,776 / 1,914</a:t>
+                      </a:r>
+                    </a:p>
+                  </a:txBody>
+                  <a:tcPr>
+                    <a:solidFill>
+                      <a:srgbClr val="F6F6F6"/>
+                    </a:solidFill>
+                  </a:tcPr>
+                </a:tc>
+              </a:tr>
+              <a:tr h="420624">
+                <a:tc>
+                  <a:txBody>
+                    <a:bodyPr/>
+                    <a:lstStyle/>
+                    <a:p>
+                      <a:r>
+                        <a:rPr sz="1500" b="0">
+                          <a:solidFill>
+                            <a:srgbClr val="1A1A1A"/>
+                          </a:solidFill>
+                          <a:latin typeface="Calibri"/>
+                        </a:rPr>
+                        <a:t>22</a:t>
+                      </a:r>
+                    </a:p>
+                  </a:txBody>
+                  <a:tcPr>
+                    <a:solidFill>
+                      <a:srgbClr val="FFFFFF"/>
+                    </a:solidFill>
+                  </a:tcPr>
+                </a:tc>
+                <a:tc>
+                  <a:txBody>
+                    <a:bodyPr/>
+                    <a:lstStyle/>
+                    <a:p>
+                      <a:r>
+                        <a:rPr sz="1500" b="0">
+                          <a:solidFill>
+                            <a:srgbClr val="1A1A1A"/>
+                          </a:solidFill>
+                          <a:latin typeface="Calibri"/>
+                        </a:rPr>
+                        <a:t>93%</a:t>
+                      </a:r>
+                    </a:p>
+                  </a:txBody>
+                  <a:tcPr>
+                    <a:solidFill>
+                      <a:srgbClr val="FFFFFF"/>
+                    </a:solidFill>
+                  </a:tcPr>
+                </a:tc>
+                <a:tc>
+                  <a:txBody>
+                    <a:bodyPr/>
+                    <a:lstStyle/>
+                    <a:p>
+                      <a:r>
+                        <a:rPr sz="1500" b="0">
+                          <a:solidFill>
+                            <a:srgbClr val="1A1A1A"/>
+                          </a:solidFill>
+                          <a:latin typeface="Calibri"/>
+                        </a:rPr>
+                        <a:t>98%</a:t>
+                      </a:r>
+                    </a:p>
+                  </a:txBody>
+                  <a:tcPr>
+                    <a:solidFill>
+                      <a:srgbClr val="FFFFFF"/>
+                    </a:solidFill>
+                  </a:tcPr>
+                </a:tc>
+                <a:tc>
+                  <a:txBody>
+                    <a:bodyPr/>
+                    <a:lstStyle/>
+                    <a:p>
+                      <a:r>
+                        <a:rPr sz="1500" b="0">
+                          <a:solidFill>
+                            <a:srgbClr val="1A1A1A"/>
+                          </a:solidFill>
+                          <a:latin typeface="Calibri"/>
+                        </a:rPr>
+                        <a:t>13,780 / 9,663</a:t>
+                      </a:r>
+                    </a:p>
+                  </a:txBody>
+                  <a:tcPr>
+                    <a:solidFill>
+                      <a:srgbClr val="FFFFFF"/>
+                    </a:solidFill>
+                  </a:tcPr>
+                </a:tc>
+              </a:tr>
+              <a:tr h="420624">
+                <a:tc>
+                  <a:txBody>
+                    <a:bodyPr/>
+                    <a:lstStyle/>
+                    <a:p>
+                      <a:r>
+                        <a:rPr sz="1500" b="0">
+                          <a:solidFill>
+                            <a:srgbClr val="1A1A1A"/>
+                          </a:solidFill>
+                          <a:latin typeface="Calibri"/>
+                        </a:rPr>
+                        <a:t>26</a:t>
+                      </a:r>
+                    </a:p>
+                  </a:txBody>
+                  <a:tcPr>
+                    <a:solidFill>
+                      <a:srgbClr val="F6F6F6"/>
+                    </a:solidFill>
+                  </a:tcPr>
+                </a:tc>
+                <a:tc>
+                  <a:txBody>
+                    <a:bodyPr/>
+                    <a:lstStyle/>
+                    <a:p>
+                      <a:r>
+                        <a:rPr sz="1500" b="0">
+                          <a:solidFill>
+                            <a:srgbClr val="1A1A1A"/>
+                          </a:solidFill>
+                          <a:latin typeface="Calibri"/>
+                        </a:rPr>
+                        <a:t>58%</a:t>
+                      </a:r>
+                    </a:p>
+                  </a:txBody>
+                  <a:tcPr>
+                    <a:solidFill>
+                      <a:srgbClr val="F6F6F6"/>
+                    </a:solidFill>
+                  </a:tcPr>
+                </a:tc>
+                <a:tc>
+                  <a:txBody>
+                    <a:bodyPr/>
+                    <a:lstStyle/>
+                    <a:p>
+                      <a:r>
+                        <a:rPr sz="1500" b="0">
+                          <a:solidFill>
+                            <a:srgbClr val="1A1A1A"/>
+                          </a:solidFill>
+                          <a:latin typeface="Calibri"/>
+                        </a:rPr>
+                        <a:t>75%</a:t>
+                      </a:r>
+                    </a:p>
+                  </a:txBody>
+                  <a:tcPr>
+                    <a:solidFill>
+                      <a:srgbClr val="F6F6F6"/>
+                    </a:solidFill>
+                  </a:tcPr>
+                </a:tc>
+                <a:tc>
+                  <a:txBody>
+                    <a:bodyPr/>
+                    <a:lstStyle/>
+                    <a:p>
+                      <a:r>
+                        <a:rPr sz="1500" b="0">
+                          <a:solidFill>
+                            <a:srgbClr val="1A1A1A"/>
+                          </a:solidFill>
+                          <a:latin typeface="Calibri"/>
+                        </a:rPr>
+                        <a:t>39,170 / 31,817</a:t>
+                      </a:r>
+                    </a:p>
+                  </a:txBody>
+                  <a:tcPr>
+                    <a:solidFill>
+                      <a:srgbClr val="F6F6F6"/>
+                    </a:solidFill>
+                  </a:tcPr>
+                </a:tc>
+              </a:tr>
+            </a:tbl>
+          </a:graphicData>
+        </a:graphic>
+      </p:graphicFrame>
+      <p:sp>
+        <p:nvSpPr>
+          <p:cNvPr id="6" name="TextBox 5"/>
+          <p:cNvSpPr txBox="1"/>
+          <p:nvPr/>
+        </p:nvSpPr>
+        <p:spPr>
+          <a:xfrm>
+            <a:off x="548640" y="4023360"/>
+            <a:ext cx="11064240" cy="2651760"/>
+          </a:xfrm>
+          <a:prstGeom prst="rect">
+            <a:avLst/>
+          </a:prstGeom>
+          <a:noFill/>
+        </p:spPr>
+        <p:txBody>
+          <a:bodyPr wrap="square">
+            <a:spAutoFit/>
+          </a:bodyPr>
+          <a:lstStyle/>
+          <a:p>
+            <a:pPr>
+              <a:spcAft>
+                <a:spcPts val="600"/>
+              </a:spcAft>
+            </a:pPr>
+            <a:r>
+              <a:rPr sz="1600" b="0">
+                <a:solidFill>
+                  <a:srgbClr val="1A1A1A"/>
+                </a:solidFill>
+                <a:latin typeface="Calibri"/>
+              </a:rPr>
+              <a:t>•  Peg Solitaire: the pagoda bound proves positions lost. From the real start it cuts the search from 139,048 to 82,009 nodes.</a:t>
+            </a:r>
+          </a:p>
+          <a:p>
+            <a:pPr>
+              <a:spcAft>
+                <a:spcPts val="600"/>
+              </a:spcAft>
+            </a:pPr>
+            <a:r>
+              <a:rPr sz="1600" b="0">
+                <a:solidFill>
+                  <a:srgbClr val="1A1A1A"/>
+                </a:solidFill>
+                <a:latin typeface="Calibri"/>
+              </a:rPr>
+              <a:t>•  24-puzzle and cube: the checker only guards the start. On an unsolvable start the plain search spends its whole budget (60,000 and 400,000 nodes), the check uses at most 1.</a:t>
+            </a:r>
+          </a:p>
+          <a:p>
+            <a:pPr>
+              <a:spcAft>
+                <a:spcPts val="600"/>
+              </a:spcAft>
+            </a:pPr>
+            <a:r>
+              <a:rPr sz="1600" b="0">
+                <a:solidFill>
+                  <a:srgbClr val="1A1A1A"/>
+                </a:solidFill>
+                <a:latin typeface="Calibri"/>
+              </a:rPr>
+              <a:t>•  Weighted A* solves 100%, 95%, 73% and 57% of 24-puzzle scrambles of 20, 40, 60 and 80 moves. Meet in the middle solves every cube scramble of 4 to 8 moves.</a:t>
+            </a:r>
+          </a:p>
+        </p:txBody>
+      </p:sp>
+    </p:spTree>
+  </p:cSld>
+  <p:clrMapOvr>
+    <a:masterClrMapping/>
+  </p:clrMapOvr>
+</p:sld>
+</file>
+
+<file path=ppt/slides/slide16.xml><?xml version="1.0" encoding="utf-8"?>
+<p:sld xmlns:a="http://schemas.openxmlformats.org/drawingml/2006/main" xmlns:p="http://schemas.openxmlformats.org/presentationml/2006/main" xmlns:r="http://schemas.openxmlformats.org/officeDocument/2006/relationships">
+  <p:cSld>
+    <p:spTree>
+      <p:nvGrpSpPr>
+        <p:cNvPr id="1" name=""/>
+        <p:cNvGrpSpPr/>
+        <p:nvPr/>
+      </p:nvGrpSpPr>
+      <p:grpSpPr/>
+      <p:sp>
+        <p:nvSpPr>
+          <p:cNvPr id="2" name="TextBox 1"/>
+          <p:cNvSpPr txBox="1"/>
+          <p:nvPr/>
+        </p:nvSpPr>
+        <p:spPr>
+          <a:xfrm>
+            <a:off x="548640" y="320040"/>
+            <a:ext cx="10972800" cy="731520"/>
+          </a:xfrm>
+          <a:prstGeom prst="rect">
+            <a:avLst/>
+          </a:prstGeom>
+          <a:noFill/>
+        </p:spPr>
+        <p:txBody>
+          <a:bodyPr wrap="square">
+            <a:spAutoFit/>
+          </a:bodyPr>
+          <a:lstStyle/>
+          <a:p>
+            <a:pPr>
+              <a:spcAft>
+                <a:spcPts val="600"/>
+              </a:spcAft>
+            </a:pPr>
+            <a:r>
+              <a:rPr sz="3400" b="1">
+                <a:solidFill>
+                  <a:srgbClr val="1A1A1A"/>
+                </a:solidFill>
+                <a:latin typeface="Calibri"/>
+              </a:rPr>
+              <a:t>Results and Discussion: Other Search Methods</a:t>
+            </a:r>
+          </a:p>
+        </p:txBody>
+      </p:sp>
+      <p:cxnSp>
+        <p:nvCxnSpPr>
+          <p:cNvPr id="3" name="Connector 2"/>
+          <p:cNvCxnSpPr/>
+          <p:nvPr/>
+        </p:nvCxnSpPr>
+        <p:spPr>
+          <a:xfrm>
+            <a:off x="548640" y="1051560"/>
+            <a:ext cx="11064240" cy="0"/>
+          </a:xfrm>
+          <a:prstGeom prst="line">
+            <a:avLst/>
+          </a:prstGeom>
+          <a:ln w="25400">
+            <a:solidFill>
+              <a:srgbClr val="1F4FC8"/>
+            </a:solidFill>
+          </a:ln>
+        </p:spPr>
+        <p:style>
+          <a:lnRef idx="2">
+            <a:schemeClr val="accent1"/>
+          </a:lnRef>
+          <a:fillRef idx="0">
+            <a:schemeClr val="accent1"/>
+          </a:fillRef>
+          <a:effectRef idx="1">
+            <a:schemeClr val="accent1"/>
+          </a:effectRef>
+          <a:fontRef idx="minor">
+            <a:schemeClr val="tx1"/>
+          </a:fontRef>
+        </p:style>
+      </p:cxnSp>
+      <p:sp>
+        <p:nvSpPr>
+          <p:cNvPr id="4" name="TextBox 3"/>
+          <p:cNvSpPr txBox="1"/>
+          <p:nvPr/>
+        </p:nvSpPr>
+        <p:spPr>
+          <a:xfrm>
+            <a:off x="548640" y="1115568"/>
+            <a:ext cx="10972800" cy="457200"/>
+          </a:xfrm>
+          <a:prstGeom prst="rect">
+            <a:avLst/>
+          </a:prstGeom>
+          <a:noFill/>
+        </p:spPr>
+        <p:txBody>
+          <a:bodyPr wrap="square">
+            <a:spAutoFit/>
+          </a:bodyPr>
+          <a:lstStyle/>
+          <a:p>
+            <a:pPr>
+              <a:spcAft>
+                <a:spcPts val="600"/>
+              </a:spcAft>
+            </a:pPr>
+            <a:r>
+              <a:rPr sz="1600" b="0">
+                <a:solidFill>
+                  <a:srgbClr val="5A5A5A"/>
+                </a:solidFill>
+                <a:latin typeface="Calibri"/>
+              </a:rPr>
               <a:t>Do BFS, DFS and A* variants help? Share solved within 100,000 nodes, with mean nodes in brackets.</a:t>
             </a:r>
           </a:p>
@@ -7103,7 +8293,7 @@
 </p:sld>
 </file>
 
-<file path=ppt/slides/slide15.xml><?xml version="1.0" encoding="utf-8"?>
+<file path=ppt/slides/slide17.xml><?xml version="1.0" encoding="utf-8"?>
 <p:sld xmlns:a="http://schemas.openxmlformats.org/drawingml/2006/main" xmlns:p="http://schemas.openxmlformats.org/presentationml/2006/main" xmlns:r="http://schemas.openxmlformats.org/officeDocument/2006/relationships">
   <p:cSld>
     <p:spTree>
@@ -7648,7 +8838,7 @@
 </p:sld>
 </file>
 
-<file path=ppt/slides/slide16.xml><?xml version="1.0" encoding="utf-8"?>
+<file path=ppt/slides/slide18.xml><?xml version="1.0" encoding="utf-8"?>
 <p:sld xmlns:a="http://schemas.openxmlformats.org/drawingml/2006/main" xmlns:p="http://schemas.openxmlformats.org/presentationml/2006/main" xmlns:r="http://schemas.openxmlformats.org/officeDocument/2006/relationships">
   <p:cSld>
     <p:spTree>
@@ -7924,7 +9114,7 @@
                 </a:solidFill>
                 <a:latin typeface="Calibri"/>
               </a:rPr>
-              <a:t>•  Finish the research paper (full draft written, with figures).</a:t>
+              <a:t>•  Finish the research paper (full draft written, with figures). Add a learned proposer to the demo's failure scenarios.</a:t>
             </a:r>
           </a:p>
         </p:txBody>
@@ -7937,7 +9127,7 @@
 </p:sld>
 </file>
 
-<file path=ppt/slides/slide17.xml><?xml version="1.0" encoding="utf-8"?>
+<file path=ppt/slides/slide19.xml><?xml version="1.0" encoding="utf-8"?>
 <p:sld xmlns:a="http://schemas.openxmlformats.org/drawingml/2006/main" xmlns:p="http://schemas.openxmlformats.org/presentationml/2006/main" xmlns:r="http://schemas.openxmlformats.org/officeDocument/2006/relationships">
   <p:cSld>
     <p:spTree>
@@ -10798,7 +11988,7 @@
                 </a:solidFill>
                 <a:latin typeface="Calibri"/>
               </a:rPr>
-              <a:t>Proposers are synthetic programs; no language model is used.</a:t>
+              <a:t>Proposers are synthetic programs; no language model is used. Seven games share this pipeline unchanged.</a:t>
             </a:r>
           </a:p>
         </p:txBody>
@@ -12822,7 +14012,7 @@
                 </a:solidFill>
                 <a:latin typeface="Calibri"/>
               </a:rPr>
-              <a:t>About 2,300 lines in src/tape, 1,500 in experiments, 1,000 in tests. 90 automated tests pass. Interactive demo with a tab per game and a 3D Rubik's cube. Code: github.com/Harsh-v69/MachineLearningCP</a:t>
+              <a:t>About 2,300 lines in src/tape, 1,500 in experiments, 1,000 in tests. 90 automated tests pass. Interactive 3D demo with a tab per game. Code: github.com/Harsh-v69/MachineLearningCP</a:t>
             </a:r>
           </a:p>
         </p:txBody>

</xml_diff>

<commit_message>
Review deck: team contributions slide
Co-Authored-By: Claude Sonnet 5.5 <noreply@anthropic.com>
</commit_message>
<xml_diff>
--- a/docs/CP_Project_Review.pptx
+++ b/docs/CP_Project_Review.pptx
@@ -24,6 +24,7 @@
     <p:sldId id="272" r:id="rId23"/>
     <p:sldId id="273" r:id="rId24"/>
     <p:sldId id="274" r:id="rId25"/>
+    <p:sldId id="275" r:id="rId26"/>
   </p:sldIdLst>
   <p:sldSz cx="12191695" cy="6858000" type="screen4x3"/>
   <p:notesSz cx="6858000" cy="9144000"/>
@@ -8882,6 +8883,543 @@
                 </a:solidFill>
                 <a:latin typeface="Calibri"/>
               </a:rPr>
+              <a:t>Team Contributions</a:t>
+            </a:r>
+          </a:p>
+        </p:txBody>
+      </p:sp>
+      <p:cxnSp>
+        <p:nvCxnSpPr>
+          <p:cNvPr id="3" name="Connector 2"/>
+          <p:cNvCxnSpPr/>
+          <p:nvPr/>
+        </p:nvCxnSpPr>
+        <p:spPr>
+          <a:xfrm>
+            <a:off x="548640" y="1051560"/>
+            <a:ext cx="11064240" cy="0"/>
+          </a:xfrm>
+          <a:prstGeom prst="line">
+            <a:avLst/>
+          </a:prstGeom>
+          <a:ln w="25400">
+            <a:solidFill>
+              <a:srgbClr val="1F4FC8"/>
+            </a:solidFill>
+          </a:ln>
+        </p:spPr>
+        <p:style>
+          <a:lnRef idx="2">
+            <a:schemeClr val="accent1"/>
+          </a:lnRef>
+          <a:fillRef idx="0">
+            <a:schemeClr val="accent1"/>
+          </a:fillRef>
+          <a:effectRef idx="1">
+            <a:schemeClr val="accent1"/>
+          </a:effectRef>
+          <a:fontRef idx="minor">
+            <a:schemeClr val="tx1"/>
+          </a:fontRef>
+        </p:style>
+      </p:cxnSp>
+      <p:sp>
+        <p:nvSpPr>
+          <p:cNvPr id="4" name="TextBox 3"/>
+          <p:cNvSpPr txBox="1"/>
+          <p:nvPr/>
+        </p:nvSpPr>
+        <p:spPr>
+          <a:xfrm>
+            <a:off x="548640" y="1115568"/>
+            <a:ext cx="10972800" cy="457200"/>
+          </a:xfrm>
+          <a:prstGeom prst="rect">
+            <a:avLst/>
+          </a:prstGeom>
+          <a:noFill/>
+        </p:spPr>
+        <p:txBody>
+          <a:bodyPr wrap="square">
+            <a:spAutoFit/>
+          </a:bodyPr>
+          <a:lstStyle/>
+          <a:p>
+            <a:pPr>
+              <a:spcAft>
+                <a:spcPts val="600"/>
+              </a:spcAft>
+            </a:pPr>
+            <a:r>
+              <a:rPr sz="1600" b="0">
+                <a:solidFill>
+                  <a:srgbClr val="5A5A5A"/>
+                </a:solidFill>
+                <a:latin typeface="Calibri"/>
+              </a:rPr>
+              <a:t>Group 3. Each member owns one part of the project, from code to results.</a:t>
+            </a:r>
+          </a:p>
+        </p:txBody>
+      </p:sp>
+      <p:graphicFrame>
+        <p:nvGraphicFramePr>
+          <p:cNvPr id="5" name="Table 4"/>
+          <p:cNvGraphicFramePr>
+            <a:graphicFrameLocks noGrp="1"/>
+          </p:cNvGraphicFramePr>
+          <p:nvPr/>
+        </p:nvGraphicFramePr>
+        <p:xfrm>
+          <a:off x="548640" y="1737360"/>
+          <a:ext cx="11064240" cy="3291839"/>
+        </p:xfrm>
+        <a:graphic>
+          <a:graphicData uri="http://schemas.openxmlformats.org/drawingml/2006/table">
+            <a:tbl>
+              <a:tblPr firstRow="1" bandRow="1">
+                <a:tableStyleId>{5C22544A-7EE6-4342-B048-85BDC9FD1C3A}</a:tableStyleId>
+              </a:tblPr>
+              <a:tblGrid>
+                <a:gridCol w="2377440"/>
+                <a:gridCol w="2651760"/>
+                <a:gridCol w="6035040"/>
+              </a:tblGrid>
+              <a:tr h="658367">
+                <a:tc>
+                  <a:txBody>
+                    <a:bodyPr/>
+                    <a:lstStyle/>
+                    <a:p>
+                      <a:r>
+                        <a:rPr sz="1400" b="1">
+                          <a:solidFill>
+                            <a:srgbClr val="FFFFFF"/>
+                          </a:solidFill>
+                          <a:latin typeface="Calibri"/>
+                        </a:rPr>
+                        <a:t>Member</a:t>
+                      </a:r>
+                    </a:p>
+                  </a:txBody>
+                  <a:tcPr>
+                    <a:solidFill>
+                      <a:srgbClr val="1F4FC8"/>
+                    </a:solidFill>
+                  </a:tcPr>
+                </a:tc>
+                <a:tc>
+                  <a:txBody>
+                    <a:bodyPr/>
+                    <a:lstStyle/>
+                    <a:p>
+                      <a:r>
+                        <a:rPr sz="1400" b="1">
+                          <a:solidFill>
+                            <a:srgbClr val="FFFFFF"/>
+                          </a:solidFill>
+                          <a:latin typeface="Calibri"/>
+                        </a:rPr>
+                        <a:t>Role</a:t>
+                      </a:r>
+                    </a:p>
+                  </a:txBody>
+                  <a:tcPr>
+                    <a:solidFill>
+                      <a:srgbClr val="1F4FC8"/>
+                    </a:solidFill>
+                  </a:tcPr>
+                </a:tc>
+                <a:tc>
+                  <a:txBody>
+                    <a:bodyPr/>
+                    <a:lstStyle/>
+                    <a:p>
+                      <a:r>
+                        <a:rPr sz="1400" b="1">
+                          <a:solidFill>
+                            <a:srgbClr val="FFFFFF"/>
+                          </a:solidFill>
+                          <a:latin typeface="Calibri"/>
+                        </a:rPr>
+                        <a:t>Work</a:t>
+                      </a:r>
+                    </a:p>
+                  </a:txBody>
+                  <a:tcPr>
+                    <a:solidFill>
+                      <a:srgbClr val="1F4FC8"/>
+                    </a:solidFill>
+                  </a:tcPr>
+                </a:tc>
+              </a:tr>
+              <a:tr h="658367">
+                <a:tc>
+                  <a:txBody>
+                    <a:bodyPr/>
+                    <a:lstStyle/>
+                    <a:p>
+                      <a:r>
+                        <a:rPr sz="1400" b="0">
+                          <a:solidFill>
+                            <a:srgbClr val="1A1A1A"/>
+                          </a:solidFill>
+                          <a:latin typeface="Calibri"/>
+                        </a:rPr>
+                        <a:t>Harshvardhan Rawat</a:t>
+                      </a:r>
+                    </a:p>
+                  </a:txBody>
+                  <a:tcPr>
+                    <a:solidFill>
+                      <a:srgbClr val="FFFFFF"/>
+                    </a:solidFill>
+                  </a:tcPr>
+                </a:tc>
+                <a:tc>
+                  <a:txBody>
+                    <a:bodyPr/>
+                    <a:lstStyle/>
+                    <a:p>
+                      <a:r>
+                        <a:rPr sz="1400" b="0">
+                          <a:solidFill>
+                            <a:srgbClr val="1A1A1A"/>
+                          </a:solidFill>
+                          <a:latin typeface="Calibri"/>
+                        </a:rPr>
+                        <a:t>Project lead, core pipeline</a:t>
+                      </a:r>
+                    </a:p>
+                  </a:txBody>
+                  <a:tcPr>
+                    <a:solidFill>
+                      <a:srgbClr val="FFFFFF"/>
+                    </a:solidFill>
+                  </a:tcPr>
+                </a:tc>
+                <a:tc>
+                  <a:txBody>
+                    <a:bodyPr/>
+                    <a:lstStyle/>
+                    <a:p>
+                      <a:r>
+                        <a:rPr sz="1400" b="0">
+                          <a:solidFill>
+                            <a:srgbClr val="1A1A1A"/>
+                          </a:solidFill>
+                          <a:latin typeface="Calibri"/>
+                        </a:rPr>
+                        <a:t>Plan graph, CP-SAT and A* solvers, adaptive selection, experience store, move scoring, replanning, integration</a:t>
+                      </a:r>
+                    </a:p>
+                  </a:txBody>
+                  <a:tcPr>
+                    <a:solidFill>
+                      <a:srgbClr val="FFFFFF"/>
+                    </a:solidFill>
+                  </a:tcPr>
+                </a:tc>
+              </a:tr>
+              <a:tr h="658367">
+                <a:tc>
+                  <a:txBody>
+                    <a:bodyPr/>
+                    <a:lstStyle/>
+                    <a:p>
+                      <a:r>
+                        <a:rPr sz="1400" b="0">
+                          <a:solidFill>
+                            <a:srgbClr val="1A1A1A"/>
+                          </a:solidFill>
+                          <a:latin typeface="Calibri"/>
+                        </a:rPr>
+                        <a:t>Divyanshu Gajbhiye</a:t>
+                      </a:r>
+                    </a:p>
+                  </a:txBody>
+                  <a:tcPr>
+                    <a:solidFill>
+                      <a:srgbClr val="F6F6F6"/>
+                    </a:solidFill>
+                  </a:tcPr>
+                </a:tc>
+                <a:tc>
+                  <a:txBody>
+                    <a:bodyPr/>
+                    <a:lstStyle/>
+                    <a:p>
+                      <a:r>
+                        <a:rPr sz="1400" b="0">
+                          <a:solidFill>
+                            <a:srgbClr val="1A1A1A"/>
+                          </a:solidFill>
+                          <a:latin typeface="Calibri"/>
+                        </a:rPr>
+                        <a:t>Games, rule checkers, proposers</a:t>
+                      </a:r>
+                    </a:p>
+                  </a:txBody>
+                  <a:tcPr>
+                    <a:solidFill>
+                      <a:srgbClr val="F6F6F6"/>
+                    </a:solidFill>
+                  </a:tcPr>
+                </a:tc>
+                <a:tc>
+                  <a:txBody>
+                    <a:bodyPr/>
+                    <a:lstStyle/>
+                    <a:p>
+                      <a:r>
+                        <a:rPr sz="1400" b="0">
+                          <a:solidFill>
+                            <a:srgbClr val="1A1A1A"/>
+                          </a:solidFill>
+                          <a:latin typeface="Calibri"/>
+                        </a:rPr>
+                        <a:t>Seven games, per-game checkers (corner, safety, gridlock, pagoda bound, parity, cube invariants), search proposers</a:t>
+                      </a:r>
+                    </a:p>
+                  </a:txBody>
+                  <a:tcPr>
+                    <a:solidFill>
+                      <a:srgbClr val="F6F6F6"/>
+                    </a:solidFill>
+                  </a:tcPr>
+                </a:tc>
+              </a:tr>
+              <a:tr h="658367">
+                <a:tc>
+                  <a:txBody>
+                    <a:bodyPr/>
+                    <a:lstStyle/>
+                    <a:p>
+                      <a:r>
+                        <a:rPr sz="1400" b="0">
+                          <a:solidFill>
+                            <a:srgbClr val="1A1A1A"/>
+                          </a:solidFill>
+                          <a:latin typeface="Calibri"/>
+                        </a:rPr>
+                        <a:t>Vidhi Hadoltikar</a:t>
+                      </a:r>
+                    </a:p>
+                  </a:txBody>
+                  <a:tcPr>
+                    <a:solidFill>
+                      <a:srgbClr val="FFFFFF"/>
+                    </a:solidFill>
+                  </a:tcPr>
+                </a:tc>
+                <a:tc>
+                  <a:txBody>
+                    <a:bodyPr/>
+                    <a:lstStyle/>
+                    <a:p>
+                      <a:r>
+                        <a:rPr sz="1400" b="0">
+                          <a:solidFill>
+                            <a:srgbClr val="1A1A1A"/>
+                          </a:solidFill>
+                          <a:latin typeface="Calibri"/>
+                        </a:rPr>
+                        <a:t>Experiments and evaluation</a:t>
+                      </a:r>
+                    </a:p>
+                  </a:txBody>
+                  <a:tcPr>
+                    <a:solidFill>
+                      <a:srgbClr val="FFFFFF"/>
+                    </a:solidFill>
+                  </a:tcPr>
+                </a:tc>
+                <a:tc>
+                  <a:txBody>
+                    <a:bodyPr/>
+                    <a:lstStyle/>
+                    <a:p>
+                      <a:r>
+                        <a:rPr sz="1400" b="0">
+                          <a:solidFill>
+                            <a:srgbClr val="1A1A1A"/>
+                          </a:solidFill>
+                          <a:latin typeface="Calibri"/>
+                        </a:rPr>
+                        <a:t>Ablation, memory test, weight tuning, proposer sweep, Boxoban, harder games, search-method comparison</a:t>
+                      </a:r>
+                    </a:p>
+                  </a:txBody>
+                  <a:tcPr>
+                    <a:solidFill>
+                      <a:srgbClr val="FFFFFF"/>
+                    </a:solidFill>
+                  </a:tcPr>
+                </a:tc>
+              </a:tr>
+              <a:tr h="658371">
+                <a:tc>
+                  <a:txBody>
+                    <a:bodyPr/>
+                    <a:lstStyle/>
+                    <a:p>
+                      <a:r>
+                        <a:rPr sz="1400" b="0">
+                          <a:solidFill>
+                            <a:srgbClr val="1A1A1A"/>
+                          </a:solidFill>
+                          <a:latin typeface="Calibri"/>
+                        </a:rPr>
+                        <a:t>Nirmit Hatti</a:t>
+                      </a:r>
+                    </a:p>
+                  </a:txBody>
+                  <a:tcPr>
+                    <a:solidFill>
+                      <a:srgbClr val="F6F6F6"/>
+                    </a:solidFill>
+                  </a:tcPr>
+                </a:tc>
+                <a:tc>
+                  <a:txBody>
+                    <a:bodyPr/>
+                    <a:lstStyle/>
+                    <a:p>
+                      <a:r>
+                        <a:rPr sz="1400" b="0">
+                          <a:solidFill>
+                            <a:srgbClr val="1A1A1A"/>
+                          </a:solidFill>
+                          <a:latin typeface="Calibri"/>
+                        </a:rPr>
+                        <a:t>Demo, documentation, paper</a:t>
+                      </a:r>
+                    </a:p>
+                  </a:txBody>
+                  <a:tcPr>
+                    <a:solidFill>
+                      <a:srgbClr val="F6F6F6"/>
+                    </a:solidFill>
+                  </a:tcPr>
+                </a:tc>
+                <a:tc>
+                  <a:txBody>
+                    <a:bodyPr/>
+                    <a:lstStyle/>
+                    <a:p>
+                      <a:r>
+                        <a:rPr sz="1400" b="0">
+                          <a:solidFill>
+                            <a:srgbClr val="1A1A1A"/>
+                          </a:solidFill>
+                          <a:latin typeface="Calibri"/>
+                        </a:rPr>
+                        <a:t>Interactive 3D demo, flow diagram, review deck, research paper, literature survey</a:t>
+                      </a:r>
+                    </a:p>
+                  </a:txBody>
+                  <a:tcPr>
+                    <a:solidFill>
+                      <a:srgbClr val="F6F6F6"/>
+                    </a:solidFill>
+                  </a:tcPr>
+                </a:tc>
+              </a:tr>
+            </a:tbl>
+          </a:graphicData>
+        </a:graphic>
+      </p:graphicFrame>
+      <p:sp>
+        <p:nvSpPr>
+          <p:cNvPr id="6" name="TextBox 5"/>
+          <p:cNvSpPr txBox="1"/>
+          <p:nvPr/>
+        </p:nvSpPr>
+        <p:spPr>
+          <a:xfrm>
+            <a:off x="548640" y="5669280"/>
+            <a:ext cx="11064240" cy="822960"/>
+          </a:xfrm>
+          <a:prstGeom prst="rect">
+            <a:avLst/>
+          </a:prstGeom>
+          <a:noFill/>
+        </p:spPr>
+        <p:txBody>
+          <a:bodyPr wrap="square">
+            <a:spAutoFit/>
+          </a:bodyPr>
+          <a:lstStyle/>
+          <a:p>
+            <a:pPr>
+              <a:spcAft>
+                <a:spcPts val="600"/>
+              </a:spcAft>
+            </a:pPr>
+            <a:r>
+              <a:rPr sz="1600" b="0">
+                <a:solidFill>
+                  <a:srgbClr val="5A5A5A"/>
+                </a:solidFill>
+                <a:latin typeface="Calibri"/>
+              </a:rPr>
+              <a:t>Each member owns the tests for their files, and work is cross-reviewed in pairs. Guide: Dr. Premanand P Ghadekar.</a:t>
+            </a:r>
+          </a:p>
+        </p:txBody>
+      </p:sp>
+    </p:spTree>
+  </p:cSld>
+  <p:clrMapOvr>
+    <a:masterClrMapping/>
+  </p:clrMapOvr>
+</p:sld>
+</file>
+
+<file path=ppt/slides/slide19.xml><?xml version="1.0" encoding="utf-8"?>
+<p:sld xmlns:a="http://schemas.openxmlformats.org/drawingml/2006/main" xmlns:p="http://schemas.openxmlformats.org/presentationml/2006/main" xmlns:r="http://schemas.openxmlformats.org/officeDocument/2006/relationships">
+  <p:cSld>
+    <p:spTree>
+      <p:nvGrpSpPr>
+        <p:cNvPr id="1" name=""/>
+        <p:cNvGrpSpPr/>
+        <p:nvPr/>
+      </p:nvGrpSpPr>
+      <p:grpSpPr/>
+      <p:sp>
+        <p:nvSpPr>
+          <p:cNvPr id="2" name="TextBox 1"/>
+          <p:cNvSpPr txBox="1"/>
+          <p:nvPr/>
+        </p:nvSpPr>
+        <p:spPr>
+          <a:xfrm>
+            <a:off x="548640" y="320040"/>
+            <a:ext cx="10972800" cy="731520"/>
+          </a:xfrm>
+          <a:prstGeom prst="rect">
+            <a:avLst/>
+          </a:prstGeom>
+          <a:noFill/>
+        </p:spPr>
+        <p:txBody>
+          <a:bodyPr wrap="square">
+            <a:spAutoFit/>
+          </a:bodyPr>
+          <a:lstStyle/>
+          <a:p>
+            <a:pPr>
+              <a:spcAft>
+                <a:spcPts val="600"/>
+              </a:spcAft>
+            </a:pPr>
+            <a:r>
+              <a:rPr sz="3400" b="1">
+                <a:solidFill>
+                  <a:srgbClr val="1A1A1A"/>
+                </a:solidFill>
+                <a:latin typeface="Calibri"/>
+              </a:rPr>
               <a:t>Conclusion</a:t>
             </a:r>
           </a:p>
@@ -9127,7 +9665,202 @@
 </p:sld>
 </file>
 
-<file path=ppt/slides/slide19.xml><?xml version="1.0" encoding="utf-8"?>
+<file path=ppt/slides/slide2.xml><?xml version="1.0" encoding="utf-8"?>
+<p:sld xmlns:a="http://schemas.openxmlformats.org/drawingml/2006/main" xmlns:p="http://schemas.openxmlformats.org/presentationml/2006/main" xmlns:r="http://schemas.openxmlformats.org/officeDocument/2006/relationships">
+  <p:cSld>
+    <p:spTree>
+      <p:nvGrpSpPr>
+        <p:cNvPr id="1" name=""/>
+        <p:cNvGrpSpPr/>
+        <p:nvPr/>
+      </p:nvGrpSpPr>
+      <p:grpSpPr/>
+      <p:sp>
+        <p:nvSpPr>
+          <p:cNvPr id="2" name="TextBox 1"/>
+          <p:cNvSpPr txBox="1"/>
+          <p:nvPr/>
+        </p:nvSpPr>
+        <p:spPr>
+          <a:xfrm>
+            <a:off x="548640" y="320040"/>
+            <a:ext cx="10972800" cy="731520"/>
+          </a:xfrm>
+          <a:prstGeom prst="rect">
+            <a:avLst/>
+          </a:prstGeom>
+          <a:noFill/>
+        </p:spPr>
+        <p:txBody>
+          <a:bodyPr wrap="square">
+            <a:spAutoFit/>
+          </a:bodyPr>
+          <a:lstStyle/>
+          <a:p>
+            <a:pPr>
+              <a:spcAft>
+                <a:spcPts val="600"/>
+              </a:spcAft>
+            </a:pPr>
+            <a:r>
+              <a:rPr sz="3400" b="1">
+                <a:solidFill>
+                  <a:srgbClr val="1A1A1A"/>
+                </a:solidFill>
+                <a:latin typeface="Calibri"/>
+              </a:rPr>
+              <a:t>Introduction</a:t>
+            </a:r>
+          </a:p>
+        </p:txBody>
+      </p:sp>
+      <p:cxnSp>
+        <p:nvCxnSpPr>
+          <p:cNvPr id="3" name="Connector 2"/>
+          <p:cNvCxnSpPr/>
+          <p:nvPr/>
+        </p:nvCxnSpPr>
+        <p:spPr>
+          <a:xfrm>
+            <a:off x="548640" y="1051560"/>
+            <a:ext cx="11064240" cy="0"/>
+          </a:xfrm>
+          <a:prstGeom prst="line">
+            <a:avLst/>
+          </a:prstGeom>
+          <a:ln w="25400">
+            <a:solidFill>
+              <a:srgbClr val="1F4FC8"/>
+            </a:solidFill>
+          </a:ln>
+        </p:spPr>
+        <p:style>
+          <a:lnRef idx="2">
+            <a:schemeClr val="accent1"/>
+          </a:lnRef>
+          <a:fillRef idx="0">
+            <a:schemeClr val="accent1"/>
+          </a:fillRef>
+          <a:effectRef idx="1">
+            <a:schemeClr val="accent1"/>
+          </a:effectRef>
+          <a:fontRef idx="minor">
+            <a:schemeClr val="tx1"/>
+          </a:fontRef>
+        </p:style>
+      </p:cxnSp>
+      <p:sp>
+        <p:nvSpPr>
+          <p:cNvPr id="4" name="TextBox 3"/>
+          <p:cNvSpPr txBox="1"/>
+          <p:nvPr/>
+        </p:nvSpPr>
+        <p:spPr>
+          <a:xfrm>
+            <a:off x="548640" y="1371600"/>
+            <a:ext cx="11064240" cy="5029200"/>
+          </a:xfrm>
+          <a:prstGeom prst="rect">
+            <a:avLst/>
+          </a:prstGeom>
+          <a:noFill/>
+        </p:spPr>
+        <p:txBody>
+          <a:bodyPr wrap="square">
+            <a:spAutoFit/>
+          </a:bodyPr>
+          <a:lstStyle/>
+          <a:p>
+            <a:pPr>
+              <a:spcAft>
+                <a:spcPts val="600"/>
+              </a:spcAft>
+            </a:pPr>
+            <a:r>
+              <a:rPr sz="2200" b="0">
+                <a:solidFill>
+                  <a:srgbClr val="1A1A1A"/>
+                </a:solidFill>
+                <a:latin typeface="Calibri"/>
+              </a:rPr>
+              <a:t>•  Long-horizon planning is hard for language-model agents: a single plan often fails midway.</a:t>
+            </a:r>
+          </a:p>
+          <a:p>
+            <a:pPr>
+              <a:spcAft>
+                <a:spcPts val="600"/>
+              </a:spcAft>
+            </a:pPr>
+            <a:r>
+              <a:rPr sz="2200" b="0">
+                <a:solidFill>
+                  <a:srgbClr val="1A1A1A"/>
+                </a:solidFill>
+                <a:latin typeface="Calibri"/>
+              </a:rPr>
+              <a:t>•  TAPE (Jeong et al., 2026) generates several candidate plans, merges them into one plan graph, picks a path with an external solver (ILP), executes it, and replans when reality differs.</a:t>
+            </a:r>
+          </a:p>
+          <a:p>
+            <a:pPr>
+              <a:spcAft>
+                <a:spcPts val="600"/>
+              </a:spcAft>
+            </a:pPr>
+            <a:r>
+              <a:rPr sz="2200" b="0">
+                <a:solidFill>
+                  <a:srgbClr val="1A1A1A"/>
+                </a:solidFill>
+                <a:latin typeface="Calibri"/>
+              </a:rPr>
+              <a:t>•  A plan graph is only as good as the plans behind it, and the solver is fixed in advance.</a:t>
+            </a:r>
+          </a:p>
+          <a:p>
+            <a:pPr>
+              <a:spcAft>
+                <a:spcPts val="600"/>
+              </a:spcAft>
+            </a:pPr>
+            <a:r>
+              <a:rPr sz="2200" b="0">
+                <a:solidFill>
+                  <a:srgbClr val="1A1A1A"/>
+                </a:solidFill>
+                <a:latin typeface="Calibri"/>
+              </a:rPr>
+              <a:t>•  Our project adds a checking and selection layer on top of the TAPE pipeline: validate moves, learn from failures, score moves, and choose the solver per task.</a:t>
+            </a:r>
+          </a:p>
+          <a:p>
+            <a:pPr>
+              <a:spcAft>
+                <a:spcPts val="600"/>
+              </a:spcAft>
+            </a:pPr>
+            <a:r>
+              <a:rPr sz="2200" b="0">
+                <a:solidFill>
+                  <a:srgbClr val="1A1A1A"/>
+                </a:solidFill>
+                <a:latin typeface="Calibri"/>
+              </a:rPr>
+              <a:t>•  Tested on seven games: Sokoban, River Crossing, Rush Hour, Peg Solitaire, the 24-puzzle, the Rubik's cube and 3,000 Boxoban levels.</a:t>
+            </a:r>
+          </a:p>
+        </p:txBody>
+      </p:sp>
+    </p:spTree>
+  </p:cSld>
+  <p:clrMapOvr>
+    <a:masterClrMapping/>
+  </p:clrMapOvr>
+</p:sld>
+</file>
+
+<file path=ppt/slides/slide20.xml><?xml version="1.0" encoding="utf-8"?>
 <p:sld xmlns:a="http://schemas.openxmlformats.org/drawingml/2006/main" xmlns:p="http://schemas.openxmlformats.org/presentationml/2006/main" xmlns:r="http://schemas.openxmlformats.org/officeDocument/2006/relationships">
   <p:cSld>
     <p:spTree>
@@ -9589,201 +10322,6 @@
                 <a:latin typeface="Calibri"/>
               </a:rPr>
               <a:t>[21] E. A. Hansen, S. Zilberstein, "LAO*: A heuristic search algorithm that finds solutions with loops," Artificial Intelligence 129(1-2):35-62, 2001.</a:t>
-            </a:r>
-          </a:p>
-        </p:txBody>
-      </p:sp>
-    </p:spTree>
-  </p:cSld>
-  <p:clrMapOvr>
-    <a:masterClrMapping/>
-  </p:clrMapOvr>
-</p:sld>
-</file>
-
-<file path=ppt/slides/slide2.xml><?xml version="1.0" encoding="utf-8"?>
-<p:sld xmlns:a="http://schemas.openxmlformats.org/drawingml/2006/main" xmlns:p="http://schemas.openxmlformats.org/presentationml/2006/main" xmlns:r="http://schemas.openxmlformats.org/officeDocument/2006/relationships">
-  <p:cSld>
-    <p:spTree>
-      <p:nvGrpSpPr>
-        <p:cNvPr id="1" name=""/>
-        <p:cNvGrpSpPr/>
-        <p:nvPr/>
-      </p:nvGrpSpPr>
-      <p:grpSpPr/>
-      <p:sp>
-        <p:nvSpPr>
-          <p:cNvPr id="2" name="TextBox 1"/>
-          <p:cNvSpPr txBox="1"/>
-          <p:nvPr/>
-        </p:nvSpPr>
-        <p:spPr>
-          <a:xfrm>
-            <a:off x="548640" y="320040"/>
-            <a:ext cx="10972800" cy="731520"/>
-          </a:xfrm>
-          <a:prstGeom prst="rect">
-            <a:avLst/>
-          </a:prstGeom>
-          <a:noFill/>
-        </p:spPr>
-        <p:txBody>
-          <a:bodyPr wrap="square">
-            <a:spAutoFit/>
-          </a:bodyPr>
-          <a:lstStyle/>
-          <a:p>
-            <a:pPr>
-              <a:spcAft>
-                <a:spcPts val="600"/>
-              </a:spcAft>
-            </a:pPr>
-            <a:r>
-              <a:rPr sz="3400" b="1">
-                <a:solidFill>
-                  <a:srgbClr val="1A1A1A"/>
-                </a:solidFill>
-                <a:latin typeface="Calibri"/>
-              </a:rPr>
-              <a:t>Introduction</a:t>
-            </a:r>
-          </a:p>
-        </p:txBody>
-      </p:sp>
-      <p:cxnSp>
-        <p:nvCxnSpPr>
-          <p:cNvPr id="3" name="Connector 2"/>
-          <p:cNvCxnSpPr/>
-          <p:nvPr/>
-        </p:nvCxnSpPr>
-        <p:spPr>
-          <a:xfrm>
-            <a:off x="548640" y="1051560"/>
-            <a:ext cx="11064240" cy="0"/>
-          </a:xfrm>
-          <a:prstGeom prst="line">
-            <a:avLst/>
-          </a:prstGeom>
-          <a:ln w="25400">
-            <a:solidFill>
-              <a:srgbClr val="1F4FC8"/>
-            </a:solidFill>
-          </a:ln>
-        </p:spPr>
-        <p:style>
-          <a:lnRef idx="2">
-            <a:schemeClr val="accent1"/>
-          </a:lnRef>
-          <a:fillRef idx="0">
-            <a:schemeClr val="accent1"/>
-          </a:fillRef>
-          <a:effectRef idx="1">
-            <a:schemeClr val="accent1"/>
-          </a:effectRef>
-          <a:fontRef idx="minor">
-            <a:schemeClr val="tx1"/>
-          </a:fontRef>
-        </p:style>
-      </p:cxnSp>
-      <p:sp>
-        <p:nvSpPr>
-          <p:cNvPr id="4" name="TextBox 3"/>
-          <p:cNvSpPr txBox="1"/>
-          <p:nvPr/>
-        </p:nvSpPr>
-        <p:spPr>
-          <a:xfrm>
-            <a:off x="548640" y="1371600"/>
-            <a:ext cx="11064240" cy="5029200"/>
-          </a:xfrm>
-          <a:prstGeom prst="rect">
-            <a:avLst/>
-          </a:prstGeom>
-          <a:noFill/>
-        </p:spPr>
-        <p:txBody>
-          <a:bodyPr wrap="square">
-            <a:spAutoFit/>
-          </a:bodyPr>
-          <a:lstStyle/>
-          <a:p>
-            <a:pPr>
-              <a:spcAft>
-                <a:spcPts val="600"/>
-              </a:spcAft>
-            </a:pPr>
-            <a:r>
-              <a:rPr sz="2200" b="0">
-                <a:solidFill>
-                  <a:srgbClr val="1A1A1A"/>
-                </a:solidFill>
-                <a:latin typeface="Calibri"/>
-              </a:rPr>
-              <a:t>•  Long-horizon planning is hard for language-model agents: a single plan often fails midway.</a:t>
-            </a:r>
-          </a:p>
-          <a:p>
-            <a:pPr>
-              <a:spcAft>
-                <a:spcPts val="600"/>
-              </a:spcAft>
-            </a:pPr>
-            <a:r>
-              <a:rPr sz="2200" b="0">
-                <a:solidFill>
-                  <a:srgbClr val="1A1A1A"/>
-                </a:solidFill>
-                <a:latin typeface="Calibri"/>
-              </a:rPr>
-              <a:t>•  TAPE (Jeong et al., 2026) generates several candidate plans, merges them into one plan graph, picks a path with an external solver (ILP), executes it, and replans when reality differs.</a:t>
-            </a:r>
-          </a:p>
-          <a:p>
-            <a:pPr>
-              <a:spcAft>
-                <a:spcPts val="600"/>
-              </a:spcAft>
-            </a:pPr>
-            <a:r>
-              <a:rPr sz="2200" b="0">
-                <a:solidFill>
-                  <a:srgbClr val="1A1A1A"/>
-                </a:solidFill>
-                <a:latin typeface="Calibri"/>
-              </a:rPr>
-              <a:t>•  A plan graph is only as good as the plans behind it, and the solver is fixed in advance.</a:t>
-            </a:r>
-          </a:p>
-          <a:p>
-            <a:pPr>
-              <a:spcAft>
-                <a:spcPts val="600"/>
-              </a:spcAft>
-            </a:pPr>
-            <a:r>
-              <a:rPr sz="2200" b="0">
-                <a:solidFill>
-                  <a:srgbClr val="1A1A1A"/>
-                </a:solidFill>
-                <a:latin typeface="Calibri"/>
-              </a:rPr>
-              <a:t>•  Our project adds a checking and selection layer on top of the TAPE pipeline: validate moves, learn from failures, score moves, and choose the solver per task.</a:t>
-            </a:r>
-          </a:p>
-          <a:p>
-            <a:pPr>
-              <a:spcAft>
-                <a:spcPts val="600"/>
-              </a:spcAft>
-            </a:pPr>
-            <a:r>
-              <a:rPr sz="2200" b="0">
-                <a:solidFill>
-                  <a:srgbClr val="1A1A1A"/>
-                </a:solidFill>
-                <a:latin typeface="Calibri"/>
-              </a:rPr>
-              <a:t>•  Tested on seven games: Sokoban, River Crossing, Rush Hour, Peg Solitaire, the 24-puzzle, the Rubik's cube and 3,000 Boxoban levels.</a:t>
             </a:r>
           </a:p>
         </p:txBody>

</xml_diff>